<commit_message>
doc: cover Multi-PPI++ in decision tree and tutorials index
Co-Authored-By: Claude Opus 4.8 (1M context) <noreply@anthropic.com>
</commit_message>
<xml_diff>
--- a/docs/assets/glide-decision-tree.pptx
+++ b/docs/assets/glide-decision-tree.pptx
@@ -1062,7 +1062,7 @@
           <a:p>
             <a:fld id="{554093C4-DEE1-4C4E-AC4A-8D017280FD94}" type="datetimeFigureOut">
               <a:rPr lang="nl-NL" smtClean="0"/>
-              <a:t>11-06-2026</a:t>
+              <a:t>25-06-2026</a:t>
             </a:fld>
             <a:endParaRPr lang="nl-NL"/>
           </a:p>
@@ -1255,7 +1255,7 @@
           <a:p>
             <a:fld id="{68674519-6056-489F-B3DD-67FB69B5B4F9}" type="datetimeFigureOut">
               <a:rPr lang="en-GB" smtClean="0"/>
-              <a:t>11/06/2026</a:t>
+              <a:t>25/06/2026</a:t>
             </a:fld>
             <a:endParaRPr lang="en-GB"/>
           </a:p>
@@ -2115,10 +2115,10 @@
       </p:grpSpPr>
       <p:sp>
         <p:nvSpPr>
-          <p:cNvPr id="47" name="Rectangle 46">
-            <a:extLst>
-              <a:ext uri="{FF2B5EF4-FFF2-40B4-BE49-F238E27FC236}">
-                <a16:creationId xmlns:a16="http://schemas.microsoft.com/office/drawing/2014/main" id="{F8FD8B8E-9FAE-AE86-0224-467F10F48274}"/>
+          <p:cNvPr id="3" name="Rectangle 2">
+            <a:extLst>
+              <a:ext uri="{FF2B5EF4-FFF2-40B4-BE49-F238E27FC236}">
+                <a16:creationId xmlns:a16="http://schemas.microsoft.com/office/drawing/2014/main" id="{BF28B7B1-E577-E393-BDF4-4A77D458937E}"/>
               </a:ext>
             </a:extLst>
           </p:cNvPr>
@@ -2127,128 +2127,8 @@
         </p:nvSpPr>
         <p:spPr>
           <a:xfrm>
-            <a:off x="5492038" y="13565828"/>
-            <a:ext cx="6238412" cy="154748"/>
-          </a:xfrm>
-          <a:prstGeom prst="rect">
-            <a:avLst/>
-          </a:prstGeom>
-          <a:solidFill>
-            <a:schemeClr val="accent6">
-              <a:lumMod val="50000"/>
-            </a:schemeClr>
-          </a:solidFill>
-          <a:ln>
-            <a:noFill/>
-          </a:ln>
-        </p:spPr>
-        <p:style>
-          <a:lnRef idx="2">
-            <a:schemeClr val="accent1">
-              <a:shade val="50000"/>
-            </a:schemeClr>
-          </a:lnRef>
-          <a:fillRef idx="1">
-            <a:schemeClr val="accent1"/>
-          </a:fillRef>
-          <a:effectRef idx="0">
-            <a:schemeClr val="accent1"/>
-          </a:effectRef>
-          <a:fontRef idx="minor">
-            <a:schemeClr val="lt1"/>
-          </a:fontRef>
-        </p:style>
-        <p:txBody>
-          <a:bodyPr lIns="365760" tIns="72000" rIns="72000" bIns="72000" rtlCol="0" anchor="ctr" anchorCtr="0"/>
-          <a:lstStyle/>
-          <a:p>
-            <a:pPr algn="ctr"/>
-            <a:r>
-              <a:rPr lang="en-US" sz="1400" b="1" dirty="0">
-                <a:solidFill>
-                  <a:schemeClr val="bg1"/>
-                </a:solidFill>
-              </a:rPr>
-              <a:t>Annotation</a:t>
-            </a:r>
-          </a:p>
-        </p:txBody>
-      </p:sp>
-      <p:sp>
-        <p:nvSpPr>
-          <p:cNvPr id="49" name="Rectangle 48">
-            <a:extLst>
-              <a:ext uri="{FF2B5EF4-FFF2-40B4-BE49-F238E27FC236}">
-                <a16:creationId xmlns:a16="http://schemas.microsoft.com/office/drawing/2014/main" id="{842D5FB2-1FB0-6DE4-D76C-B2A97892FCD5}"/>
-              </a:ext>
-            </a:extLst>
-          </p:cNvPr>
-          <p:cNvSpPr/>
-          <p:nvPr/>
-        </p:nvSpPr>
-        <p:spPr>
-          <a:xfrm>
-            <a:off x="5492038" y="13755061"/>
-            <a:ext cx="6238412" cy="154748"/>
-          </a:xfrm>
-          <a:prstGeom prst="rect">
-            <a:avLst/>
-          </a:prstGeom>
-          <a:solidFill>
-            <a:schemeClr val="bg2"/>
-          </a:solidFill>
-          <a:ln>
-            <a:noFill/>
-          </a:ln>
-        </p:spPr>
-        <p:style>
-          <a:lnRef idx="2">
-            <a:schemeClr val="accent1">
-              <a:shade val="50000"/>
-            </a:schemeClr>
-          </a:lnRef>
-          <a:fillRef idx="1">
-            <a:schemeClr val="accent1"/>
-          </a:fillRef>
-          <a:effectRef idx="0">
-            <a:schemeClr val="accent1"/>
-          </a:effectRef>
-          <a:fontRef idx="minor">
-            <a:schemeClr val="lt1"/>
-          </a:fontRef>
-        </p:style>
-        <p:txBody>
-          <a:bodyPr lIns="365760" tIns="72000" rIns="72000" bIns="72000" rtlCol="0" anchor="ctr" anchorCtr="0"/>
-          <a:lstStyle/>
-          <a:p>
-            <a:pPr algn="ctr"/>
-            <a:r>
-              <a:rPr lang="en-US" sz="1400" b="1">
-                <a:solidFill>
-                  <a:schemeClr val="bg1"/>
-                </a:solidFill>
-              </a:rPr>
-              <a:t>Estimation</a:t>
-            </a:r>
-          </a:p>
-        </p:txBody>
-      </p:sp>
-      <p:sp>
-        <p:nvSpPr>
-          <p:cNvPr id="3" name="Rectangle 2">
-            <a:extLst>
-              <a:ext uri="{FF2B5EF4-FFF2-40B4-BE49-F238E27FC236}">
-                <a16:creationId xmlns:a16="http://schemas.microsoft.com/office/drawing/2014/main" id="{BF28B7B1-E577-E393-BDF4-4A77D458937E}"/>
-              </a:ext>
-            </a:extLst>
-          </p:cNvPr>
-          <p:cNvSpPr/>
-          <p:nvPr/>
-        </p:nvSpPr>
-        <p:spPr>
-          <a:xfrm>
-            <a:off x="5492037" y="13944294"/>
-            <a:ext cx="6238410" cy="1601680"/>
+            <a:off x="5492037" y="13944293"/>
+            <a:ext cx="7484067" cy="2888533"/>
           </a:xfrm>
           <a:prstGeom prst="rect">
             <a:avLst/>
@@ -2307,7 +2187,7 @@
         <p:spPr>
           <a:xfrm>
             <a:off x="5492037" y="9586292"/>
-            <a:ext cx="6238410" cy="3945051"/>
+            <a:ext cx="7484067" cy="3945051"/>
           </a:xfrm>
           <a:prstGeom prst="rect">
             <a:avLst/>
@@ -3053,7 +2933,7 @@
         </p:nvSpPr>
         <p:spPr>
           <a:xfrm>
-            <a:off x="10336984" y="14909029"/>
+            <a:off x="11443786" y="16091997"/>
             <a:ext cx="618087" cy="550255"/>
           </a:xfrm>
           <a:prstGeom prst="rect">
@@ -3117,7 +2997,7 @@
         </p:nvSpPr>
         <p:spPr>
           <a:xfrm>
-            <a:off x="11020176" y="14909029"/>
+            <a:off x="12126978" y="16091997"/>
             <a:ext cx="618087" cy="550255"/>
           </a:xfrm>
           <a:prstGeom prst="rect">
@@ -3158,7 +3038,7 @@
           <a:p>
             <a:pPr algn="ctr"/>
             <a:r>
-              <a:rPr lang="en-US" sz="900" b="1">
+              <a:rPr lang="en-US" sz="900" b="1" dirty="0">
                 <a:solidFill>
                   <a:schemeClr val="tx1"/>
                 </a:solidFill>
@@ -3182,7 +3062,7 @@
         </p:nvSpPr>
         <p:spPr>
           <a:xfrm>
-            <a:off x="10443667" y="14054128"/>
+            <a:off x="11550469" y="15237096"/>
             <a:ext cx="1087913" cy="548640"/>
           </a:xfrm>
           <a:prstGeom prst="rect">
@@ -3310,7 +3190,7 @@
         </p:nvSpPr>
         <p:spPr>
           <a:xfrm>
-            <a:off x="7599734" y="14909029"/>
+            <a:off x="7599734" y="16091997"/>
             <a:ext cx="618087" cy="550255"/>
           </a:xfrm>
           <a:prstGeom prst="rect">
@@ -3374,7 +3254,7 @@
         </p:nvSpPr>
         <p:spPr>
           <a:xfrm>
-            <a:off x="8282927" y="14909029"/>
+            <a:off x="8282927" y="16091997"/>
             <a:ext cx="618087" cy="550255"/>
           </a:xfrm>
           <a:prstGeom prst="rect">
@@ -3439,7 +3319,7 @@
         </p:nvSpPr>
         <p:spPr>
           <a:xfrm>
-            <a:off x="7706418" y="14054128"/>
+            <a:off x="7706418" y="15237096"/>
             <a:ext cx="1087913" cy="548640"/>
           </a:xfrm>
           <a:prstGeom prst="rect">
@@ -3712,7 +3592,7 @@
         </p:nvSpPr>
         <p:spPr>
           <a:xfrm>
-            <a:off x="5879867" y="14909029"/>
+            <a:off x="5879867" y="16091997"/>
             <a:ext cx="618087" cy="550255"/>
           </a:xfrm>
           <a:prstGeom prst="rect">
@@ -3776,7 +3656,7 @@
         </p:nvSpPr>
         <p:spPr>
           <a:xfrm>
-            <a:off x="6563061" y="14909029"/>
+            <a:off x="6563061" y="16091997"/>
             <a:ext cx="618087" cy="550255"/>
           </a:xfrm>
           <a:prstGeom prst="rect">
@@ -3841,7 +3721,7 @@
         </p:nvSpPr>
         <p:spPr>
           <a:xfrm>
-            <a:off x="5986550" y="14054128"/>
+            <a:off x="5986550" y="15237096"/>
             <a:ext cx="1087913" cy="548640"/>
           </a:xfrm>
           <a:prstGeom prst="rect">
@@ -3909,7 +3789,7 @@
         </p:nvCxnSpPr>
         <p:spPr>
           <a:xfrm flipH="1">
-            <a:off x="6188911" y="14602768"/>
+            <a:off x="6188911" y="15785736"/>
             <a:ext cx="341596" cy="306261"/>
           </a:xfrm>
           <a:prstGeom prst="straightConnector1">
@@ -3955,7 +3835,7 @@
         </p:nvCxnSpPr>
         <p:spPr>
           <a:xfrm>
-            <a:off x="6530507" y="14602768"/>
+            <a:off x="6530507" y="15785736"/>
             <a:ext cx="341598" cy="306261"/>
           </a:xfrm>
           <a:prstGeom prst="straightConnector1">
@@ -4001,7 +3881,7 @@
         </p:nvCxnSpPr>
         <p:spPr>
           <a:xfrm>
-            <a:off x="10987624" y="14602768"/>
+            <a:off x="12094426" y="15785736"/>
             <a:ext cx="341596" cy="306261"/>
           </a:xfrm>
           <a:prstGeom prst="straightConnector1">
@@ -4047,7 +3927,7 @@
         </p:nvCxnSpPr>
         <p:spPr>
           <a:xfrm flipH="1">
-            <a:off x="10646028" y="14602768"/>
+            <a:off x="11752830" y="15785736"/>
             <a:ext cx="341596" cy="306261"/>
           </a:xfrm>
           <a:prstGeom prst="straightConnector1">
@@ -4093,7 +3973,7 @@
         </p:nvCxnSpPr>
         <p:spPr>
           <a:xfrm>
-            <a:off x="8250375" y="14602768"/>
+            <a:off x="8250375" y="15785736"/>
             <a:ext cx="341596" cy="306261"/>
           </a:xfrm>
           <a:prstGeom prst="straightConnector1">
@@ -4139,7 +4019,7 @@
         </p:nvCxnSpPr>
         <p:spPr>
           <a:xfrm flipH="1">
-            <a:off x="7908778" y="14602768"/>
+            <a:off x="7908778" y="15785736"/>
             <a:ext cx="341597" cy="306261"/>
           </a:xfrm>
           <a:prstGeom prst="straightConnector1">
@@ -4186,7 +4066,7 @@
         <p:spPr>
           <a:xfrm>
             <a:off x="5839642" y="13431482"/>
-            <a:ext cx="690865" cy="622646"/>
+            <a:ext cx="690865" cy="1805614"/>
           </a:xfrm>
           <a:prstGeom prst="straightConnector1">
             <a:avLst/>
@@ -4234,7 +4114,7 @@
         <p:spPr>
           <a:xfrm flipH="1">
             <a:off x="6530507" y="13431482"/>
-            <a:ext cx="987" cy="622646"/>
+            <a:ext cx="987" cy="1805614"/>
           </a:xfrm>
           <a:prstGeom prst="straightConnector1">
             <a:avLst/>
@@ -4282,7 +4162,7 @@
         <p:spPr>
           <a:xfrm flipH="1">
             <a:off x="6530507" y="13431482"/>
-            <a:ext cx="692839" cy="622646"/>
+            <a:ext cx="692839" cy="1805614"/>
           </a:xfrm>
           <a:prstGeom prst="straightConnector1">
             <a:avLst/>
@@ -4330,7 +4210,7 @@
         <p:spPr>
           <a:xfrm flipH="1">
             <a:off x="8250375" y="13431482"/>
-            <a:ext cx="3018" cy="622646"/>
+            <a:ext cx="3018" cy="1805614"/>
           </a:xfrm>
           <a:prstGeom prst="straightConnector1">
             <a:avLst/>
@@ -4371,14 +4251,14 @@
           <p:cNvCxnSpPr>
             <a:cxnSpLocks/>
             <a:stCxn id="17" idx="2"/>
-            <a:endCxn id="20" idx="0"/>
+            <a:endCxn id="60" idx="0"/>
           </p:cNvCxnSpPr>
           <p:nvPr/>
         </p:nvCxnSpPr>
         <p:spPr>
           <a:xfrm>
             <a:off x="10987624" y="13431482"/>
-            <a:ext cx="0" cy="622646"/>
+            <a:ext cx="0" cy="802724"/>
           </a:xfrm>
           <a:prstGeom prst="straightConnector1">
             <a:avLst/>
@@ -4421,7 +4301,7 @@
         </p:nvSpPr>
         <p:spPr>
           <a:xfrm>
-            <a:off x="10954319" y="9670994"/>
+            <a:off x="12203766" y="9670994"/>
             <a:ext cx="613885" cy="332847"/>
           </a:xfrm>
           <a:prstGeom prst="rect">
@@ -4479,7 +4359,7 @@
         </p:nvCxnSpPr>
         <p:spPr>
           <a:xfrm flipV="1">
-            <a:off x="11014964" y="9905578"/>
+            <a:off x="12264411" y="9905578"/>
             <a:ext cx="305176" cy="106"/>
           </a:xfrm>
           <a:prstGeom prst="straightConnector1">
@@ -4523,7 +4403,7 @@
         </p:nvCxnSpPr>
         <p:spPr>
           <a:xfrm flipV="1">
-            <a:off x="11009352" y="9785623"/>
+            <a:off x="12258799" y="9785623"/>
             <a:ext cx="305176" cy="106"/>
           </a:xfrm>
           <a:prstGeom prst="straightConnector1">
@@ -4565,7 +4445,7 @@
         </p:nvSpPr>
         <p:spPr>
           <a:xfrm>
-            <a:off x="11339963" y="9687467"/>
+            <a:off x="12589410" y="9687467"/>
             <a:ext cx="367389" cy="211203"/>
           </a:xfrm>
           <a:prstGeom prst="rect">
@@ -4605,7 +4485,7 @@
         </p:nvSpPr>
         <p:spPr>
           <a:xfrm>
-            <a:off x="11339962" y="9807422"/>
+            <a:off x="12589409" y="9807422"/>
             <a:ext cx="329213" cy="211203"/>
           </a:xfrm>
           <a:prstGeom prst="rect">
@@ -4646,7 +4526,7 @@
         <p:spPr>
           <a:xfrm>
             <a:off x="5492038" y="9397059"/>
-            <a:ext cx="6238412" cy="154748"/>
+            <a:ext cx="7484070" cy="154748"/>
           </a:xfrm>
           <a:prstGeom prst="rect">
             <a:avLst/>
@@ -4832,7 +4712,7 @@
         </p:nvSpPr>
         <p:spPr>
           <a:xfrm>
-            <a:off x="8968359" y="14909029"/>
+            <a:off x="8968359" y="16091997"/>
             <a:ext cx="618087" cy="550255"/>
           </a:xfrm>
           <a:prstGeom prst="rect">
@@ -4896,7 +4776,7 @@
         </p:nvSpPr>
         <p:spPr>
           <a:xfrm>
-            <a:off x="9651551" y="14909029"/>
+            <a:off x="9651551" y="16091997"/>
             <a:ext cx="618087" cy="550255"/>
           </a:xfrm>
           <a:prstGeom prst="rect">
@@ -4961,7 +4841,7 @@
         </p:nvSpPr>
         <p:spPr>
           <a:xfrm>
-            <a:off x="9075042" y="14054128"/>
+            <a:off x="9075042" y="15237096"/>
             <a:ext cx="1087913" cy="548640"/>
           </a:xfrm>
           <a:prstGeom prst="rect">
@@ -5029,7 +4909,7 @@
         </p:nvCxnSpPr>
         <p:spPr>
           <a:xfrm>
-            <a:off x="9618999" y="14602768"/>
+            <a:off x="9618999" y="15785736"/>
             <a:ext cx="341596" cy="306261"/>
           </a:xfrm>
           <a:prstGeom prst="straightConnector1">
@@ -5075,7 +4955,7 @@
         </p:nvCxnSpPr>
         <p:spPr>
           <a:xfrm flipH="1">
-            <a:off x="9277403" y="14602768"/>
+            <a:off x="9277403" y="15785736"/>
             <a:ext cx="341596" cy="306261"/>
           </a:xfrm>
           <a:prstGeom prst="straightConnector1">
@@ -5122,7 +5002,7 @@
         <p:spPr>
           <a:xfrm>
             <a:off x="9618999" y="13431482"/>
-            <a:ext cx="0" cy="622646"/>
+            <a:ext cx="0" cy="1805614"/>
           </a:xfrm>
           <a:prstGeom prst="straightConnector1">
             <a:avLst/>
@@ -5243,6 +5123,347 @@
           </a:fontRef>
         </p:style>
       </p:cxnSp>
+      <p:sp>
+        <p:nvSpPr>
+          <p:cNvPr id="50" name="Rectangle 49">
+            <a:extLst>
+              <a:ext uri="{FF2B5EF4-FFF2-40B4-BE49-F238E27FC236}">
+                <a16:creationId xmlns:a16="http://schemas.microsoft.com/office/drawing/2014/main" id="{7DD94F55-CC54-1638-8B4D-6D05B04412AF}"/>
+              </a:ext>
+            </a:extLst>
+          </p:cNvPr>
+          <p:cNvSpPr/>
+          <p:nvPr/>
+        </p:nvSpPr>
+        <p:spPr>
+          <a:xfrm>
+            <a:off x="10678580" y="16091997"/>
+            <a:ext cx="618087" cy="550255"/>
+          </a:xfrm>
+          <a:prstGeom prst="rect">
+            <a:avLst/>
+          </a:prstGeom>
+          <a:solidFill>
+            <a:schemeClr val="accent3">
+              <a:lumMod val="20000"/>
+              <a:lumOff val="80000"/>
+            </a:schemeClr>
+          </a:solidFill>
+          <a:ln>
+            <a:solidFill>
+              <a:schemeClr val="tx1"/>
+            </a:solidFill>
+            <a:prstDash val="solid"/>
+          </a:ln>
+        </p:spPr>
+        <p:style>
+          <a:lnRef idx="2">
+            <a:schemeClr val="accent1">
+              <a:shade val="50000"/>
+            </a:schemeClr>
+          </a:lnRef>
+          <a:fillRef idx="1">
+            <a:schemeClr val="accent1"/>
+          </a:fillRef>
+          <a:effectRef idx="0">
+            <a:schemeClr val="accent1"/>
+          </a:effectRef>
+          <a:fontRef idx="minor">
+            <a:schemeClr val="lt1"/>
+          </a:fontRef>
+        </p:style>
+        <p:txBody>
+          <a:bodyPr lIns="72000" tIns="72000" rIns="72000" bIns="72000" rtlCol="0" anchor="ctr" anchorCtr="0"/>
+          <a:lstStyle/>
+          <a:p>
+            <a:pPr algn="ctr"/>
+            <a:r>
+              <a:rPr lang="en-US" sz="900" b="1" dirty="0">
+                <a:solidFill>
+                  <a:schemeClr val="tx1"/>
+                </a:solidFill>
+              </a:rPr>
+              <a:t>Multi-PPI++</a:t>
+            </a:r>
+          </a:p>
+        </p:txBody>
+      </p:sp>
+      <p:sp>
+        <p:nvSpPr>
+          <p:cNvPr id="60" name="Rectangle 59">
+            <a:extLst>
+              <a:ext uri="{FF2B5EF4-FFF2-40B4-BE49-F238E27FC236}">
+                <a16:creationId xmlns:a16="http://schemas.microsoft.com/office/drawing/2014/main" id="{8140010D-3E5C-ADE1-B301-73133EE59575}"/>
+              </a:ext>
+            </a:extLst>
+          </p:cNvPr>
+          <p:cNvSpPr/>
+          <p:nvPr/>
+        </p:nvSpPr>
+        <p:spPr>
+          <a:xfrm>
+            <a:off x="10443667" y="14234206"/>
+            <a:ext cx="1087913" cy="548640"/>
+          </a:xfrm>
+          <a:prstGeom prst="rect">
+            <a:avLst/>
+          </a:prstGeom>
+          <a:solidFill>
+            <a:schemeClr val="accent2">
+              <a:lumMod val="20000"/>
+              <a:lumOff val="80000"/>
+            </a:schemeClr>
+          </a:solidFill>
+          <a:ln>
+            <a:solidFill>
+              <a:schemeClr val="tx1"/>
+            </a:solidFill>
+          </a:ln>
+        </p:spPr>
+        <p:style>
+          <a:lnRef idx="2">
+            <a:schemeClr val="accent1">
+              <a:shade val="50000"/>
+            </a:schemeClr>
+          </a:lnRef>
+          <a:fillRef idx="1">
+            <a:schemeClr val="accent1"/>
+          </a:fillRef>
+          <a:effectRef idx="0">
+            <a:schemeClr val="accent1"/>
+          </a:effectRef>
+          <a:fontRef idx="minor">
+            <a:schemeClr val="lt1"/>
+          </a:fontRef>
+        </p:style>
+        <p:txBody>
+          <a:bodyPr lIns="72000" tIns="72000" rIns="72000" bIns="72000" rtlCol="0" anchor="ctr" anchorCtr="0"/>
+          <a:lstStyle/>
+          <a:p>
+            <a:pPr algn="ctr"/>
+            <a:r>
+              <a:rPr lang="en-US" sz="900" b="1" dirty="0">
+                <a:solidFill>
+                  <a:schemeClr val="tx1"/>
+                </a:solidFill>
+              </a:rPr>
+              <a:t>Do I have several proxies?</a:t>
+            </a:r>
+          </a:p>
+        </p:txBody>
+      </p:sp>
+      <p:cxnSp>
+        <p:nvCxnSpPr>
+          <p:cNvPr id="62" name="Straight Arrow Connector 61">
+            <a:extLst>
+              <a:ext uri="{FF2B5EF4-FFF2-40B4-BE49-F238E27FC236}">
+                <a16:creationId xmlns:a16="http://schemas.microsoft.com/office/drawing/2014/main" id="{D7A857F5-C9E0-C09C-54D9-5541011C98CE}"/>
+              </a:ext>
+            </a:extLst>
+          </p:cNvPr>
+          <p:cNvCxnSpPr>
+            <a:cxnSpLocks/>
+            <a:stCxn id="60" idx="2"/>
+            <a:endCxn id="50" idx="0"/>
+          </p:cNvCxnSpPr>
+          <p:nvPr/>
+        </p:nvCxnSpPr>
+        <p:spPr>
+          <a:xfrm>
+            <a:off x="10987624" y="14782846"/>
+            <a:ext cx="0" cy="1309151"/>
+          </a:xfrm>
+          <a:prstGeom prst="straightConnector1">
+            <a:avLst/>
+          </a:prstGeom>
+          <a:ln w="9525">
+            <a:solidFill>
+              <a:schemeClr val="accent3"/>
+            </a:solidFill>
+            <a:tailEnd type="triangle"/>
+          </a:ln>
+        </p:spPr>
+        <p:style>
+          <a:lnRef idx="1">
+            <a:schemeClr val="accent1"/>
+          </a:lnRef>
+          <a:fillRef idx="0">
+            <a:schemeClr val="accent1"/>
+          </a:fillRef>
+          <a:effectRef idx="0">
+            <a:schemeClr val="accent1"/>
+          </a:effectRef>
+          <a:fontRef idx="minor">
+            <a:schemeClr val="tx1"/>
+          </a:fontRef>
+        </p:style>
+      </p:cxnSp>
+      <p:cxnSp>
+        <p:nvCxnSpPr>
+          <p:cNvPr id="137" name="Straight Arrow Connector 136">
+            <a:extLst>
+              <a:ext uri="{FF2B5EF4-FFF2-40B4-BE49-F238E27FC236}">
+                <a16:creationId xmlns:a16="http://schemas.microsoft.com/office/drawing/2014/main" id="{E6ECE97A-DC17-793C-6CD3-64A9A72FE63F}"/>
+              </a:ext>
+            </a:extLst>
+          </p:cNvPr>
+          <p:cNvCxnSpPr>
+            <a:cxnSpLocks/>
+            <a:stCxn id="60" idx="2"/>
+            <a:endCxn id="20" idx="0"/>
+          </p:cNvCxnSpPr>
+          <p:nvPr/>
+        </p:nvCxnSpPr>
+        <p:spPr>
+          <a:xfrm>
+            <a:off x="10987624" y="14782846"/>
+            <a:ext cx="1106802" cy="454250"/>
+          </a:xfrm>
+          <a:prstGeom prst="straightConnector1">
+            <a:avLst/>
+          </a:prstGeom>
+          <a:ln w="9525">
+            <a:solidFill>
+              <a:schemeClr val="tx2"/>
+            </a:solidFill>
+            <a:tailEnd type="triangle"/>
+          </a:ln>
+        </p:spPr>
+        <p:style>
+          <a:lnRef idx="1">
+            <a:schemeClr val="accent1"/>
+          </a:lnRef>
+          <a:fillRef idx="0">
+            <a:schemeClr val="accent1"/>
+          </a:fillRef>
+          <a:effectRef idx="0">
+            <a:schemeClr val="accent1"/>
+          </a:effectRef>
+          <a:fontRef idx="minor">
+            <a:schemeClr val="tx1"/>
+          </a:fontRef>
+        </p:style>
+      </p:cxnSp>
+      <p:sp>
+        <p:nvSpPr>
+          <p:cNvPr id="47" name="Rectangle 46">
+            <a:extLst>
+              <a:ext uri="{FF2B5EF4-FFF2-40B4-BE49-F238E27FC236}">
+                <a16:creationId xmlns:a16="http://schemas.microsoft.com/office/drawing/2014/main" id="{F8FD8B8E-9FAE-AE86-0224-467F10F48274}"/>
+              </a:ext>
+            </a:extLst>
+          </p:cNvPr>
+          <p:cNvSpPr/>
+          <p:nvPr/>
+        </p:nvSpPr>
+        <p:spPr>
+          <a:xfrm>
+            <a:off x="5492038" y="13565828"/>
+            <a:ext cx="7484070" cy="154748"/>
+          </a:xfrm>
+          <a:prstGeom prst="rect">
+            <a:avLst/>
+          </a:prstGeom>
+          <a:solidFill>
+            <a:schemeClr val="accent6">
+              <a:lumMod val="50000"/>
+            </a:schemeClr>
+          </a:solidFill>
+          <a:ln>
+            <a:noFill/>
+          </a:ln>
+        </p:spPr>
+        <p:style>
+          <a:lnRef idx="2">
+            <a:schemeClr val="accent1">
+              <a:shade val="50000"/>
+            </a:schemeClr>
+          </a:lnRef>
+          <a:fillRef idx="1">
+            <a:schemeClr val="accent1"/>
+          </a:fillRef>
+          <a:effectRef idx="0">
+            <a:schemeClr val="accent1"/>
+          </a:effectRef>
+          <a:fontRef idx="minor">
+            <a:schemeClr val="lt1"/>
+          </a:fontRef>
+        </p:style>
+        <p:txBody>
+          <a:bodyPr lIns="0" tIns="72000" rIns="0" bIns="72000" rtlCol="0" anchor="ctr" anchorCtr="0"/>
+          <a:lstStyle/>
+          <a:p>
+            <a:pPr algn="ctr"/>
+            <a:r>
+              <a:rPr lang="en-US" sz="1400" b="1" dirty="0">
+                <a:solidFill>
+                  <a:schemeClr val="bg1"/>
+                </a:solidFill>
+              </a:rPr>
+              <a:t>Annotation</a:t>
+            </a:r>
+          </a:p>
+        </p:txBody>
+      </p:sp>
+      <p:sp>
+        <p:nvSpPr>
+          <p:cNvPr id="49" name="Rectangle 48">
+            <a:extLst>
+              <a:ext uri="{FF2B5EF4-FFF2-40B4-BE49-F238E27FC236}">
+                <a16:creationId xmlns:a16="http://schemas.microsoft.com/office/drawing/2014/main" id="{842D5FB2-1FB0-6DE4-D76C-B2A97892FCD5}"/>
+              </a:ext>
+            </a:extLst>
+          </p:cNvPr>
+          <p:cNvSpPr/>
+          <p:nvPr/>
+        </p:nvSpPr>
+        <p:spPr>
+          <a:xfrm>
+            <a:off x="5492038" y="13755061"/>
+            <a:ext cx="7484070" cy="154748"/>
+          </a:xfrm>
+          <a:prstGeom prst="rect">
+            <a:avLst/>
+          </a:prstGeom>
+          <a:solidFill>
+            <a:schemeClr val="bg2"/>
+          </a:solidFill>
+          <a:ln>
+            <a:noFill/>
+          </a:ln>
+        </p:spPr>
+        <p:style>
+          <a:lnRef idx="2">
+            <a:schemeClr val="accent1">
+              <a:shade val="50000"/>
+            </a:schemeClr>
+          </a:lnRef>
+          <a:fillRef idx="1">
+            <a:schemeClr val="accent1"/>
+          </a:fillRef>
+          <a:effectRef idx="0">
+            <a:schemeClr val="accent1"/>
+          </a:effectRef>
+          <a:fontRef idx="minor">
+            <a:schemeClr val="lt1"/>
+          </a:fontRef>
+        </p:style>
+        <p:txBody>
+          <a:bodyPr lIns="0" tIns="72000" rIns="0" bIns="72000" rtlCol="0" anchor="ctr" anchorCtr="0"/>
+          <a:lstStyle/>
+          <a:p>
+            <a:pPr algn="ctr"/>
+            <a:r>
+              <a:rPr lang="en-US" sz="1400" b="1">
+                <a:solidFill>
+                  <a:schemeClr val="bg1"/>
+                </a:solidFill>
+              </a:rPr>
+              <a:t>Estimation</a:t>
+            </a:r>
+          </a:p>
+        </p:txBody>
+      </p:sp>
     </p:spTree>
     <p:extLst>
       <p:ext uri="{BB962C8B-B14F-4D97-AF65-F5344CB8AC3E}">

</xml_diff>

<commit_message>
doc: cover Multi-PPI++ in decision tree and tutorials index (#304)
Co-authored-by: Claude Opus 4.8 (1M context) <noreply@anthropic.com>
</commit_message>
<xml_diff>
--- a/docs/assets/glide-decision-tree.pptx
+++ b/docs/assets/glide-decision-tree.pptx
@@ -1062,7 +1062,7 @@
           <a:p>
             <a:fld id="{554093C4-DEE1-4C4E-AC4A-8D017280FD94}" type="datetimeFigureOut">
               <a:rPr lang="nl-NL" smtClean="0"/>
-              <a:t>11-06-2026</a:t>
+              <a:t>25-06-2026</a:t>
             </a:fld>
             <a:endParaRPr lang="nl-NL"/>
           </a:p>
@@ -1255,7 +1255,7 @@
           <a:p>
             <a:fld id="{68674519-6056-489F-B3DD-67FB69B5B4F9}" type="datetimeFigureOut">
               <a:rPr lang="en-GB" smtClean="0"/>
-              <a:t>11/06/2026</a:t>
+              <a:t>25/06/2026</a:t>
             </a:fld>
             <a:endParaRPr lang="en-GB"/>
           </a:p>
@@ -2115,10 +2115,10 @@
       </p:grpSpPr>
       <p:sp>
         <p:nvSpPr>
-          <p:cNvPr id="47" name="Rectangle 46">
-            <a:extLst>
-              <a:ext uri="{FF2B5EF4-FFF2-40B4-BE49-F238E27FC236}">
-                <a16:creationId xmlns:a16="http://schemas.microsoft.com/office/drawing/2014/main" id="{F8FD8B8E-9FAE-AE86-0224-467F10F48274}"/>
+          <p:cNvPr id="3" name="Rectangle 2">
+            <a:extLst>
+              <a:ext uri="{FF2B5EF4-FFF2-40B4-BE49-F238E27FC236}">
+                <a16:creationId xmlns:a16="http://schemas.microsoft.com/office/drawing/2014/main" id="{BF28B7B1-E577-E393-BDF4-4A77D458937E}"/>
               </a:ext>
             </a:extLst>
           </p:cNvPr>
@@ -2127,128 +2127,8 @@
         </p:nvSpPr>
         <p:spPr>
           <a:xfrm>
-            <a:off x="5492038" y="13565828"/>
-            <a:ext cx="6238412" cy="154748"/>
-          </a:xfrm>
-          <a:prstGeom prst="rect">
-            <a:avLst/>
-          </a:prstGeom>
-          <a:solidFill>
-            <a:schemeClr val="accent6">
-              <a:lumMod val="50000"/>
-            </a:schemeClr>
-          </a:solidFill>
-          <a:ln>
-            <a:noFill/>
-          </a:ln>
-        </p:spPr>
-        <p:style>
-          <a:lnRef idx="2">
-            <a:schemeClr val="accent1">
-              <a:shade val="50000"/>
-            </a:schemeClr>
-          </a:lnRef>
-          <a:fillRef idx="1">
-            <a:schemeClr val="accent1"/>
-          </a:fillRef>
-          <a:effectRef idx="0">
-            <a:schemeClr val="accent1"/>
-          </a:effectRef>
-          <a:fontRef idx="minor">
-            <a:schemeClr val="lt1"/>
-          </a:fontRef>
-        </p:style>
-        <p:txBody>
-          <a:bodyPr lIns="365760" tIns="72000" rIns="72000" bIns="72000" rtlCol="0" anchor="ctr" anchorCtr="0"/>
-          <a:lstStyle/>
-          <a:p>
-            <a:pPr algn="ctr"/>
-            <a:r>
-              <a:rPr lang="en-US" sz="1400" b="1" dirty="0">
-                <a:solidFill>
-                  <a:schemeClr val="bg1"/>
-                </a:solidFill>
-              </a:rPr>
-              <a:t>Annotation</a:t>
-            </a:r>
-          </a:p>
-        </p:txBody>
-      </p:sp>
-      <p:sp>
-        <p:nvSpPr>
-          <p:cNvPr id="49" name="Rectangle 48">
-            <a:extLst>
-              <a:ext uri="{FF2B5EF4-FFF2-40B4-BE49-F238E27FC236}">
-                <a16:creationId xmlns:a16="http://schemas.microsoft.com/office/drawing/2014/main" id="{842D5FB2-1FB0-6DE4-D76C-B2A97892FCD5}"/>
-              </a:ext>
-            </a:extLst>
-          </p:cNvPr>
-          <p:cNvSpPr/>
-          <p:nvPr/>
-        </p:nvSpPr>
-        <p:spPr>
-          <a:xfrm>
-            <a:off x="5492038" y="13755061"/>
-            <a:ext cx="6238412" cy="154748"/>
-          </a:xfrm>
-          <a:prstGeom prst="rect">
-            <a:avLst/>
-          </a:prstGeom>
-          <a:solidFill>
-            <a:schemeClr val="bg2"/>
-          </a:solidFill>
-          <a:ln>
-            <a:noFill/>
-          </a:ln>
-        </p:spPr>
-        <p:style>
-          <a:lnRef idx="2">
-            <a:schemeClr val="accent1">
-              <a:shade val="50000"/>
-            </a:schemeClr>
-          </a:lnRef>
-          <a:fillRef idx="1">
-            <a:schemeClr val="accent1"/>
-          </a:fillRef>
-          <a:effectRef idx="0">
-            <a:schemeClr val="accent1"/>
-          </a:effectRef>
-          <a:fontRef idx="minor">
-            <a:schemeClr val="lt1"/>
-          </a:fontRef>
-        </p:style>
-        <p:txBody>
-          <a:bodyPr lIns="365760" tIns="72000" rIns="72000" bIns="72000" rtlCol="0" anchor="ctr" anchorCtr="0"/>
-          <a:lstStyle/>
-          <a:p>
-            <a:pPr algn="ctr"/>
-            <a:r>
-              <a:rPr lang="en-US" sz="1400" b="1">
-                <a:solidFill>
-                  <a:schemeClr val="bg1"/>
-                </a:solidFill>
-              </a:rPr>
-              <a:t>Estimation</a:t>
-            </a:r>
-          </a:p>
-        </p:txBody>
-      </p:sp>
-      <p:sp>
-        <p:nvSpPr>
-          <p:cNvPr id="3" name="Rectangle 2">
-            <a:extLst>
-              <a:ext uri="{FF2B5EF4-FFF2-40B4-BE49-F238E27FC236}">
-                <a16:creationId xmlns:a16="http://schemas.microsoft.com/office/drawing/2014/main" id="{BF28B7B1-E577-E393-BDF4-4A77D458937E}"/>
-              </a:ext>
-            </a:extLst>
-          </p:cNvPr>
-          <p:cNvSpPr/>
-          <p:nvPr/>
-        </p:nvSpPr>
-        <p:spPr>
-          <a:xfrm>
-            <a:off x="5492037" y="13944294"/>
-            <a:ext cx="6238410" cy="1601680"/>
+            <a:off x="5492037" y="13944293"/>
+            <a:ext cx="7484067" cy="2888533"/>
           </a:xfrm>
           <a:prstGeom prst="rect">
             <a:avLst/>
@@ -2307,7 +2187,7 @@
         <p:spPr>
           <a:xfrm>
             <a:off x="5492037" y="9586292"/>
-            <a:ext cx="6238410" cy="3945051"/>
+            <a:ext cx="7484067" cy="3945051"/>
           </a:xfrm>
           <a:prstGeom prst="rect">
             <a:avLst/>
@@ -3053,7 +2933,7 @@
         </p:nvSpPr>
         <p:spPr>
           <a:xfrm>
-            <a:off x="10336984" y="14909029"/>
+            <a:off x="11443786" y="16091997"/>
             <a:ext cx="618087" cy="550255"/>
           </a:xfrm>
           <a:prstGeom prst="rect">
@@ -3117,7 +2997,7 @@
         </p:nvSpPr>
         <p:spPr>
           <a:xfrm>
-            <a:off x="11020176" y="14909029"/>
+            <a:off x="12126978" y="16091997"/>
             <a:ext cx="618087" cy="550255"/>
           </a:xfrm>
           <a:prstGeom prst="rect">
@@ -3158,7 +3038,7 @@
           <a:p>
             <a:pPr algn="ctr"/>
             <a:r>
-              <a:rPr lang="en-US" sz="900" b="1">
+              <a:rPr lang="en-US" sz="900" b="1" dirty="0">
                 <a:solidFill>
                   <a:schemeClr val="tx1"/>
                 </a:solidFill>
@@ -3182,7 +3062,7 @@
         </p:nvSpPr>
         <p:spPr>
           <a:xfrm>
-            <a:off x="10443667" y="14054128"/>
+            <a:off x="11550469" y="15237096"/>
             <a:ext cx="1087913" cy="548640"/>
           </a:xfrm>
           <a:prstGeom prst="rect">
@@ -3310,7 +3190,7 @@
         </p:nvSpPr>
         <p:spPr>
           <a:xfrm>
-            <a:off x="7599734" y="14909029"/>
+            <a:off x="7599734" y="16091997"/>
             <a:ext cx="618087" cy="550255"/>
           </a:xfrm>
           <a:prstGeom prst="rect">
@@ -3374,7 +3254,7 @@
         </p:nvSpPr>
         <p:spPr>
           <a:xfrm>
-            <a:off x="8282927" y="14909029"/>
+            <a:off x="8282927" y="16091997"/>
             <a:ext cx="618087" cy="550255"/>
           </a:xfrm>
           <a:prstGeom prst="rect">
@@ -3439,7 +3319,7 @@
         </p:nvSpPr>
         <p:spPr>
           <a:xfrm>
-            <a:off x="7706418" y="14054128"/>
+            <a:off x="7706418" y="15237096"/>
             <a:ext cx="1087913" cy="548640"/>
           </a:xfrm>
           <a:prstGeom prst="rect">
@@ -3712,7 +3592,7 @@
         </p:nvSpPr>
         <p:spPr>
           <a:xfrm>
-            <a:off x="5879867" y="14909029"/>
+            <a:off x="5879867" y="16091997"/>
             <a:ext cx="618087" cy="550255"/>
           </a:xfrm>
           <a:prstGeom prst="rect">
@@ -3776,7 +3656,7 @@
         </p:nvSpPr>
         <p:spPr>
           <a:xfrm>
-            <a:off x="6563061" y="14909029"/>
+            <a:off x="6563061" y="16091997"/>
             <a:ext cx="618087" cy="550255"/>
           </a:xfrm>
           <a:prstGeom prst="rect">
@@ -3841,7 +3721,7 @@
         </p:nvSpPr>
         <p:spPr>
           <a:xfrm>
-            <a:off x="5986550" y="14054128"/>
+            <a:off x="5986550" y="15237096"/>
             <a:ext cx="1087913" cy="548640"/>
           </a:xfrm>
           <a:prstGeom prst="rect">
@@ -3909,7 +3789,7 @@
         </p:nvCxnSpPr>
         <p:spPr>
           <a:xfrm flipH="1">
-            <a:off x="6188911" y="14602768"/>
+            <a:off x="6188911" y="15785736"/>
             <a:ext cx="341596" cy="306261"/>
           </a:xfrm>
           <a:prstGeom prst="straightConnector1">
@@ -3955,7 +3835,7 @@
         </p:nvCxnSpPr>
         <p:spPr>
           <a:xfrm>
-            <a:off x="6530507" y="14602768"/>
+            <a:off x="6530507" y="15785736"/>
             <a:ext cx="341598" cy="306261"/>
           </a:xfrm>
           <a:prstGeom prst="straightConnector1">
@@ -4001,7 +3881,7 @@
         </p:nvCxnSpPr>
         <p:spPr>
           <a:xfrm>
-            <a:off x="10987624" y="14602768"/>
+            <a:off x="12094426" y="15785736"/>
             <a:ext cx="341596" cy="306261"/>
           </a:xfrm>
           <a:prstGeom prst="straightConnector1">
@@ -4047,7 +3927,7 @@
         </p:nvCxnSpPr>
         <p:spPr>
           <a:xfrm flipH="1">
-            <a:off x="10646028" y="14602768"/>
+            <a:off x="11752830" y="15785736"/>
             <a:ext cx="341596" cy="306261"/>
           </a:xfrm>
           <a:prstGeom prst="straightConnector1">
@@ -4093,7 +3973,7 @@
         </p:nvCxnSpPr>
         <p:spPr>
           <a:xfrm>
-            <a:off x="8250375" y="14602768"/>
+            <a:off x="8250375" y="15785736"/>
             <a:ext cx="341596" cy="306261"/>
           </a:xfrm>
           <a:prstGeom prst="straightConnector1">
@@ -4139,7 +4019,7 @@
         </p:nvCxnSpPr>
         <p:spPr>
           <a:xfrm flipH="1">
-            <a:off x="7908778" y="14602768"/>
+            <a:off x="7908778" y="15785736"/>
             <a:ext cx="341597" cy="306261"/>
           </a:xfrm>
           <a:prstGeom prst="straightConnector1">
@@ -4186,7 +4066,7 @@
         <p:spPr>
           <a:xfrm>
             <a:off x="5839642" y="13431482"/>
-            <a:ext cx="690865" cy="622646"/>
+            <a:ext cx="690865" cy="1805614"/>
           </a:xfrm>
           <a:prstGeom prst="straightConnector1">
             <a:avLst/>
@@ -4234,7 +4114,7 @@
         <p:spPr>
           <a:xfrm flipH="1">
             <a:off x="6530507" y="13431482"/>
-            <a:ext cx="987" cy="622646"/>
+            <a:ext cx="987" cy="1805614"/>
           </a:xfrm>
           <a:prstGeom prst="straightConnector1">
             <a:avLst/>
@@ -4282,7 +4162,7 @@
         <p:spPr>
           <a:xfrm flipH="1">
             <a:off x="6530507" y="13431482"/>
-            <a:ext cx="692839" cy="622646"/>
+            <a:ext cx="692839" cy="1805614"/>
           </a:xfrm>
           <a:prstGeom prst="straightConnector1">
             <a:avLst/>
@@ -4330,7 +4210,7 @@
         <p:spPr>
           <a:xfrm flipH="1">
             <a:off x="8250375" y="13431482"/>
-            <a:ext cx="3018" cy="622646"/>
+            <a:ext cx="3018" cy="1805614"/>
           </a:xfrm>
           <a:prstGeom prst="straightConnector1">
             <a:avLst/>
@@ -4371,14 +4251,14 @@
           <p:cNvCxnSpPr>
             <a:cxnSpLocks/>
             <a:stCxn id="17" idx="2"/>
-            <a:endCxn id="20" idx="0"/>
+            <a:endCxn id="60" idx="0"/>
           </p:cNvCxnSpPr>
           <p:nvPr/>
         </p:nvCxnSpPr>
         <p:spPr>
           <a:xfrm>
             <a:off x="10987624" y="13431482"/>
-            <a:ext cx="0" cy="622646"/>
+            <a:ext cx="0" cy="802724"/>
           </a:xfrm>
           <a:prstGeom prst="straightConnector1">
             <a:avLst/>
@@ -4421,7 +4301,7 @@
         </p:nvSpPr>
         <p:spPr>
           <a:xfrm>
-            <a:off x="10954319" y="9670994"/>
+            <a:off x="12203766" y="9670994"/>
             <a:ext cx="613885" cy="332847"/>
           </a:xfrm>
           <a:prstGeom prst="rect">
@@ -4479,7 +4359,7 @@
         </p:nvCxnSpPr>
         <p:spPr>
           <a:xfrm flipV="1">
-            <a:off x="11014964" y="9905578"/>
+            <a:off x="12264411" y="9905578"/>
             <a:ext cx="305176" cy="106"/>
           </a:xfrm>
           <a:prstGeom prst="straightConnector1">
@@ -4523,7 +4403,7 @@
         </p:nvCxnSpPr>
         <p:spPr>
           <a:xfrm flipV="1">
-            <a:off x="11009352" y="9785623"/>
+            <a:off x="12258799" y="9785623"/>
             <a:ext cx="305176" cy="106"/>
           </a:xfrm>
           <a:prstGeom prst="straightConnector1">
@@ -4565,7 +4445,7 @@
         </p:nvSpPr>
         <p:spPr>
           <a:xfrm>
-            <a:off x="11339963" y="9687467"/>
+            <a:off x="12589410" y="9687467"/>
             <a:ext cx="367389" cy="211203"/>
           </a:xfrm>
           <a:prstGeom prst="rect">
@@ -4605,7 +4485,7 @@
         </p:nvSpPr>
         <p:spPr>
           <a:xfrm>
-            <a:off x="11339962" y="9807422"/>
+            <a:off x="12589409" y="9807422"/>
             <a:ext cx="329213" cy="211203"/>
           </a:xfrm>
           <a:prstGeom prst="rect">
@@ -4646,7 +4526,7 @@
         <p:spPr>
           <a:xfrm>
             <a:off x="5492038" y="9397059"/>
-            <a:ext cx="6238412" cy="154748"/>
+            <a:ext cx="7484070" cy="154748"/>
           </a:xfrm>
           <a:prstGeom prst="rect">
             <a:avLst/>
@@ -4832,7 +4712,7 @@
         </p:nvSpPr>
         <p:spPr>
           <a:xfrm>
-            <a:off x="8968359" y="14909029"/>
+            <a:off x="8968359" y="16091997"/>
             <a:ext cx="618087" cy="550255"/>
           </a:xfrm>
           <a:prstGeom prst="rect">
@@ -4896,7 +4776,7 @@
         </p:nvSpPr>
         <p:spPr>
           <a:xfrm>
-            <a:off x="9651551" y="14909029"/>
+            <a:off x="9651551" y="16091997"/>
             <a:ext cx="618087" cy="550255"/>
           </a:xfrm>
           <a:prstGeom prst="rect">
@@ -4961,7 +4841,7 @@
         </p:nvSpPr>
         <p:spPr>
           <a:xfrm>
-            <a:off x="9075042" y="14054128"/>
+            <a:off x="9075042" y="15237096"/>
             <a:ext cx="1087913" cy="548640"/>
           </a:xfrm>
           <a:prstGeom prst="rect">
@@ -5029,7 +4909,7 @@
         </p:nvCxnSpPr>
         <p:spPr>
           <a:xfrm>
-            <a:off x="9618999" y="14602768"/>
+            <a:off x="9618999" y="15785736"/>
             <a:ext cx="341596" cy="306261"/>
           </a:xfrm>
           <a:prstGeom prst="straightConnector1">
@@ -5075,7 +4955,7 @@
         </p:nvCxnSpPr>
         <p:spPr>
           <a:xfrm flipH="1">
-            <a:off x="9277403" y="14602768"/>
+            <a:off x="9277403" y="15785736"/>
             <a:ext cx="341596" cy="306261"/>
           </a:xfrm>
           <a:prstGeom prst="straightConnector1">
@@ -5122,7 +5002,7 @@
         <p:spPr>
           <a:xfrm>
             <a:off x="9618999" y="13431482"/>
-            <a:ext cx="0" cy="622646"/>
+            <a:ext cx="0" cy="1805614"/>
           </a:xfrm>
           <a:prstGeom prst="straightConnector1">
             <a:avLst/>
@@ -5243,6 +5123,347 @@
           </a:fontRef>
         </p:style>
       </p:cxnSp>
+      <p:sp>
+        <p:nvSpPr>
+          <p:cNvPr id="50" name="Rectangle 49">
+            <a:extLst>
+              <a:ext uri="{FF2B5EF4-FFF2-40B4-BE49-F238E27FC236}">
+                <a16:creationId xmlns:a16="http://schemas.microsoft.com/office/drawing/2014/main" id="{7DD94F55-CC54-1638-8B4D-6D05B04412AF}"/>
+              </a:ext>
+            </a:extLst>
+          </p:cNvPr>
+          <p:cNvSpPr/>
+          <p:nvPr/>
+        </p:nvSpPr>
+        <p:spPr>
+          <a:xfrm>
+            <a:off x="10678580" y="16091997"/>
+            <a:ext cx="618087" cy="550255"/>
+          </a:xfrm>
+          <a:prstGeom prst="rect">
+            <a:avLst/>
+          </a:prstGeom>
+          <a:solidFill>
+            <a:schemeClr val="accent3">
+              <a:lumMod val="20000"/>
+              <a:lumOff val="80000"/>
+            </a:schemeClr>
+          </a:solidFill>
+          <a:ln>
+            <a:solidFill>
+              <a:schemeClr val="tx1"/>
+            </a:solidFill>
+            <a:prstDash val="solid"/>
+          </a:ln>
+        </p:spPr>
+        <p:style>
+          <a:lnRef idx="2">
+            <a:schemeClr val="accent1">
+              <a:shade val="50000"/>
+            </a:schemeClr>
+          </a:lnRef>
+          <a:fillRef idx="1">
+            <a:schemeClr val="accent1"/>
+          </a:fillRef>
+          <a:effectRef idx="0">
+            <a:schemeClr val="accent1"/>
+          </a:effectRef>
+          <a:fontRef idx="minor">
+            <a:schemeClr val="lt1"/>
+          </a:fontRef>
+        </p:style>
+        <p:txBody>
+          <a:bodyPr lIns="72000" tIns="72000" rIns="72000" bIns="72000" rtlCol="0" anchor="ctr" anchorCtr="0"/>
+          <a:lstStyle/>
+          <a:p>
+            <a:pPr algn="ctr"/>
+            <a:r>
+              <a:rPr lang="en-US" sz="900" b="1" dirty="0">
+                <a:solidFill>
+                  <a:schemeClr val="tx1"/>
+                </a:solidFill>
+              </a:rPr>
+              <a:t>Multi-PPI++</a:t>
+            </a:r>
+          </a:p>
+        </p:txBody>
+      </p:sp>
+      <p:sp>
+        <p:nvSpPr>
+          <p:cNvPr id="60" name="Rectangle 59">
+            <a:extLst>
+              <a:ext uri="{FF2B5EF4-FFF2-40B4-BE49-F238E27FC236}">
+                <a16:creationId xmlns:a16="http://schemas.microsoft.com/office/drawing/2014/main" id="{8140010D-3E5C-ADE1-B301-73133EE59575}"/>
+              </a:ext>
+            </a:extLst>
+          </p:cNvPr>
+          <p:cNvSpPr/>
+          <p:nvPr/>
+        </p:nvSpPr>
+        <p:spPr>
+          <a:xfrm>
+            <a:off x="10443667" y="14234206"/>
+            <a:ext cx="1087913" cy="548640"/>
+          </a:xfrm>
+          <a:prstGeom prst="rect">
+            <a:avLst/>
+          </a:prstGeom>
+          <a:solidFill>
+            <a:schemeClr val="accent2">
+              <a:lumMod val="20000"/>
+              <a:lumOff val="80000"/>
+            </a:schemeClr>
+          </a:solidFill>
+          <a:ln>
+            <a:solidFill>
+              <a:schemeClr val="tx1"/>
+            </a:solidFill>
+          </a:ln>
+        </p:spPr>
+        <p:style>
+          <a:lnRef idx="2">
+            <a:schemeClr val="accent1">
+              <a:shade val="50000"/>
+            </a:schemeClr>
+          </a:lnRef>
+          <a:fillRef idx="1">
+            <a:schemeClr val="accent1"/>
+          </a:fillRef>
+          <a:effectRef idx="0">
+            <a:schemeClr val="accent1"/>
+          </a:effectRef>
+          <a:fontRef idx="minor">
+            <a:schemeClr val="lt1"/>
+          </a:fontRef>
+        </p:style>
+        <p:txBody>
+          <a:bodyPr lIns="72000" tIns="72000" rIns="72000" bIns="72000" rtlCol="0" anchor="ctr" anchorCtr="0"/>
+          <a:lstStyle/>
+          <a:p>
+            <a:pPr algn="ctr"/>
+            <a:r>
+              <a:rPr lang="en-US" sz="900" b="1" dirty="0">
+                <a:solidFill>
+                  <a:schemeClr val="tx1"/>
+                </a:solidFill>
+              </a:rPr>
+              <a:t>Do I have several proxies?</a:t>
+            </a:r>
+          </a:p>
+        </p:txBody>
+      </p:sp>
+      <p:cxnSp>
+        <p:nvCxnSpPr>
+          <p:cNvPr id="62" name="Straight Arrow Connector 61">
+            <a:extLst>
+              <a:ext uri="{FF2B5EF4-FFF2-40B4-BE49-F238E27FC236}">
+                <a16:creationId xmlns:a16="http://schemas.microsoft.com/office/drawing/2014/main" id="{D7A857F5-C9E0-C09C-54D9-5541011C98CE}"/>
+              </a:ext>
+            </a:extLst>
+          </p:cNvPr>
+          <p:cNvCxnSpPr>
+            <a:cxnSpLocks/>
+            <a:stCxn id="60" idx="2"/>
+            <a:endCxn id="50" idx="0"/>
+          </p:cNvCxnSpPr>
+          <p:nvPr/>
+        </p:nvCxnSpPr>
+        <p:spPr>
+          <a:xfrm>
+            <a:off x="10987624" y="14782846"/>
+            <a:ext cx="0" cy="1309151"/>
+          </a:xfrm>
+          <a:prstGeom prst="straightConnector1">
+            <a:avLst/>
+          </a:prstGeom>
+          <a:ln w="9525">
+            <a:solidFill>
+              <a:schemeClr val="accent3"/>
+            </a:solidFill>
+            <a:tailEnd type="triangle"/>
+          </a:ln>
+        </p:spPr>
+        <p:style>
+          <a:lnRef idx="1">
+            <a:schemeClr val="accent1"/>
+          </a:lnRef>
+          <a:fillRef idx="0">
+            <a:schemeClr val="accent1"/>
+          </a:fillRef>
+          <a:effectRef idx="0">
+            <a:schemeClr val="accent1"/>
+          </a:effectRef>
+          <a:fontRef idx="minor">
+            <a:schemeClr val="tx1"/>
+          </a:fontRef>
+        </p:style>
+      </p:cxnSp>
+      <p:cxnSp>
+        <p:nvCxnSpPr>
+          <p:cNvPr id="137" name="Straight Arrow Connector 136">
+            <a:extLst>
+              <a:ext uri="{FF2B5EF4-FFF2-40B4-BE49-F238E27FC236}">
+                <a16:creationId xmlns:a16="http://schemas.microsoft.com/office/drawing/2014/main" id="{E6ECE97A-DC17-793C-6CD3-64A9A72FE63F}"/>
+              </a:ext>
+            </a:extLst>
+          </p:cNvPr>
+          <p:cNvCxnSpPr>
+            <a:cxnSpLocks/>
+            <a:stCxn id="60" idx="2"/>
+            <a:endCxn id="20" idx="0"/>
+          </p:cNvCxnSpPr>
+          <p:nvPr/>
+        </p:nvCxnSpPr>
+        <p:spPr>
+          <a:xfrm>
+            <a:off x="10987624" y="14782846"/>
+            <a:ext cx="1106802" cy="454250"/>
+          </a:xfrm>
+          <a:prstGeom prst="straightConnector1">
+            <a:avLst/>
+          </a:prstGeom>
+          <a:ln w="9525">
+            <a:solidFill>
+              <a:schemeClr val="tx2"/>
+            </a:solidFill>
+            <a:tailEnd type="triangle"/>
+          </a:ln>
+        </p:spPr>
+        <p:style>
+          <a:lnRef idx="1">
+            <a:schemeClr val="accent1"/>
+          </a:lnRef>
+          <a:fillRef idx="0">
+            <a:schemeClr val="accent1"/>
+          </a:fillRef>
+          <a:effectRef idx="0">
+            <a:schemeClr val="accent1"/>
+          </a:effectRef>
+          <a:fontRef idx="minor">
+            <a:schemeClr val="tx1"/>
+          </a:fontRef>
+        </p:style>
+      </p:cxnSp>
+      <p:sp>
+        <p:nvSpPr>
+          <p:cNvPr id="47" name="Rectangle 46">
+            <a:extLst>
+              <a:ext uri="{FF2B5EF4-FFF2-40B4-BE49-F238E27FC236}">
+                <a16:creationId xmlns:a16="http://schemas.microsoft.com/office/drawing/2014/main" id="{F8FD8B8E-9FAE-AE86-0224-467F10F48274}"/>
+              </a:ext>
+            </a:extLst>
+          </p:cNvPr>
+          <p:cNvSpPr/>
+          <p:nvPr/>
+        </p:nvSpPr>
+        <p:spPr>
+          <a:xfrm>
+            <a:off x="5492038" y="13565828"/>
+            <a:ext cx="7484070" cy="154748"/>
+          </a:xfrm>
+          <a:prstGeom prst="rect">
+            <a:avLst/>
+          </a:prstGeom>
+          <a:solidFill>
+            <a:schemeClr val="accent6">
+              <a:lumMod val="50000"/>
+            </a:schemeClr>
+          </a:solidFill>
+          <a:ln>
+            <a:noFill/>
+          </a:ln>
+        </p:spPr>
+        <p:style>
+          <a:lnRef idx="2">
+            <a:schemeClr val="accent1">
+              <a:shade val="50000"/>
+            </a:schemeClr>
+          </a:lnRef>
+          <a:fillRef idx="1">
+            <a:schemeClr val="accent1"/>
+          </a:fillRef>
+          <a:effectRef idx="0">
+            <a:schemeClr val="accent1"/>
+          </a:effectRef>
+          <a:fontRef idx="minor">
+            <a:schemeClr val="lt1"/>
+          </a:fontRef>
+        </p:style>
+        <p:txBody>
+          <a:bodyPr lIns="0" tIns="72000" rIns="0" bIns="72000" rtlCol="0" anchor="ctr" anchorCtr="0"/>
+          <a:lstStyle/>
+          <a:p>
+            <a:pPr algn="ctr"/>
+            <a:r>
+              <a:rPr lang="en-US" sz="1400" b="1" dirty="0">
+                <a:solidFill>
+                  <a:schemeClr val="bg1"/>
+                </a:solidFill>
+              </a:rPr>
+              <a:t>Annotation</a:t>
+            </a:r>
+          </a:p>
+        </p:txBody>
+      </p:sp>
+      <p:sp>
+        <p:nvSpPr>
+          <p:cNvPr id="49" name="Rectangle 48">
+            <a:extLst>
+              <a:ext uri="{FF2B5EF4-FFF2-40B4-BE49-F238E27FC236}">
+                <a16:creationId xmlns:a16="http://schemas.microsoft.com/office/drawing/2014/main" id="{842D5FB2-1FB0-6DE4-D76C-B2A97892FCD5}"/>
+              </a:ext>
+            </a:extLst>
+          </p:cNvPr>
+          <p:cNvSpPr/>
+          <p:nvPr/>
+        </p:nvSpPr>
+        <p:spPr>
+          <a:xfrm>
+            <a:off x="5492038" y="13755061"/>
+            <a:ext cx="7484070" cy="154748"/>
+          </a:xfrm>
+          <a:prstGeom prst="rect">
+            <a:avLst/>
+          </a:prstGeom>
+          <a:solidFill>
+            <a:schemeClr val="bg2"/>
+          </a:solidFill>
+          <a:ln>
+            <a:noFill/>
+          </a:ln>
+        </p:spPr>
+        <p:style>
+          <a:lnRef idx="2">
+            <a:schemeClr val="accent1">
+              <a:shade val="50000"/>
+            </a:schemeClr>
+          </a:lnRef>
+          <a:fillRef idx="1">
+            <a:schemeClr val="accent1"/>
+          </a:fillRef>
+          <a:effectRef idx="0">
+            <a:schemeClr val="accent1"/>
+          </a:effectRef>
+          <a:fontRef idx="minor">
+            <a:schemeClr val="lt1"/>
+          </a:fontRef>
+        </p:style>
+        <p:txBody>
+          <a:bodyPr lIns="0" tIns="72000" rIns="0" bIns="72000" rtlCol="0" anchor="ctr" anchorCtr="0"/>
+          <a:lstStyle/>
+          <a:p>
+            <a:pPr algn="ctr"/>
+            <a:r>
+              <a:rPr lang="en-US" sz="1400" b="1">
+                <a:solidFill>
+                  <a:schemeClr val="bg1"/>
+                </a:solidFill>
+              </a:rPr>
+              <a:t>Estimation</a:t>
+            </a:r>
+          </a:p>
+        </p:txBody>
+      </p:sp>
     </p:spTree>
     <p:extLst>
       <p:ext uri="{BB962C8B-B14F-4D97-AF65-F5344CB8AC3E}">

</xml_diff>

<commit_message>
doc: update decision tree to include Multi-Predict-Then-Debias branch
Co-Authored-By: Claude Sonnet 5 <noreply@anthropic.com>
</commit_message>
<xml_diff>
--- a/docs/assets/glide-decision-tree.pptx
+++ b/docs/assets/glide-decision-tree.pptx
@@ -1062,7 +1062,7 @@
           <a:p>
             <a:fld id="{554093C4-DEE1-4C4E-AC4A-8D017280FD94}" type="datetimeFigureOut">
               <a:rPr lang="nl-NL" smtClean="0"/>
-              <a:t>25-06-2026</a:t>
+              <a:t>27-07-2026</a:t>
             </a:fld>
             <a:endParaRPr lang="nl-NL"/>
           </a:p>
@@ -1255,7 +1255,7 @@
           <a:p>
             <a:fld id="{68674519-6056-489F-B3DD-67FB69B5B4F9}" type="datetimeFigureOut">
               <a:rPr lang="en-GB" smtClean="0"/>
-              <a:t>25/06/2026</a:t>
+              <a:t>27/07/2026</a:t>
             </a:fld>
             <a:endParaRPr lang="en-GB"/>
           </a:p>
@@ -2127,8 +2127,8 @@
         </p:nvSpPr>
         <p:spPr>
           <a:xfrm>
-            <a:off x="5492037" y="13944293"/>
-            <a:ext cx="7484067" cy="2888533"/>
+            <a:off x="5492038" y="13944293"/>
+            <a:ext cx="7658126" cy="2888533"/>
           </a:xfrm>
           <a:prstGeom prst="rect">
             <a:avLst/>
@@ -2186,8 +2186,8 @@
         </p:nvSpPr>
         <p:spPr>
           <a:xfrm>
-            <a:off x="5492037" y="9586292"/>
-            <a:ext cx="7484067" cy="3945051"/>
+            <a:off x="5492038" y="9586292"/>
+            <a:ext cx="7658126" cy="3945051"/>
           </a:xfrm>
           <a:prstGeom prst="rect">
             <a:avLst/>
@@ -2373,7 +2373,7 @@
         </p:nvSpPr>
         <p:spPr>
           <a:xfrm>
-            <a:off x="7194413" y="10467948"/>
+            <a:off x="7194413" y="10467947"/>
             <a:ext cx="1087913" cy="548640"/>
           </a:xfrm>
           <a:prstGeom prst="rect">
@@ -2579,8 +2579,8 @@
         </p:nvCxnSpPr>
         <p:spPr>
           <a:xfrm flipH="1">
-            <a:off x="7223346" y="11016588"/>
-            <a:ext cx="515024" cy="1864639"/>
+            <a:off x="7223346" y="11016587"/>
+            <a:ext cx="515024" cy="1864640"/>
           </a:xfrm>
           <a:prstGeom prst="straightConnector1">
             <a:avLst/>
@@ -2625,7 +2625,7 @@
         </p:nvCxnSpPr>
         <p:spPr>
           <a:xfrm>
-            <a:off x="7738370" y="11016588"/>
+            <a:off x="7738370" y="11016587"/>
             <a:ext cx="1196317" cy="255786"/>
           </a:xfrm>
           <a:prstGeom prst="straightConnector1">
@@ -2671,8 +2671,8 @@
         </p:nvCxnSpPr>
         <p:spPr>
           <a:xfrm flipH="1">
-            <a:off x="8253393" y="11821014"/>
-            <a:ext cx="681294" cy="1060213"/>
+            <a:off x="8253393" y="11821013"/>
+            <a:ext cx="681294" cy="1060214"/>
           </a:xfrm>
           <a:prstGeom prst="straightConnector1">
             <a:avLst/>
@@ -2717,8 +2717,8 @@
         </p:nvCxnSpPr>
         <p:spPr>
           <a:xfrm>
-            <a:off x="8934687" y="11821014"/>
-            <a:ext cx="1368625" cy="255786"/>
+            <a:off x="8934687" y="11821013"/>
+            <a:ext cx="1710128" cy="255787"/>
           </a:xfrm>
           <a:prstGeom prst="straightConnector1">
             <a:avLst/>
@@ -2764,7 +2764,7 @@
         <p:spPr>
           <a:xfrm>
             <a:off x="6989112" y="10212161"/>
-            <a:ext cx="749258" cy="255787"/>
+            <a:ext cx="749258" cy="255786"/>
           </a:xfrm>
           <a:prstGeom prst="straightConnector1">
             <a:avLst/>
@@ -2805,7 +2805,7 @@
         </p:nvSpPr>
         <p:spPr>
           <a:xfrm>
-            <a:off x="8390730" y="11272374"/>
+            <a:off x="8390730" y="11272373"/>
             <a:ext cx="1087913" cy="548640"/>
           </a:xfrm>
           <a:prstGeom prst="rect">
@@ -2869,7 +2869,7 @@
         </p:nvSpPr>
         <p:spPr>
           <a:xfrm>
-            <a:off x="10678580" y="12881227"/>
+            <a:off x="11361587" y="12881227"/>
             <a:ext cx="618087" cy="550255"/>
           </a:xfrm>
           <a:prstGeom prst="rect">
@@ -2915,199 +2915,6 @@
                 </a:solidFill>
               </a:rPr>
               <a:t>Uniform Sampler</a:t>
-            </a:r>
-          </a:p>
-        </p:txBody>
-      </p:sp>
-      <p:sp>
-        <p:nvSpPr>
-          <p:cNvPr id="18" name="Rectangle 17">
-            <a:extLst>
-              <a:ext uri="{FF2B5EF4-FFF2-40B4-BE49-F238E27FC236}">
-                <a16:creationId xmlns:a16="http://schemas.microsoft.com/office/drawing/2014/main" id="{8C0A3CA3-7E77-168F-07DD-94AF2A1E042A}"/>
-              </a:ext>
-            </a:extLst>
-          </p:cNvPr>
-          <p:cNvSpPr/>
-          <p:nvPr/>
-        </p:nvSpPr>
-        <p:spPr>
-          <a:xfrm>
-            <a:off x="11443786" y="16091997"/>
-            <a:ext cx="618087" cy="550255"/>
-          </a:xfrm>
-          <a:prstGeom prst="rect">
-            <a:avLst/>
-          </a:prstGeom>
-          <a:solidFill>
-            <a:schemeClr val="accent3">
-              <a:lumMod val="20000"/>
-              <a:lumOff val="80000"/>
-            </a:schemeClr>
-          </a:solidFill>
-          <a:ln>
-            <a:solidFill>
-              <a:schemeClr val="tx1"/>
-            </a:solidFill>
-          </a:ln>
-        </p:spPr>
-        <p:style>
-          <a:lnRef idx="2">
-            <a:schemeClr val="accent1">
-              <a:shade val="50000"/>
-            </a:schemeClr>
-          </a:lnRef>
-          <a:fillRef idx="1">
-            <a:schemeClr val="accent1"/>
-          </a:fillRef>
-          <a:effectRef idx="0">
-            <a:schemeClr val="accent1"/>
-          </a:effectRef>
-          <a:fontRef idx="minor">
-            <a:schemeClr val="lt1"/>
-          </a:fontRef>
-        </p:style>
-        <p:txBody>
-          <a:bodyPr lIns="72000" tIns="72000" rIns="72000" bIns="72000" rtlCol="0" anchor="ctr" anchorCtr="0"/>
-          <a:lstStyle/>
-          <a:p>
-            <a:pPr algn="ctr"/>
-            <a:r>
-              <a:rPr lang="en-US" sz="900" b="1">
-                <a:solidFill>
-                  <a:schemeClr val="tx1"/>
-                </a:solidFill>
-              </a:rPr>
-              <a:t>PPI++</a:t>
-            </a:r>
-          </a:p>
-        </p:txBody>
-      </p:sp>
-      <p:sp>
-        <p:nvSpPr>
-          <p:cNvPr id="19" name="Rectangle 18">
-            <a:extLst>
-              <a:ext uri="{FF2B5EF4-FFF2-40B4-BE49-F238E27FC236}">
-                <a16:creationId xmlns:a16="http://schemas.microsoft.com/office/drawing/2014/main" id="{6C2C49B0-B5A7-FA43-E23D-18CADD1633D1}"/>
-              </a:ext>
-            </a:extLst>
-          </p:cNvPr>
-          <p:cNvSpPr/>
-          <p:nvPr/>
-        </p:nvSpPr>
-        <p:spPr>
-          <a:xfrm>
-            <a:off x="12126978" y="16091997"/>
-            <a:ext cx="618087" cy="550255"/>
-          </a:xfrm>
-          <a:prstGeom prst="rect">
-            <a:avLst/>
-          </a:prstGeom>
-          <a:solidFill>
-            <a:schemeClr val="accent3">
-              <a:lumMod val="20000"/>
-              <a:lumOff val="80000"/>
-            </a:schemeClr>
-          </a:solidFill>
-          <a:ln>
-            <a:solidFill>
-              <a:schemeClr val="tx1"/>
-            </a:solidFill>
-            <a:prstDash val="solid"/>
-          </a:ln>
-        </p:spPr>
-        <p:style>
-          <a:lnRef idx="2">
-            <a:schemeClr val="accent1">
-              <a:shade val="50000"/>
-            </a:schemeClr>
-          </a:lnRef>
-          <a:fillRef idx="1">
-            <a:schemeClr val="accent1"/>
-          </a:fillRef>
-          <a:effectRef idx="0">
-            <a:schemeClr val="accent1"/>
-          </a:effectRef>
-          <a:fontRef idx="minor">
-            <a:schemeClr val="lt1"/>
-          </a:fontRef>
-        </p:style>
-        <p:txBody>
-          <a:bodyPr lIns="72000" tIns="72000" rIns="72000" bIns="72000" rtlCol="0" anchor="ctr" anchorCtr="0"/>
-          <a:lstStyle/>
-          <a:p>
-            <a:pPr algn="ctr"/>
-            <a:r>
-              <a:rPr lang="en-US" sz="900" b="1" dirty="0">
-                <a:solidFill>
-                  <a:schemeClr val="tx1"/>
-                </a:solidFill>
-              </a:rPr>
-              <a:t>Predict-Then-Debias</a:t>
-            </a:r>
-          </a:p>
-        </p:txBody>
-      </p:sp>
-      <p:sp>
-        <p:nvSpPr>
-          <p:cNvPr id="20" name="Rectangle 19">
-            <a:extLst>
-              <a:ext uri="{FF2B5EF4-FFF2-40B4-BE49-F238E27FC236}">
-                <a16:creationId xmlns:a16="http://schemas.microsoft.com/office/drawing/2014/main" id="{2DFA7926-41C5-7E1B-F41B-4ADF8018AA06}"/>
-              </a:ext>
-            </a:extLst>
-          </p:cNvPr>
-          <p:cNvSpPr/>
-          <p:nvPr/>
-        </p:nvSpPr>
-        <p:spPr>
-          <a:xfrm>
-            <a:off x="11550469" y="15237096"/>
-            <a:ext cx="1087913" cy="548640"/>
-          </a:xfrm>
-          <a:prstGeom prst="rect">
-            <a:avLst/>
-          </a:prstGeom>
-          <a:solidFill>
-            <a:schemeClr val="accent2">
-              <a:lumMod val="20000"/>
-              <a:lumOff val="80000"/>
-            </a:schemeClr>
-          </a:solidFill>
-          <a:ln>
-            <a:solidFill>
-              <a:schemeClr val="tx1"/>
-            </a:solidFill>
-          </a:ln>
-        </p:spPr>
-        <p:style>
-          <a:lnRef idx="2">
-            <a:schemeClr val="accent1">
-              <a:shade val="50000"/>
-            </a:schemeClr>
-          </a:lnRef>
-          <a:fillRef idx="1">
-            <a:schemeClr val="accent1"/>
-          </a:fillRef>
-          <a:effectRef idx="0">
-            <a:schemeClr val="accent1"/>
-          </a:effectRef>
-          <a:fontRef idx="minor">
-            <a:schemeClr val="lt1"/>
-          </a:fontRef>
-        </p:style>
-        <p:txBody>
-          <a:bodyPr lIns="72000" tIns="72000" rIns="72000" bIns="72000" rtlCol="0" anchor="ctr" anchorCtr="0"/>
-          <a:lstStyle/>
-          <a:p>
-            <a:pPr algn="ctr"/>
-            <a:r>
-              <a:rPr lang="en-US" sz="900" b="1" dirty="0">
-                <a:solidFill>
-                  <a:schemeClr val="tx1"/>
-                </a:solidFill>
-              </a:rPr>
-              <a:t>Do I have more than 50 human labels?</a:t>
             </a:r>
           </a:p>
         </p:txBody>
@@ -3863,6 +3670,199 @@
           </a:fontRef>
         </p:style>
       </p:cxnSp>
+      <p:sp>
+        <p:nvSpPr>
+          <p:cNvPr id="18" name="Rectangle 17">
+            <a:extLst>
+              <a:ext uri="{FF2B5EF4-FFF2-40B4-BE49-F238E27FC236}">
+                <a16:creationId xmlns:a16="http://schemas.microsoft.com/office/drawing/2014/main" id="{8C0A3CA3-7E77-168F-07DD-94AF2A1E042A}"/>
+              </a:ext>
+            </a:extLst>
+          </p:cNvPr>
+          <p:cNvSpPr/>
+          <p:nvPr/>
+        </p:nvSpPr>
+        <p:spPr>
+          <a:xfrm>
+            <a:off x="11699336" y="16091997"/>
+            <a:ext cx="618087" cy="550255"/>
+          </a:xfrm>
+          <a:prstGeom prst="rect">
+            <a:avLst/>
+          </a:prstGeom>
+          <a:solidFill>
+            <a:schemeClr val="accent3">
+              <a:lumMod val="20000"/>
+              <a:lumOff val="80000"/>
+            </a:schemeClr>
+          </a:solidFill>
+          <a:ln>
+            <a:solidFill>
+              <a:schemeClr val="tx1"/>
+            </a:solidFill>
+          </a:ln>
+        </p:spPr>
+        <p:style>
+          <a:lnRef idx="2">
+            <a:schemeClr val="accent1">
+              <a:shade val="50000"/>
+            </a:schemeClr>
+          </a:lnRef>
+          <a:fillRef idx="1">
+            <a:schemeClr val="accent1"/>
+          </a:fillRef>
+          <a:effectRef idx="0">
+            <a:schemeClr val="accent1"/>
+          </a:effectRef>
+          <a:fontRef idx="minor">
+            <a:schemeClr val="lt1"/>
+          </a:fontRef>
+        </p:style>
+        <p:txBody>
+          <a:bodyPr lIns="72000" tIns="72000" rIns="72000" bIns="72000" rtlCol="0" anchor="ctr" anchorCtr="0"/>
+          <a:lstStyle/>
+          <a:p>
+            <a:pPr algn="ctr"/>
+            <a:r>
+              <a:rPr lang="en-US" sz="900" b="1">
+                <a:solidFill>
+                  <a:schemeClr val="tx1"/>
+                </a:solidFill>
+              </a:rPr>
+              <a:t>PPI++</a:t>
+            </a:r>
+          </a:p>
+        </p:txBody>
+      </p:sp>
+      <p:sp>
+        <p:nvSpPr>
+          <p:cNvPr id="19" name="Rectangle 18">
+            <a:extLst>
+              <a:ext uri="{FF2B5EF4-FFF2-40B4-BE49-F238E27FC236}">
+                <a16:creationId xmlns:a16="http://schemas.microsoft.com/office/drawing/2014/main" id="{6C2C49B0-B5A7-FA43-E23D-18CADD1633D1}"/>
+              </a:ext>
+            </a:extLst>
+          </p:cNvPr>
+          <p:cNvSpPr/>
+          <p:nvPr/>
+        </p:nvSpPr>
+        <p:spPr>
+          <a:xfrm>
+            <a:off x="12384415" y="16091997"/>
+            <a:ext cx="618087" cy="550255"/>
+          </a:xfrm>
+          <a:prstGeom prst="rect">
+            <a:avLst/>
+          </a:prstGeom>
+          <a:solidFill>
+            <a:schemeClr val="accent3">
+              <a:lumMod val="20000"/>
+              <a:lumOff val="80000"/>
+            </a:schemeClr>
+          </a:solidFill>
+          <a:ln>
+            <a:solidFill>
+              <a:schemeClr val="tx1"/>
+            </a:solidFill>
+            <a:prstDash val="solid"/>
+          </a:ln>
+        </p:spPr>
+        <p:style>
+          <a:lnRef idx="2">
+            <a:schemeClr val="accent1">
+              <a:shade val="50000"/>
+            </a:schemeClr>
+          </a:lnRef>
+          <a:fillRef idx="1">
+            <a:schemeClr val="accent1"/>
+          </a:fillRef>
+          <a:effectRef idx="0">
+            <a:schemeClr val="accent1"/>
+          </a:effectRef>
+          <a:fontRef idx="minor">
+            <a:schemeClr val="lt1"/>
+          </a:fontRef>
+        </p:style>
+        <p:txBody>
+          <a:bodyPr lIns="72000" tIns="72000" rIns="72000" bIns="72000" rtlCol="0" anchor="ctr" anchorCtr="0"/>
+          <a:lstStyle/>
+          <a:p>
+            <a:pPr algn="ctr"/>
+            <a:r>
+              <a:rPr lang="en-US" sz="900" b="1" dirty="0">
+                <a:solidFill>
+                  <a:schemeClr val="tx1"/>
+                </a:solidFill>
+              </a:rPr>
+              <a:t>Predict-Then-Debias</a:t>
+            </a:r>
+          </a:p>
+        </p:txBody>
+      </p:sp>
+      <p:sp>
+        <p:nvSpPr>
+          <p:cNvPr id="20" name="Rectangle 19">
+            <a:extLst>
+              <a:ext uri="{FF2B5EF4-FFF2-40B4-BE49-F238E27FC236}">
+                <a16:creationId xmlns:a16="http://schemas.microsoft.com/office/drawing/2014/main" id="{2DFA7926-41C5-7E1B-F41B-4ADF8018AA06}"/>
+              </a:ext>
+            </a:extLst>
+          </p:cNvPr>
+          <p:cNvSpPr/>
+          <p:nvPr/>
+        </p:nvSpPr>
+        <p:spPr>
+          <a:xfrm>
+            <a:off x="11806962" y="15237096"/>
+            <a:ext cx="1087913" cy="548640"/>
+          </a:xfrm>
+          <a:prstGeom prst="rect">
+            <a:avLst/>
+          </a:prstGeom>
+          <a:solidFill>
+            <a:schemeClr val="accent2">
+              <a:lumMod val="20000"/>
+              <a:lumOff val="80000"/>
+            </a:schemeClr>
+          </a:solidFill>
+          <a:ln>
+            <a:solidFill>
+              <a:schemeClr val="tx1"/>
+            </a:solidFill>
+          </a:ln>
+        </p:spPr>
+        <p:style>
+          <a:lnRef idx="2">
+            <a:schemeClr val="accent1">
+              <a:shade val="50000"/>
+            </a:schemeClr>
+          </a:lnRef>
+          <a:fillRef idx="1">
+            <a:schemeClr val="accent1"/>
+          </a:fillRef>
+          <a:effectRef idx="0">
+            <a:schemeClr val="accent1"/>
+          </a:effectRef>
+          <a:fontRef idx="minor">
+            <a:schemeClr val="lt1"/>
+          </a:fontRef>
+        </p:style>
+        <p:txBody>
+          <a:bodyPr lIns="72000" tIns="72000" rIns="72000" bIns="72000" rtlCol="0" anchor="ctr" anchorCtr="0"/>
+          <a:lstStyle/>
+          <a:p>
+            <a:pPr algn="ctr"/>
+            <a:r>
+              <a:rPr lang="en-US" sz="900" b="1" dirty="0">
+                <a:solidFill>
+                  <a:schemeClr val="tx1"/>
+                </a:solidFill>
+              </a:rPr>
+              <a:t>Do I have more than 50 human labels?</a:t>
+            </a:r>
+          </a:p>
+        </p:txBody>
+      </p:sp>
       <p:cxnSp>
         <p:nvCxnSpPr>
           <p:cNvPr id="33" name="Straight Arrow Connector 32">
@@ -3881,8 +3881,8 @@
         </p:nvCxnSpPr>
         <p:spPr>
           <a:xfrm>
-            <a:off x="12094426" y="15785736"/>
-            <a:ext cx="341596" cy="306261"/>
+            <a:off x="12350919" y="15785736"/>
+            <a:ext cx="342540" cy="306261"/>
           </a:xfrm>
           <a:prstGeom prst="straightConnector1">
             <a:avLst/>
@@ -3927,8 +3927,8 @@
         </p:nvCxnSpPr>
         <p:spPr>
           <a:xfrm flipH="1">
-            <a:off x="11752830" y="15785736"/>
-            <a:ext cx="341596" cy="306261"/>
+            <a:off x="12008380" y="15785736"/>
+            <a:ext cx="342539" cy="306261"/>
           </a:xfrm>
           <a:prstGeom prst="straightConnector1">
             <a:avLst/>
@@ -4256,9 +4256,9 @@
           <p:nvPr/>
         </p:nvCxnSpPr>
         <p:spPr>
-          <a:xfrm>
-            <a:off x="10987624" y="13431482"/>
-            <a:ext cx="0" cy="802724"/>
+          <a:xfrm flipH="1">
+            <a:off x="11667502" y="13431482"/>
+            <a:ext cx="3129" cy="802724"/>
           </a:xfrm>
           <a:prstGeom prst="straightConnector1">
             <a:avLst/>
@@ -4525,8 +4525,8 @@
         </p:nvSpPr>
         <p:spPr>
           <a:xfrm>
-            <a:off x="5492038" y="9397059"/>
-            <a:ext cx="7484070" cy="154748"/>
+            <a:off x="5492037" y="9397059"/>
+            <a:ext cx="7658129" cy="154748"/>
           </a:xfrm>
           <a:prstGeom prst="rect">
             <a:avLst/>
@@ -4584,7 +4584,7 @@
         </p:nvSpPr>
         <p:spPr>
           <a:xfrm>
-            <a:off x="9759355" y="12076800"/>
+            <a:off x="10100858" y="12076800"/>
             <a:ext cx="1087913" cy="548640"/>
           </a:xfrm>
           <a:prstGeom prst="rect">
@@ -5050,7 +5050,7 @@
         <p:spPr>
           <a:xfrm flipH="1">
             <a:off x="9618999" y="12625440"/>
-            <a:ext cx="684313" cy="255787"/>
+            <a:ext cx="1025816" cy="255787"/>
           </a:xfrm>
           <a:prstGeom prst="straightConnector1">
             <a:avLst/>
@@ -5095,8 +5095,8 @@
         </p:nvCxnSpPr>
         <p:spPr>
           <a:xfrm>
-            <a:off x="10303312" y="12625440"/>
-            <a:ext cx="684312" cy="255787"/>
+            <a:off x="10644815" y="12625440"/>
+            <a:ext cx="1025816" cy="255787"/>
           </a:xfrm>
           <a:prstGeom prst="straightConnector1">
             <a:avLst/>
@@ -5125,10 +5125,10 @@
       </p:cxnSp>
       <p:sp>
         <p:nvSpPr>
-          <p:cNvPr id="50" name="Rectangle 49">
-            <a:extLst>
-              <a:ext uri="{FF2B5EF4-FFF2-40B4-BE49-F238E27FC236}">
-                <a16:creationId xmlns:a16="http://schemas.microsoft.com/office/drawing/2014/main" id="{7DD94F55-CC54-1638-8B4D-6D05B04412AF}"/>
+          <p:cNvPr id="60" name="Rectangle 59">
+            <a:extLst>
+              <a:ext uri="{FF2B5EF4-FFF2-40B4-BE49-F238E27FC236}">
+                <a16:creationId xmlns:a16="http://schemas.microsoft.com/office/drawing/2014/main" id="{8140010D-3E5C-ADE1-B301-73133EE59575}"/>
               </a:ext>
             </a:extLst>
           </p:cNvPr>
@@ -5137,72 +5137,7 @@
         </p:nvSpPr>
         <p:spPr>
           <a:xfrm>
-            <a:off x="10678580" y="16091997"/>
-            <a:ext cx="618087" cy="550255"/>
-          </a:xfrm>
-          <a:prstGeom prst="rect">
-            <a:avLst/>
-          </a:prstGeom>
-          <a:solidFill>
-            <a:schemeClr val="accent3">
-              <a:lumMod val="20000"/>
-              <a:lumOff val="80000"/>
-            </a:schemeClr>
-          </a:solidFill>
-          <a:ln>
-            <a:solidFill>
-              <a:schemeClr val="tx1"/>
-            </a:solidFill>
-            <a:prstDash val="solid"/>
-          </a:ln>
-        </p:spPr>
-        <p:style>
-          <a:lnRef idx="2">
-            <a:schemeClr val="accent1">
-              <a:shade val="50000"/>
-            </a:schemeClr>
-          </a:lnRef>
-          <a:fillRef idx="1">
-            <a:schemeClr val="accent1"/>
-          </a:fillRef>
-          <a:effectRef idx="0">
-            <a:schemeClr val="accent1"/>
-          </a:effectRef>
-          <a:fontRef idx="minor">
-            <a:schemeClr val="lt1"/>
-          </a:fontRef>
-        </p:style>
-        <p:txBody>
-          <a:bodyPr lIns="72000" tIns="72000" rIns="72000" bIns="72000" rtlCol="0" anchor="ctr" anchorCtr="0"/>
-          <a:lstStyle/>
-          <a:p>
-            <a:pPr algn="ctr"/>
-            <a:r>
-              <a:rPr lang="en-US" sz="900" b="1" dirty="0">
-                <a:solidFill>
-                  <a:schemeClr val="tx1"/>
-                </a:solidFill>
-              </a:rPr>
-              <a:t>Multi-PPI++</a:t>
-            </a:r>
-          </a:p>
-        </p:txBody>
-      </p:sp>
-      <p:sp>
-        <p:nvSpPr>
-          <p:cNvPr id="60" name="Rectangle 59">
-            <a:extLst>
-              <a:ext uri="{FF2B5EF4-FFF2-40B4-BE49-F238E27FC236}">
-                <a16:creationId xmlns:a16="http://schemas.microsoft.com/office/drawing/2014/main" id="{8140010D-3E5C-ADE1-B301-73133EE59575}"/>
-              </a:ext>
-            </a:extLst>
-          </p:cNvPr>
-          <p:cNvSpPr/>
-          <p:nvPr/>
-        </p:nvSpPr>
-        <p:spPr>
-          <a:xfrm>
-            <a:off x="10443667" y="14234206"/>
+            <a:off x="11123545" y="14234206"/>
             <a:ext cx="1087913" cy="548640"/>
           </a:xfrm>
           <a:prstGeom prst="rect">
@@ -5264,14 +5199,14 @@
           <p:cNvCxnSpPr>
             <a:cxnSpLocks/>
             <a:stCxn id="60" idx="2"/>
-            <a:endCxn id="50" idx="0"/>
+            <a:endCxn id="59" idx="0"/>
           </p:cNvCxnSpPr>
           <p:nvPr/>
         </p:nvCxnSpPr>
         <p:spPr>
-          <a:xfrm>
-            <a:off x="10987624" y="14782846"/>
-            <a:ext cx="0" cy="1309151"/>
+          <a:xfrm flipH="1">
+            <a:off x="10984086" y="14782846"/>
+            <a:ext cx="683416" cy="454250"/>
           </a:xfrm>
           <a:prstGeom prst="straightConnector1">
             <a:avLst/>
@@ -5316,8 +5251,8 @@
         </p:nvCxnSpPr>
         <p:spPr>
           <a:xfrm>
-            <a:off x="10987624" y="14782846"/>
-            <a:ext cx="1106802" cy="454250"/>
+            <a:off x="11667502" y="14782846"/>
+            <a:ext cx="683417" cy="454250"/>
           </a:xfrm>
           <a:prstGeom prst="straightConnector1">
             <a:avLst/>
@@ -5358,8 +5293,8 @@
         </p:nvSpPr>
         <p:spPr>
           <a:xfrm>
-            <a:off x="5492038" y="13565828"/>
-            <a:ext cx="7484070" cy="154748"/>
+            <a:off x="5492037" y="13565828"/>
+            <a:ext cx="7658129" cy="154748"/>
           </a:xfrm>
           <a:prstGeom prst="rect">
             <a:avLst/>
@@ -5419,8 +5354,8 @@
         </p:nvSpPr>
         <p:spPr>
           <a:xfrm>
-            <a:off x="5492038" y="13755061"/>
-            <a:ext cx="7484070" cy="154748"/>
+            <a:off x="5492037" y="13755061"/>
+            <a:ext cx="7658129" cy="154748"/>
           </a:xfrm>
           <a:prstGeom prst="rect">
             <a:avLst/>
@@ -5464,6 +5399,292 @@
           </a:p>
         </p:txBody>
       </p:sp>
+      <p:sp>
+        <p:nvSpPr>
+          <p:cNvPr id="50" name="Rectangle 49">
+            <a:extLst>
+              <a:ext uri="{FF2B5EF4-FFF2-40B4-BE49-F238E27FC236}">
+                <a16:creationId xmlns:a16="http://schemas.microsoft.com/office/drawing/2014/main" id="{7DD94F55-CC54-1638-8B4D-6D05B04412AF}"/>
+              </a:ext>
+            </a:extLst>
+          </p:cNvPr>
+          <p:cNvSpPr/>
+          <p:nvPr/>
+        </p:nvSpPr>
+        <p:spPr>
+          <a:xfrm>
+            <a:off x="10331063" y="16091997"/>
+            <a:ext cx="618087" cy="550255"/>
+          </a:xfrm>
+          <a:prstGeom prst="rect">
+            <a:avLst/>
+          </a:prstGeom>
+          <a:solidFill>
+            <a:schemeClr val="accent3">
+              <a:lumMod val="20000"/>
+              <a:lumOff val="80000"/>
+            </a:schemeClr>
+          </a:solidFill>
+          <a:ln>
+            <a:solidFill>
+              <a:schemeClr val="tx1"/>
+            </a:solidFill>
+            <a:prstDash val="solid"/>
+          </a:ln>
+        </p:spPr>
+        <p:style>
+          <a:lnRef idx="2">
+            <a:schemeClr val="accent1">
+              <a:shade val="50000"/>
+            </a:schemeClr>
+          </a:lnRef>
+          <a:fillRef idx="1">
+            <a:schemeClr val="accent1"/>
+          </a:fillRef>
+          <a:effectRef idx="0">
+            <a:schemeClr val="accent1"/>
+          </a:effectRef>
+          <a:fontRef idx="minor">
+            <a:schemeClr val="lt1"/>
+          </a:fontRef>
+        </p:style>
+        <p:txBody>
+          <a:bodyPr lIns="72000" tIns="72000" rIns="72000" bIns="72000" rtlCol="0" anchor="ctr" anchorCtr="0"/>
+          <a:lstStyle/>
+          <a:p>
+            <a:pPr algn="ctr"/>
+            <a:r>
+              <a:rPr lang="en-US" sz="900" b="1" dirty="0">
+                <a:solidFill>
+                  <a:schemeClr val="tx1"/>
+                </a:solidFill>
+              </a:rPr>
+              <a:t>Multi-PPI++</a:t>
+            </a:r>
+          </a:p>
+        </p:txBody>
+      </p:sp>
+      <p:sp>
+        <p:nvSpPr>
+          <p:cNvPr id="59" name="Rectangle 58">
+            <a:extLst>
+              <a:ext uri="{FF2B5EF4-FFF2-40B4-BE49-F238E27FC236}">
+                <a16:creationId xmlns:a16="http://schemas.microsoft.com/office/drawing/2014/main" id="{02F9FFA9-CDEB-EF97-BB4E-3708238FA809}"/>
+              </a:ext>
+            </a:extLst>
+          </p:cNvPr>
+          <p:cNvSpPr/>
+          <p:nvPr/>
+        </p:nvSpPr>
+        <p:spPr>
+          <a:xfrm>
+            <a:off x="10440129" y="15237096"/>
+            <a:ext cx="1087913" cy="548640"/>
+          </a:xfrm>
+          <a:prstGeom prst="rect">
+            <a:avLst/>
+          </a:prstGeom>
+          <a:solidFill>
+            <a:schemeClr val="accent2">
+              <a:lumMod val="20000"/>
+              <a:lumOff val="80000"/>
+            </a:schemeClr>
+          </a:solidFill>
+          <a:ln>
+            <a:solidFill>
+              <a:schemeClr val="tx1"/>
+            </a:solidFill>
+          </a:ln>
+        </p:spPr>
+        <p:style>
+          <a:lnRef idx="2">
+            <a:schemeClr val="accent1">
+              <a:shade val="50000"/>
+            </a:schemeClr>
+          </a:lnRef>
+          <a:fillRef idx="1">
+            <a:schemeClr val="accent1"/>
+          </a:fillRef>
+          <a:effectRef idx="0">
+            <a:schemeClr val="accent1"/>
+          </a:effectRef>
+          <a:fontRef idx="minor">
+            <a:schemeClr val="lt1"/>
+          </a:fontRef>
+        </p:style>
+        <p:txBody>
+          <a:bodyPr lIns="72000" tIns="72000" rIns="72000" bIns="72000" rtlCol="0" anchor="ctr" anchorCtr="0"/>
+          <a:lstStyle/>
+          <a:p>
+            <a:pPr algn="ctr"/>
+            <a:r>
+              <a:rPr lang="en-US" sz="900" b="1" dirty="0">
+                <a:solidFill>
+                  <a:schemeClr val="tx1"/>
+                </a:solidFill>
+              </a:rPr>
+              <a:t>Do I have more than 50 human labels?</a:t>
+            </a:r>
+          </a:p>
+        </p:txBody>
+      </p:sp>
+      <p:sp>
+        <p:nvSpPr>
+          <p:cNvPr id="128" name="Rectangle 127">
+            <a:extLst>
+              <a:ext uri="{FF2B5EF4-FFF2-40B4-BE49-F238E27FC236}">
+                <a16:creationId xmlns:a16="http://schemas.microsoft.com/office/drawing/2014/main" id="{3FEF0966-C11E-CDF7-E2B2-3FA3DD92D7F2}"/>
+              </a:ext>
+            </a:extLst>
+          </p:cNvPr>
+          <p:cNvSpPr/>
+          <p:nvPr/>
+        </p:nvSpPr>
+        <p:spPr>
+          <a:xfrm>
+            <a:off x="11019021" y="16091997"/>
+            <a:ext cx="618087" cy="550255"/>
+          </a:xfrm>
+          <a:prstGeom prst="rect">
+            <a:avLst/>
+          </a:prstGeom>
+          <a:solidFill>
+            <a:schemeClr val="accent3">
+              <a:lumMod val="20000"/>
+              <a:lumOff val="80000"/>
+            </a:schemeClr>
+          </a:solidFill>
+          <a:ln>
+            <a:solidFill>
+              <a:schemeClr val="tx1"/>
+            </a:solidFill>
+            <a:prstDash val="solid"/>
+          </a:ln>
+        </p:spPr>
+        <p:style>
+          <a:lnRef idx="2">
+            <a:schemeClr val="accent1">
+              <a:shade val="50000"/>
+            </a:schemeClr>
+          </a:lnRef>
+          <a:fillRef idx="1">
+            <a:schemeClr val="accent1"/>
+          </a:fillRef>
+          <a:effectRef idx="0">
+            <a:schemeClr val="accent1"/>
+          </a:effectRef>
+          <a:fontRef idx="minor">
+            <a:schemeClr val="lt1"/>
+          </a:fontRef>
+        </p:style>
+        <p:txBody>
+          <a:bodyPr lIns="72000" tIns="72000" rIns="72000" bIns="72000" rtlCol="0" anchor="ctr" anchorCtr="0"/>
+          <a:lstStyle/>
+          <a:p>
+            <a:pPr algn="ctr"/>
+            <a:r>
+              <a:rPr lang="en-US" sz="900" b="1" dirty="0">
+                <a:solidFill>
+                  <a:schemeClr val="tx1"/>
+                </a:solidFill>
+              </a:rPr>
+              <a:t>Multi-Predict-Then-Debias</a:t>
+            </a:r>
+          </a:p>
+        </p:txBody>
+      </p:sp>
+      <p:cxnSp>
+        <p:nvCxnSpPr>
+          <p:cNvPr id="129" name="Straight Arrow Connector 128">
+            <a:extLst>
+              <a:ext uri="{FF2B5EF4-FFF2-40B4-BE49-F238E27FC236}">
+                <a16:creationId xmlns:a16="http://schemas.microsoft.com/office/drawing/2014/main" id="{961E096D-DE7E-FE29-40E0-91EF44BA1E85}"/>
+              </a:ext>
+            </a:extLst>
+          </p:cNvPr>
+          <p:cNvCxnSpPr>
+            <a:cxnSpLocks/>
+            <a:stCxn id="59" idx="2"/>
+            <a:endCxn id="50" idx="0"/>
+          </p:cNvCxnSpPr>
+          <p:nvPr/>
+        </p:nvCxnSpPr>
+        <p:spPr>
+          <a:xfrm flipH="1">
+            <a:off x="10640107" y="15785736"/>
+            <a:ext cx="343979" cy="306261"/>
+          </a:xfrm>
+          <a:prstGeom prst="straightConnector1">
+            <a:avLst/>
+          </a:prstGeom>
+          <a:ln w="9525">
+            <a:solidFill>
+              <a:schemeClr val="accent3"/>
+            </a:solidFill>
+            <a:tailEnd type="triangle"/>
+          </a:ln>
+        </p:spPr>
+        <p:style>
+          <a:lnRef idx="1">
+            <a:schemeClr val="accent1"/>
+          </a:lnRef>
+          <a:fillRef idx="0">
+            <a:schemeClr val="accent1"/>
+          </a:fillRef>
+          <a:effectRef idx="0">
+            <a:schemeClr val="accent1"/>
+          </a:effectRef>
+          <a:fontRef idx="minor">
+            <a:schemeClr val="tx1"/>
+          </a:fontRef>
+        </p:style>
+      </p:cxnSp>
+      <p:cxnSp>
+        <p:nvCxnSpPr>
+          <p:cNvPr id="133" name="Straight Arrow Connector 132">
+            <a:extLst>
+              <a:ext uri="{FF2B5EF4-FFF2-40B4-BE49-F238E27FC236}">
+                <a16:creationId xmlns:a16="http://schemas.microsoft.com/office/drawing/2014/main" id="{C0768CA0-74A7-A965-FE46-F52DF08E0AEF}"/>
+              </a:ext>
+            </a:extLst>
+          </p:cNvPr>
+          <p:cNvCxnSpPr>
+            <a:cxnSpLocks/>
+            <a:stCxn id="59" idx="2"/>
+            <a:endCxn id="128" idx="0"/>
+          </p:cNvCxnSpPr>
+          <p:nvPr/>
+        </p:nvCxnSpPr>
+        <p:spPr>
+          <a:xfrm>
+            <a:off x="10984086" y="15785736"/>
+            <a:ext cx="343979" cy="306261"/>
+          </a:xfrm>
+          <a:prstGeom prst="straightConnector1">
+            <a:avLst/>
+          </a:prstGeom>
+          <a:ln w="9525">
+            <a:solidFill>
+              <a:schemeClr val="tx2"/>
+            </a:solidFill>
+            <a:tailEnd type="triangle"/>
+          </a:ln>
+        </p:spPr>
+        <p:style>
+          <a:lnRef idx="1">
+            <a:schemeClr val="accent1"/>
+          </a:lnRef>
+          <a:fillRef idx="0">
+            <a:schemeClr val="accent1"/>
+          </a:fillRef>
+          <a:effectRef idx="0">
+            <a:schemeClr val="accent1"/>
+          </a:effectRef>
+          <a:fontRef idx="minor">
+            <a:schemeClr val="tx1"/>
+          </a:fontRef>
+        </p:style>
+      </p:cxnSp>
     </p:spTree>
     <p:extLst>
       <p:ext uri="{BB962C8B-B14F-4D97-AF65-F5344CB8AC3E}">

</xml_diff>

<commit_message>
doc: update decision tree to include Multi-Predict-Then-Debias branch (#378)
Co-authored-by: Claude Sonnet 5 <noreply@anthropic.com>
</commit_message>
<xml_diff>
--- a/docs/assets/glide-decision-tree.pptx
+++ b/docs/assets/glide-decision-tree.pptx
@@ -1062,7 +1062,7 @@
           <a:p>
             <a:fld id="{554093C4-DEE1-4C4E-AC4A-8D017280FD94}" type="datetimeFigureOut">
               <a:rPr lang="nl-NL" smtClean="0"/>
-              <a:t>25-06-2026</a:t>
+              <a:t>27-07-2026</a:t>
             </a:fld>
             <a:endParaRPr lang="nl-NL"/>
           </a:p>
@@ -1255,7 +1255,7 @@
           <a:p>
             <a:fld id="{68674519-6056-489F-B3DD-67FB69B5B4F9}" type="datetimeFigureOut">
               <a:rPr lang="en-GB" smtClean="0"/>
-              <a:t>25/06/2026</a:t>
+              <a:t>27/07/2026</a:t>
             </a:fld>
             <a:endParaRPr lang="en-GB"/>
           </a:p>
@@ -2127,8 +2127,8 @@
         </p:nvSpPr>
         <p:spPr>
           <a:xfrm>
-            <a:off x="5492037" y="13944293"/>
-            <a:ext cx="7484067" cy="2888533"/>
+            <a:off x="5492038" y="13944293"/>
+            <a:ext cx="7658126" cy="2888533"/>
           </a:xfrm>
           <a:prstGeom prst="rect">
             <a:avLst/>
@@ -2186,8 +2186,8 @@
         </p:nvSpPr>
         <p:spPr>
           <a:xfrm>
-            <a:off x="5492037" y="9586292"/>
-            <a:ext cx="7484067" cy="3945051"/>
+            <a:off x="5492038" y="9586292"/>
+            <a:ext cx="7658126" cy="3945051"/>
           </a:xfrm>
           <a:prstGeom prst="rect">
             <a:avLst/>
@@ -2373,7 +2373,7 @@
         </p:nvSpPr>
         <p:spPr>
           <a:xfrm>
-            <a:off x="7194413" y="10467948"/>
+            <a:off x="7194413" y="10467947"/>
             <a:ext cx="1087913" cy="548640"/>
           </a:xfrm>
           <a:prstGeom prst="rect">
@@ -2579,8 +2579,8 @@
         </p:nvCxnSpPr>
         <p:spPr>
           <a:xfrm flipH="1">
-            <a:off x="7223346" y="11016588"/>
-            <a:ext cx="515024" cy="1864639"/>
+            <a:off x="7223346" y="11016587"/>
+            <a:ext cx="515024" cy="1864640"/>
           </a:xfrm>
           <a:prstGeom prst="straightConnector1">
             <a:avLst/>
@@ -2625,7 +2625,7 @@
         </p:nvCxnSpPr>
         <p:spPr>
           <a:xfrm>
-            <a:off x="7738370" y="11016588"/>
+            <a:off x="7738370" y="11016587"/>
             <a:ext cx="1196317" cy="255786"/>
           </a:xfrm>
           <a:prstGeom prst="straightConnector1">
@@ -2671,8 +2671,8 @@
         </p:nvCxnSpPr>
         <p:spPr>
           <a:xfrm flipH="1">
-            <a:off x="8253393" y="11821014"/>
-            <a:ext cx="681294" cy="1060213"/>
+            <a:off x="8253393" y="11821013"/>
+            <a:ext cx="681294" cy="1060214"/>
           </a:xfrm>
           <a:prstGeom prst="straightConnector1">
             <a:avLst/>
@@ -2717,8 +2717,8 @@
         </p:nvCxnSpPr>
         <p:spPr>
           <a:xfrm>
-            <a:off x="8934687" y="11821014"/>
-            <a:ext cx="1368625" cy="255786"/>
+            <a:off x="8934687" y="11821013"/>
+            <a:ext cx="1710128" cy="255787"/>
           </a:xfrm>
           <a:prstGeom prst="straightConnector1">
             <a:avLst/>
@@ -2764,7 +2764,7 @@
         <p:spPr>
           <a:xfrm>
             <a:off x="6989112" y="10212161"/>
-            <a:ext cx="749258" cy="255787"/>
+            <a:ext cx="749258" cy="255786"/>
           </a:xfrm>
           <a:prstGeom prst="straightConnector1">
             <a:avLst/>
@@ -2805,7 +2805,7 @@
         </p:nvSpPr>
         <p:spPr>
           <a:xfrm>
-            <a:off x="8390730" y="11272374"/>
+            <a:off x="8390730" y="11272373"/>
             <a:ext cx="1087913" cy="548640"/>
           </a:xfrm>
           <a:prstGeom prst="rect">
@@ -2869,7 +2869,7 @@
         </p:nvSpPr>
         <p:spPr>
           <a:xfrm>
-            <a:off x="10678580" y="12881227"/>
+            <a:off x="11361587" y="12881227"/>
             <a:ext cx="618087" cy="550255"/>
           </a:xfrm>
           <a:prstGeom prst="rect">
@@ -2915,199 +2915,6 @@
                 </a:solidFill>
               </a:rPr>
               <a:t>Uniform Sampler</a:t>
-            </a:r>
-          </a:p>
-        </p:txBody>
-      </p:sp>
-      <p:sp>
-        <p:nvSpPr>
-          <p:cNvPr id="18" name="Rectangle 17">
-            <a:extLst>
-              <a:ext uri="{FF2B5EF4-FFF2-40B4-BE49-F238E27FC236}">
-                <a16:creationId xmlns:a16="http://schemas.microsoft.com/office/drawing/2014/main" id="{8C0A3CA3-7E77-168F-07DD-94AF2A1E042A}"/>
-              </a:ext>
-            </a:extLst>
-          </p:cNvPr>
-          <p:cNvSpPr/>
-          <p:nvPr/>
-        </p:nvSpPr>
-        <p:spPr>
-          <a:xfrm>
-            <a:off x="11443786" y="16091997"/>
-            <a:ext cx="618087" cy="550255"/>
-          </a:xfrm>
-          <a:prstGeom prst="rect">
-            <a:avLst/>
-          </a:prstGeom>
-          <a:solidFill>
-            <a:schemeClr val="accent3">
-              <a:lumMod val="20000"/>
-              <a:lumOff val="80000"/>
-            </a:schemeClr>
-          </a:solidFill>
-          <a:ln>
-            <a:solidFill>
-              <a:schemeClr val="tx1"/>
-            </a:solidFill>
-          </a:ln>
-        </p:spPr>
-        <p:style>
-          <a:lnRef idx="2">
-            <a:schemeClr val="accent1">
-              <a:shade val="50000"/>
-            </a:schemeClr>
-          </a:lnRef>
-          <a:fillRef idx="1">
-            <a:schemeClr val="accent1"/>
-          </a:fillRef>
-          <a:effectRef idx="0">
-            <a:schemeClr val="accent1"/>
-          </a:effectRef>
-          <a:fontRef idx="minor">
-            <a:schemeClr val="lt1"/>
-          </a:fontRef>
-        </p:style>
-        <p:txBody>
-          <a:bodyPr lIns="72000" tIns="72000" rIns="72000" bIns="72000" rtlCol="0" anchor="ctr" anchorCtr="0"/>
-          <a:lstStyle/>
-          <a:p>
-            <a:pPr algn="ctr"/>
-            <a:r>
-              <a:rPr lang="en-US" sz="900" b="1">
-                <a:solidFill>
-                  <a:schemeClr val="tx1"/>
-                </a:solidFill>
-              </a:rPr>
-              <a:t>PPI++</a:t>
-            </a:r>
-          </a:p>
-        </p:txBody>
-      </p:sp>
-      <p:sp>
-        <p:nvSpPr>
-          <p:cNvPr id="19" name="Rectangle 18">
-            <a:extLst>
-              <a:ext uri="{FF2B5EF4-FFF2-40B4-BE49-F238E27FC236}">
-                <a16:creationId xmlns:a16="http://schemas.microsoft.com/office/drawing/2014/main" id="{6C2C49B0-B5A7-FA43-E23D-18CADD1633D1}"/>
-              </a:ext>
-            </a:extLst>
-          </p:cNvPr>
-          <p:cNvSpPr/>
-          <p:nvPr/>
-        </p:nvSpPr>
-        <p:spPr>
-          <a:xfrm>
-            <a:off x="12126978" y="16091997"/>
-            <a:ext cx="618087" cy="550255"/>
-          </a:xfrm>
-          <a:prstGeom prst="rect">
-            <a:avLst/>
-          </a:prstGeom>
-          <a:solidFill>
-            <a:schemeClr val="accent3">
-              <a:lumMod val="20000"/>
-              <a:lumOff val="80000"/>
-            </a:schemeClr>
-          </a:solidFill>
-          <a:ln>
-            <a:solidFill>
-              <a:schemeClr val="tx1"/>
-            </a:solidFill>
-            <a:prstDash val="solid"/>
-          </a:ln>
-        </p:spPr>
-        <p:style>
-          <a:lnRef idx="2">
-            <a:schemeClr val="accent1">
-              <a:shade val="50000"/>
-            </a:schemeClr>
-          </a:lnRef>
-          <a:fillRef idx="1">
-            <a:schemeClr val="accent1"/>
-          </a:fillRef>
-          <a:effectRef idx="0">
-            <a:schemeClr val="accent1"/>
-          </a:effectRef>
-          <a:fontRef idx="minor">
-            <a:schemeClr val="lt1"/>
-          </a:fontRef>
-        </p:style>
-        <p:txBody>
-          <a:bodyPr lIns="72000" tIns="72000" rIns="72000" bIns="72000" rtlCol="0" anchor="ctr" anchorCtr="0"/>
-          <a:lstStyle/>
-          <a:p>
-            <a:pPr algn="ctr"/>
-            <a:r>
-              <a:rPr lang="en-US" sz="900" b="1" dirty="0">
-                <a:solidFill>
-                  <a:schemeClr val="tx1"/>
-                </a:solidFill>
-              </a:rPr>
-              <a:t>Predict-Then-Debias</a:t>
-            </a:r>
-          </a:p>
-        </p:txBody>
-      </p:sp>
-      <p:sp>
-        <p:nvSpPr>
-          <p:cNvPr id="20" name="Rectangle 19">
-            <a:extLst>
-              <a:ext uri="{FF2B5EF4-FFF2-40B4-BE49-F238E27FC236}">
-                <a16:creationId xmlns:a16="http://schemas.microsoft.com/office/drawing/2014/main" id="{2DFA7926-41C5-7E1B-F41B-4ADF8018AA06}"/>
-              </a:ext>
-            </a:extLst>
-          </p:cNvPr>
-          <p:cNvSpPr/>
-          <p:nvPr/>
-        </p:nvSpPr>
-        <p:spPr>
-          <a:xfrm>
-            <a:off x="11550469" y="15237096"/>
-            <a:ext cx="1087913" cy="548640"/>
-          </a:xfrm>
-          <a:prstGeom prst="rect">
-            <a:avLst/>
-          </a:prstGeom>
-          <a:solidFill>
-            <a:schemeClr val="accent2">
-              <a:lumMod val="20000"/>
-              <a:lumOff val="80000"/>
-            </a:schemeClr>
-          </a:solidFill>
-          <a:ln>
-            <a:solidFill>
-              <a:schemeClr val="tx1"/>
-            </a:solidFill>
-          </a:ln>
-        </p:spPr>
-        <p:style>
-          <a:lnRef idx="2">
-            <a:schemeClr val="accent1">
-              <a:shade val="50000"/>
-            </a:schemeClr>
-          </a:lnRef>
-          <a:fillRef idx="1">
-            <a:schemeClr val="accent1"/>
-          </a:fillRef>
-          <a:effectRef idx="0">
-            <a:schemeClr val="accent1"/>
-          </a:effectRef>
-          <a:fontRef idx="minor">
-            <a:schemeClr val="lt1"/>
-          </a:fontRef>
-        </p:style>
-        <p:txBody>
-          <a:bodyPr lIns="72000" tIns="72000" rIns="72000" bIns="72000" rtlCol="0" anchor="ctr" anchorCtr="0"/>
-          <a:lstStyle/>
-          <a:p>
-            <a:pPr algn="ctr"/>
-            <a:r>
-              <a:rPr lang="en-US" sz="900" b="1" dirty="0">
-                <a:solidFill>
-                  <a:schemeClr val="tx1"/>
-                </a:solidFill>
-              </a:rPr>
-              <a:t>Do I have more than 50 human labels?</a:t>
             </a:r>
           </a:p>
         </p:txBody>
@@ -3863,6 +3670,199 @@
           </a:fontRef>
         </p:style>
       </p:cxnSp>
+      <p:sp>
+        <p:nvSpPr>
+          <p:cNvPr id="18" name="Rectangle 17">
+            <a:extLst>
+              <a:ext uri="{FF2B5EF4-FFF2-40B4-BE49-F238E27FC236}">
+                <a16:creationId xmlns:a16="http://schemas.microsoft.com/office/drawing/2014/main" id="{8C0A3CA3-7E77-168F-07DD-94AF2A1E042A}"/>
+              </a:ext>
+            </a:extLst>
+          </p:cNvPr>
+          <p:cNvSpPr/>
+          <p:nvPr/>
+        </p:nvSpPr>
+        <p:spPr>
+          <a:xfrm>
+            <a:off x="11699336" y="16091997"/>
+            <a:ext cx="618087" cy="550255"/>
+          </a:xfrm>
+          <a:prstGeom prst="rect">
+            <a:avLst/>
+          </a:prstGeom>
+          <a:solidFill>
+            <a:schemeClr val="accent3">
+              <a:lumMod val="20000"/>
+              <a:lumOff val="80000"/>
+            </a:schemeClr>
+          </a:solidFill>
+          <a:ln>
+            <a:solidFill>
+              <a:schemeClr val="tx1"/>
+            </a:solidFill>
+          </a:ln>
+        </p:spPr>
+        <p:style>
+          <a:lnRef idx="2">
+            <a:schemeClr val="accent1">
+              <a:shade val="50000"/>
+            </a:schemeClr>
+          </a:lnRef>
+          <a:fillRef idx="1">
+            <a:schemeClr val="accent1"/>
+          </a:fillRef>
+          <a:effectRef idx="0">
+            <a:schemeClr val="accent1"/>
+          </a:effectRef>
+          <a:fontRef idx="minor">
+            <a:schemeClr val="lt1"/>
+          </a:fontRef>
+        </p:style>
+        <p:txBody>
+          <a:bodyPr lIns="72000" tIns="72000" rIns="72000" bIns="72000" rtlCol="0" anchor="ctr" anchorCtr="0"/>
+          <a:lstStyle/>
+          <a:p>
+            <a:pPr algn="ctr"/>
+            <a:r>
+              <a:rPr lang="en-US" sz="900" b="1">
+                <a:solidFill>
+                  <a:schemeClr val="tx1"/>
+                </a:solidFill>
+              </a:rPr>
+              <a:t>PPI++</a:t>
+            </a:r>
+          </a:p>
+        </p:txBody>
+      </p:sp>
+      <p:sp>
+        <p:nvSpPr>
+          <p:cNvPr id="19" name="Rectangle 18">
+            <a:extLst>
+              <a:ext uri="{FF2B5EF4-FFF2-40B4-BE49-F238E27FC236}">
+                <a16:creationId xmlns:a16="http://schemas.microsoft.com/office/drawing/2014/main" id="{6C2C49B0-B5A7-FA43-E23D-18CADD1633D1}"/>
+              </a:ext>
+            </a:extLst>
+          </p:cNvPr>
+          <p:cNvSpPr/>
+          <p:nvPr/>
+        </p:nvSpPr>
+        <p:spPr>
+          <a:xfrm>
+            <a:off x="12384415" y="16091997"/>
+            <a:ext cx="618087" cy="550255"/>
+          </a:xfrm>
+          <a:prstGeom prst="rect">
+            <a:avLst/>
+          </a:prstGeom>
+          <a:solidFill>
+            <a:schemeClr val="accent3">
+              <a:lumMod val="20000"/>
+              <a:lumOff val="80000"/>
+            </a:schemeClr>
+          </a:solidFill>
+          <a:ln>
+            <a:solidFill>
+              <a:schemeClr val="tx1"/>
+            </a:solidFill>
+            <a:prstDash val="solid"/>
+          </a:ln>
+        </p:spPr>
+        <p:style>
+          <a:lnRef idx="2">
+            <a:schemeClr val="accent1">
+              <a:shade val="50000"/>
+            </a:schemeClr>
+          </a:lnRef>
+          <a:fillRef idx="1">
+            <a:schemeClr val="accent1"/>
+          </a:fillRef>
+          <a:effectRef idx="0">
+            <a:schemeClr val="accent1"/>
+          </a:effectRef>
+          <a:fontRef idx="minor">
+            <a:schemeClr val="lt1"/>
+          </a:fontRef>
+        </p:style>
+        <p:txBody>
+          <a:bodyPr lIns="72000" tIns="72000" rIns="72000" bIns="72000" rtlCol="0" anchor="ctr" anchorCtr="0"/>
+          <a:lstStyle/>
+          <a:p>
+            <a:pPr algn="ctr"/>
+            <a:r>
+              <a:rPr lang="en-US" sz="900" b="1" dirty="0">
+                <a:solidFill>
+                  <a:schemeClr val="tx1"/>
+                </a:solidFill>
+              </a:rPr>
+              <a:t>Predict-Then-Debias</a:t>
+            </a:r>
+          </a:p>
+        </p:txBody>
+      </p:sp>
+      <p:sp>
+        <p:nvSpPr>
+          <p:cNvPr id="20" name="Rectangle 19">
+            <a:extLst>
+              <a:ext uri="{FF2B5EF4-FFF2-40B4-BE49-F238E27FC236}">
+                <a16:creationId xmlns:a16="http://schemas.microsoft.com/office/drawing/2014/main" id="{2DFA7926-41C5-7E1B-F41B-4ADF8018AA06}"/>
+              </a:ext>
+            </a:extLst>
+          </p:cNvPr>
+          <p:cNvSpPr/>
+          <p:nvPr/>
+        </p:nvSpPr>
+        <p:spPr>
+          <a:xfrm>
+            <a:off x="11806962" y="15237096"/>
+            <a:ext cx="1087913" cy="548640"/>
+          </a:xfrm>
+          <a:prstGeom prst="rect">
+            <a:avLst/>
+          </a:prstGeom>
+          <a:solidFill>
+            <a:schemeClr val="accent2">
+              <a:lumMod val="20000"/>
+              <a:lumOff val="80000"/>
+            </a:schemeClr>
+          </a:solidFill>
+          <a:ln>
+            <a:solidFill>
+              <a:schemeClr val="tx1"/>
+            </a:solidFill>
+          </a:ln>
+        </p:spPr>
+        <p:style>
+          <a:lnRef idx="2">
+            <a:schemeClr val="accent1">
+              <a:shade val="50000"/>
+            </a:schemeClr>
+          </a:lnRef>
+          <a:fillRef idx="1">
+            <a:schemeClr val="accent1"/>
+          </a:fillRef>
+          <a:effectRef idx="0">
+            <a:schemeClr val="accent1"/>
+          </a:effectRef>
+          <a:fontRef idx="minor">
+            <a:schemeClr val="lt1"/>
+          </a:fontRef>
+        </p:style>
+        <p:txBody>
+          <a:bodyPr lIns="72000" tIns="72000" rIns="72000" bIns="72000" rtlCol="0" anchor="ctr" anchorCtr="0"/>
+          <a:lstStyle/>
+          <a:p>
+            <a:pPr algn="ctr"/>
+            <a:r>
+              <a:rPr lang="en-US" sz="900" b="1" dirty="0">
+                <a:solidFill>
+                  <a:schemeClr val="tx1"/>
+                </a:solidFill>
+              </a:rPr>
+              <a:t>Do I have more than 50 human labels?</a:t>
+            </a:r>
+          </a:p>
+        </p:txBody>
+      </p:sp>
       <p:cxnSp>
         <p:nvCxnSpPr>
           <p:cNvPr id="33" name="Straight Arrow Connector 32">
@@ -3881,8 +3881,8 @@
         </p:nvCxnSpPr>
         <p:spPr>
           <a:xfrm>
-            <a:off x="12094426" y="15785736"/>
-            <a:ext cx="341596" cy="306261"/>
+            <a:off x="12350919" y="15785736"/>
+            <a:ext cx="342540" cy="306261"/>
           </a:xfrm>
           <a:prstGeom prst="straightConnector1">
             <a:avLst/>
@@ -3927,8 +3927,8 @@
         </p:nvCxnSpPr>
         <p:spPr>
           <a:xfrm flipH="1">
-            <a:off x="11752830" y="15785736"/>
-            <a:ext cx="341596" cy="306261"/>
+            <a:off x="12008380" y="15785736"/>
+            <a:ext cx="342539" cy="306261"/>
           </a:xfrm>
           <a:prstGeom prst="straightConnector1">
             <a:avLst/>
@@ -4256,9 +4256,9 @@
           <p:nvPr/>
         </p:nvCxnSpPr>
         <p:spPr>
-          <a:xfrm>
-            <a:off x="10987624" y="13431482"/>
-            <a:ext cx="0" cy="802724"/>
+          <a:xfrm flipH="1">
+            <a:off x="11667502" y="13431482"/>
+            <a:ext cx="3129" cy="802724"/>
           </a:xfrm>
           <a:prstGeom prst="straightConnector1">
             <a:avLst/>
@@ -4525,8 +4525,8 @@
         </p:nvSpPr>
         <p:spPr>
           <a:xfrm>
-            <a:off x="5492038" y="9397059"/>
-            <a:ext cx="7484070" cy="154748"/>
+            <a:off x="5492037" y="9397059"/>
+            <a:ext cx="7658129" cy="154748"/>
           </a:xfrm>
           <a:prstGeom prst="rect">
             <a:avLst/>
@@ -4584,7 +4584,7 @@
         </p:nvSpPr>
         <p:spPr>
           <a:xfrm>
-            <a:off x="9759355" y="12076800"/>
+            <a:off x="10100858" y="12076800"/>
             <a:ext cx="1087913" cy="548640"/>
           </a:xfrm>
           <a:prstGeom prst="rect">
@@ -5050,7 +5050,7 @@
         <p:spPr>
           <a:xfrm flipH="1">
             <a:off x="9618999" y="12625440"/>
-            <a:ext cx="684313" cy="255787"/>
+            <a:ext cx="1025816" cy="255787"/>
           </a:xfrm>
           <a:prstGeom prst="straightConnector1">
             <a:avLst/>
@@ -5095,8 +5095,8 @@
         </p:nvCxnSpPr>
         <p:spPr>
           <a:xfrm>
-            <a:off x="10303312" y="12625440"/>
-            <a:ext cx="684312" cy="255787"/>
+            <a:off x="10644815" y="12625440"/>
+            <a:ext cx="1025816" cy="255787"/>
           </a:xfrm>
           <a:prstGeom prst="straightConnector1">
             <a:avLst/>
@@ -5125,10 +5125,10 @@
       </p:cxnSp>
       <p:sp>
         <p:nvSpPr>
-          <p:cNvPr id="50" name="Rectangle 49">
-            <a:extLst>
-              <a:ext uri="{FF2B5EF4-FFF2-40B4-BE49-F238E27FC236}">
-                <a16:creationId xmlns:a16="http://schemas.microsoft.com/office/drawing/2014/main" id="{7DD94F55-CC54-1638-8B4D-6D05B04412AF}"/>
+          <p:cNvPr id="60" name="Rectangle 59">
+            <a:extLst>
+              <a:ext uri="{FF2B5EF4-FFF2-40B4-BE49-F238E27FC236}">
+                <a16:creationId xmlns:a16="http://schemas.microsoft.com/office/drawing/2014/main" id="{8140010D-3E5C-ADE1-B301-73133EE59575}"/>
               </a:ext>
             </a:extLst>
           </p:cNvPr>
@@ -5137,72 +5137,7 @@
         </p:nvSpPr>
         <p:spPr>
           <a:xfrm>
-            <a:off x="10678580" y="16091997"/>
-            <a:ext cx="618087" cy="550255"/>
-          </a:xfrm>
-          <a:prstGeom prst="rect">
-            <a:avLst/>
-          </a:prstGeom>
-          <a:solidFill>
-            <a:schemeClr val="accent3">
-              <a:lumMod val="20000"/>
-              <a:lumOff val="80000"/>
-            </a:schemeClr>
-          </a:solidFill>
-          <a:ln>
-            <a:solidFill>
-              <a:schemeClr val="tx1"/>
-            </a:solidFill>
-            <a:prstDash val="solid"/>
-          </a:ln>
-        </p:spPr>
-        <p:style>
-          <a:lnRef idx="2">
-            <a:schemeClr val="accent1">
-              <a:shade val="50000"/>
-            </a:schemeClr>
-          </a:lnRef>
-          <a:fillRef idx="1">
-            <a:schemeClr val="accent1"/>
-          </a:fillRef>
-          <a:effectRef idx="0">
-            <a:schemeClr val="accent1"/>
-          </a:effectRef>
-          <a:fontRef idx="minor">
-            <a:schemeClr val="lt1"/>
-          </a:fontRef>
-        </p:style>
-        <p:txBody>
-          <a:bodyPr lIns="72000" tIns="72000" rIns="72000" bIns="72000" rtlCol="0" anchor="ctr" anchorCtr="0"/>
-          <a:lstStyle/>
-          <a:p>
-            <a:pPr algn="ctr"/>
-            <a:r>
-              <a:rPr lang="en-US" sz="900" b="1" dirty="0">
-                <a:solidFill>
-                  <a:schemeClr val="tx1"/>
-                </a:solidFill>
-              </a:rPr>
-              <a:t>Multi-PPI++</a:t>
-            </a:r>
-          </a:p>
-        </p:txBody>
-      </p:sp>
-      <p:sp>
-        <p:nvSpPr>
-          <p:cNvPr id="60" name="Rectangle 59">
-            <a:extLst>
-              <a:ext uri="{FF2B5EF4-FFF2-40B4-BE49-F238E27FC236}">
-                <a16:creationId xmlns:a16="http://schemas.microsoft.com/office/drawing/2014/main" id="{8140010D-3E5C-ADE1-B301-73133EE59575}"/>
-              </a:ext>
-            </a:extLst>
-          </p:cNvPr>
-          <p:cNvSpPr/>
-          <p:nvPr/>
-        </p:nvSpPr>
-        <p:spPr>
-          <a:xfrm>
-            <a:off x="10443667" y="14234206"/>
+            <a:off x="11123545" y="14234206"/>
             <a:ext cx="1087913" cy="548640"/>
           </a:xfrm>
           <a:prstGeom prst="rect">
@@ -5264,14 +5199,14 @@
           <p:cNvCxnSpPr>
             <a:cxnSpLocks/>
             <a:stCxn id="60" idx="2"/>
-            <a:endCxn id="50" idx="0"/>
+            <a:endCxn id="59" idx="0"/>
           </p:cNvCxnSpPr>
           <p:nvPr/>
         </p:nvCxnSpPr>
         <p:spPr>
-          <a:xfrm>
-            <a:off x="10987624" y="14782846"/>
-            <a:ext cx="0" cy="1309151"/>
+          <a:xfrm flipH="1">
+            <a:off x="10984086" y="14782846"/>
+            <a:ext cx="683416" cy="454250"/>
           </a:xfrm>
           <a:prstGeom prst="straightConnector1">
             <a:avLst/>
@@ -5316,8 +5251,8 @@
         </p:nvCxnSpPr>
         <p:spPr>
           <a:xfrm>
-            <a:off x="10987624" y="14782846"/>
-            <a:ext cx="1106802" cy="454250"/>
+            <a:off x="11667502" y="14782846"/>
+            <a:ext cx="683417" cy="454250"/>
           </a:xfrm>
           <a:prstGeom prst="straightConnector1">
             <a:avLst/>
@@ -5358,8 +5293,8 @@
         </p:nvSpPr>
         <p:spPr>
           <a:xfrm>
-            <a:off x="5492038" y="13565828"/>
-            <a:ext cx="7484070" cy="154748"/>
+            <a:off x="5492037" y="13565828"/>
+            <a:ext cx="7658129" cy="154748"/>
           </a:xfrm>
           <a:prstGeom prst="rect">
             <a:avLst/>
@@ -5419,8 +5354,8 @@
         </p:nvSpPr>
         <p:spPr>
           <a:xfrm>
-            <a:off x="5492038" y="13755061"/>
-            <a:ext cx="7484070" cy="154748"/>
+            <a:off x="5492037" y="13755061"/>
+            <a:ext cx="7658129" cy="154748"/>
           </a:xfrm>
           <a:prstGeom prst="rect">
             <a:avLst/>
@@ -5464,6 +5399,292 @@
           </a:p>
         </p:txBody>
       </p:sp>
+      <p:sp>
+        <p:nvSpPr>
+          <p:cNvPr id="50" name="Rectangle 49">
+            <a:extLst>
+              <a:ext uri="{FF2B5EF4-FFF2-40B4-BE49-F238E27FC236}">
+                <a16:creationId xmlns:a16="http://schemas.microsoft.com/office/drawing/2014/main" id="{7DD94F55-CC54-1638-8B4D-6D05B04412AF}"/>
+              </a:ext>
+            </a:extLst>
+          </p:cNvPr>
+          <p:cNvSpPr/>
+          <p:nvPr/>
+        </p:nvSpPr>
+        <p:spPr>
+          <a:xfrm>
+            <a:off x="10331063" y="16091997"/>
+            <a:ext cx="618087" cy="550255"/>
+          </a:xfrm>
+          <a:prstGeom prst="rect">
+            <a:avLst/>
+          </a:prstGeom>
+          <a:solidFill>
+            <a:schemeClr val="accent3">
+              <a:lumMod val="20000"/>
+              <a:lumOff val="80000"/>
+            </a:schemeClr>
+          </a:solidFill>
+          <a:ln>
+            <a:solidFill>
+              <a:schemeClr val="tx1"/>
+            </a:solidFill>
+            <a:prstDash val="solid"/>
+          </a:ln>
+        </p:spPr>
+        <p:style>
+          <a:lnRef idx="2">
+            <a:schemeClr val="accent1">
+              <a:shade val="50000"/>
+            </a:schemeClr>
+          </a:lnRef>
+          <a:fillRef idx="1">
+            <a:schemeClr val="accent1"/>
+          </a:fillRef>
+          <a:effectRef idx="0">
+            <a:schemeClr val="accent1"/>
+          </a:effectRef>
+          <a:fontRef idx="minor">
+            <a:schemeClr val="lt1"/>
+          </a:fontRef>
+        </p:style>
+        <p:txBody>
+          <a:bodyPr lIns="72000" tIns="72000" rIns="72000" bIns="72000" rtlCol="0" anchor="ctr" anchorCtr="0"/>
+          <a:lstStyle/>
+          <a:p>
+            <a:pPr algn="ctr"/>
+            <a:r>
+              <a:rPr lang="en-US" sz="900" b="1" dirty="0">
+                <a:solidFill>
+                  <a:schemeClr val="tx1"/>
+                </a:solidFill>
+              </a:rPr>
+              <a:t>Multi-PPI++</a:t>
+            </a:r>
+          </a:p>
+        </p:txBody>
+      </p:sp>
+      <p:sp>
+        <p:nvSpPr>
+          <p:cNvPr id="59" name="Rectangle 58">
+            <a:extLst>
+              <a:ext uri="{FF2B5EF4-FFF2-40B4-BE49-F238E27FC236}">
+                <a16:creationId xmlns:a16="http://schemas.microsoft.com/office/drawing/2014/main" id="{02F9FFA9-CDEB-EF97-BB4E-3708238FA809}"/>
+              </a:ext>
+            </a:extLst>
+          </p:cNvPr>
+          <p:cNvSpPr/>
+          <p:nvPr/>
+        </p:nvSpPr>
+        <p:spPr>
+          <a:xfrm>
+            <a:off x="10440129" y="15237096"/>
+            <a:ext cx="1087913" cy="548640"/>
+          </a:xfrm>
+          <a:prstGeom prst="rect">
+            <a:avLst/>
+          </a:prstGeom>
+          <a:solidFill>
+            <a:schemeClr val="accent2">
+              <a:lumMod val="20000"/>
+              <a:lumOff val="80000"/>
+            </a:schemeClr>
+          </a:solidFill>
+          <a:ln>
+            <a:solidFill>
+              <a:schemeClr val="tx1"/>
+            </a:solidFill>
+          </a:ln>
+        </p:spPr>
+        <p:style>
+          <a:lnRef idx="2">
+            <a:schemeClr val="accent1">
+              <a:shade val="50000"/>
+            </a:schemeClr>
+          </a:lnRef>
+          <a:fillRef idx="1">
+            <a:schemeClr val="accent1"/>
+          </a:fillRef>
+          <a:effectRef idx="0">
+            <a:schemeClr val="accent1"/>
+          </a:effectRef>
+          <a:fontRef idx="minor">
+            <a:schemeClr val="lt1"/>
+          </a:fontRef>
+        </p:style>
+        <p:txBody>
+          <a:bodyPr lIns="72000" tIns="72000" rIns="72000" bIns="72000" rtlCol="0" anchor="ctr" anchorCtr="0"/>
+          <a:lstStyle/>
+          <a:p>
+            <a:pPr algn="ctr"/>
+            <a:r>
+              <a:rPr lang="en-US" sz="900" b="1" dirty="0">
+                <a:solidFill>
+                  <a:schemeClr val="tx1"/>
+                </a:solidFill>
+              </a:rPr>
+              <a:t>Do I have more than 50 human labels?</a:t>
+            </a:r>
+          </a:p>
+        </p:txBody>
+      </p:sp>
+      <p:sp>
+        <p:nvSpPr>
+          <p:cNvPr id="128" name="Rectangle 127">
+            <a:extLst>
+              <a:ext uri="{FF2B5EF4-FFF2-40B4-BE49-F238E27FC236}">
+                <a16:creationId xmlns:a16="http://schemas.microsoft.com/office/drawing/2014/main" id="{3FEF0966-C11E-CDF7-E2B2-3FA3DD92D7F2}"/>
+              </a:ext>
+            </a:extLst>
+          </p:cNvPr>
+          <p:cNvSpPr/>
+          <p:nvPr/>
+        </p:nvSpPr>
+        <p:spPr>
+          <a:xfrm>
+            <a:off x="11019021" y="16091997"/>
+            <a:ext cx="618087" cy="550255"/>
+          </a:xfrm>
+          <a:prstGeom prst="rect">
+            <a:avLst/>
+          </a:prstGeom>
+          <a:solidFill>
+            <a:schemeClr val="accent3">
+              <a:lumMod val="20000"/>
+              <a:lumOff val="80000"/>
+            </a:schemeClr>
+          </a:solidFill>
+          <a:ln>
+            <a:solidFill>
+              <a:schemeClr val="tx1"/>
+            </a:solidFill>
+            <a:prstDash val="solid"/>
+          </a:ln>
+        </p:spPr>
+        <p:style>
+          <a:lnRef idx="2">
+            <a:schemeClr val="accent1">
+              <a:shade val="50000"/>
+            </a:schemeClr>
+          </a:lnRef>
+          <a:fillRef idx="1">
+            <a:schemeClr val="accent1"/>
+          </a:fillRef>
+          <a:effectRef idx="0">
+            <a:schemeClr val="accent1"/>
+          </a:effectRef>
+          <a:fontRef idx="minor">
+            <a:schemeClr val="lt1"/>
+          </a:fontRef>
+        </p:style>
+        <p:txBody>
+          <a:bodyPr lIns="72000" tIns="72000" rIns="72000" bIns="72000" rtlCol="0" anchor="ctr" anchorCtr="0"/>
+          <a:lstStyle/>
+          <a:p>
+            <a:pPr algn="ctr"/>
+            <a:r>
+              <a:rPr lang="en-US" sz="900" b="1" dirty="0">
+                <a:solidFill>
+                  <a:schemeClr val="tx1"/>
+                </a:solidFill>
+              </a:rPr>
+              <a:t>Multi-Predict-Then-Debias</a:t>
+            </a:r>
+          </a:p>
+        </p:txBody>
+      </p:sp>
+      <p:cxnSp>
+        <p:nvCxnSpPr>
+          <p:cNvPr id="129" name="Straight Arrow Connector 128">
+            <a:extLst>
+              <a:ext uri="{FF2B5EF4-FFF2-40B4-BE49-F238E27FC236}">
+                <a16:creationId xmlns:a16="http://schemas.microsoft.com/office/drawing/2014/main" id="{961E096D-DE7E-FE29-40E0-91EF44BA1E85}"/>
+              </a:ext>
+            </a:extLst>
+          </p:cNvPr>
+          <p:cNvCxnSpPr>
+            <a:cxnSpLocks/>
+            <a:stCxn id="59" idx="2"/>
+            <a:endCxn id="50" idx="0"/>
+          </p:cNvCxnSpPr>
+          <p:nvPr/>
+        </p:nvCxnSpPr>
+        <p:spPr>
+          <a:xfrm flipH="1">
+            <a:off x="10640107" y="15785736"/>
+            <a:ext cx="343979" cy="306261"/>
+          </a:xfrm>
+          <a:prstGeom prst="straightConnector1">
+            <a:avLst/>
+          </a:prstGeom>
+          <a:ln w="9525">
+            <a:solidFill>
+              <a:schemeClr val="accent3"/>
+            </a:solidFill>
+            <a:tailEnd type="triangle"/>
+          </a:ln>
+        </p:spPr>
+        <p:style>
+          <a:lnRef idx="1">
+            <a:schemeClr val="accent1"/>
+          </a:lnRef>
+          <a:fillRef idx="0">
+            <a:schemeClr val="accent1"/>
+          </a:fillRef>
+          <a:effectRef idx="0">
+            <a:schemeClr val="accent1"/>
+          </a:effectRef>
+          <a:fontRef idx="minor">
+            <a:schemeClr val="tx1"/>
+          </a:fontRef>
+        </p:style>
+      </p:cxnSp>
+      <p:cxnSp>
+        <p:nvCxnSpPr>
+          <p:cNvPr id="133" name="Straight Arrow Connector 132">
+            <a:extLst>
+              <a:ext uri="{FF2B5EF4-FFF2-40B4-BE49-F238E27FC236}">
+                <a16:creationId xmlns:a16="http://schemas.microsoft.com/office/drawing/2014/main" id="{C0768CA0-74A7-A965-FE46-F52DF08E0AEF}"/>
+              </a:ext>
+            </a:extLst>
+          </p:cNvPr>
+          <p:cNvCxnSpPr>
+            <a:cxnSpLocks/>
+            <a:stCxn id="59" idx="2"/>
+            <a:endCxn id="128" idx="0"/>
+          </p:cNvCxnSpPr>
+          <p:nvPr/>
+        </p:nvCxnSpPr>
+        <p:spPr>
+          <a:xfrm>
+            <a:off x="10984086" y="15785736"/>
+            <a:ext cx="343979" cy="306261"/>
+          </a:xfrm>
+          <a:prstGeom prst="straightConnector1">
+            <a:avLst/>
+          </a:prstGeom>
+          <a:ln w="9525">
+            <a:solidFill>
+              <a:schemeClr val="tx2"/>
+            </a:solidFill>
+            <a:tailEnd type="triangle"/>
+          </a:ln>
+        </p:spPr>
+        <p:style>
+          <a:lnRef idx="1">
+            <a:schemeClr val="accent1"/>
+          </a:lnRef>
+          <a:fillRef idx="0">
+            <a:schemeClr val="accent1"/>
+          </a:fillRef>
+          <a:effectRef idx="0">
+            <a:schemeClr val="accent1"/>
+          </a:effectRef>
+          <a:fontRef idx="minor">
+            <a:schemeClr val="tx1"/>
+          </a:fontRef>
+        </p:style>
+      </p:cxnSp>
     </p:spTree>
     <p:extLst>
       <p:ext uri="{BB962C8B-B14F-4D97-AF65-F5344CB8AC3E}">

</xml_diff>

<commit_message>
doc: rename monitor tutorials and add Phase 4 monitoring guide
Drop the _monitor suffix from tutorial notebook filenames and enrich
the tutorials overview with a Phase 4: Monitoring section mirroring
the sampler/estimator decision guide, linking the Asymptotic PPRM
tutorial and marking the other monitor variants as coming soon.

Co-Authored-By: Claude Sonnet 5 <noreply@anthropic.com>
</commit_message>
<xml_diff>
--- a/docs/assets/glide-decision-tree.pptx
+++ b/docs/assets/glide-decision-tree.pptx
@@ -1062,7 +1062,7 @@
           <a:p>
             <a:fld id="{554093C4-DEE1-4C4E-AC4A-8D017280FD94}" type="datetimeFigureOut">
               <a:rPr lang="nl-NL" smtClean="0"/>
-              <a:t>27-07-2026</a:t>
+              <a:t>31-07-2026</a:t>
             </a:fld>
             <a:endParaRPr lang="nl-NL"/>
           </a:p>
@@ -1255,7 +1255,7 @@
           <a:p>
             <a:fld id="{68674519-6056-489F-B3DD-67FB69B5B4F9}" type="datetimeFigureOut">
               <a:rPr lang="en-GB" smtClean="0"/>
-              <a:t>27/07/2026</a:t>
+              <a:t>31/07/2026</a:t>
             </a:fld>
             <a:endParaRPr lang="en-GB"/>
           </a:p>
@@ -2127,7 +2127,7 @@
         </p:nvSpPr>
         <p:spPr>
           <a:xfrm>
-            <a:off x="5492038" y="13944293"/>
+            <a:off x="5492038" y="13946062"/>
             <a:ext cx="7658126" cy="2888533"/>
           </a:xfrm>
           <a:prstGeom prst="rect">
@@ -2186,7 +2186,7 @@
         </p:nvSpPr>
         <p:spPr>
           <a:xfrm>
-            <a:off x="5492038" y="9586292"/>
+            <a:off x="5492038" y="9586734"/>
             <a:ext cx="7658126" cy="3945051"/>
           </a:xfrm>
           <a:prstGeom prst="rect">
@@ -2252,10 +2252,7 @@
             <a:avLst/>
           </a:prstGeom>
           <a:solidFill>
-            <a:schemeClr val="accent2">
-              <a:lumMod val="20000"/>
-              <a:lumOff val="80000"/>
-            </a:schemeClr>
+            <a:schemeClr val="bg1"/>
           </a:solidFill>
           <a:ln>
             <a:solidFill>
@@ -2316,10 +2313,7 @@
             <a:avLst/>
           </a:prstGeom>
           <a:solidFill>
-            <a:schemeClr val="accent2">
-              <a:lumMod val="20000"/>
-              <a:lumOff val="80000"/>
-            </a:schemeClr>
+            <a:schemeClr val="bg1"/>
           </a:solidFill>
           <a:ln>
             <a:solidFill>
@@ -2349,7 +2343,7 @@
           <a:p>
             <a:pPr algn="ctr"/>
             <a:r>
-              <a:rPr lang="en-US" sz="900" b="1">
+              <a:rPr lang="en-US" sz="900" b="1" dirty="0">
                 <a:solidFill>
                   <a:schemeClr val="tx1"/>
                 </a:solidFill>
@@ -2380,10 +2374,7 @@
             <a:avLst/>
           </a:prstGeom>
           <a:solidFill>
-            <a:schemeClr val="accent2">
-              <a:lumMod val="20000"/>
-              <a:lumOff val="80000"/>
-            </a:schemeClr>
+            <a:schemeClr val="bg1"/>
           </a:solidFill>
           <a:ln>
             <a:solidFill>
@@ -2812,10 +2803,7 @@
             <a:avLst/>
           </a:prstGeom>
           <a:solidFill>
-            <a:schemeClr val="accent2">
-              <a:lumMod val="20000"/>
-              <a:lumOff val="80000"/>
-            </a:schemeClr>
+            <a:schemeClr val="bg1"/>
           </a:solidFill>
           <a:ln>
             <a:solidFill>
@@ -2876,7 +2864,7 @@
             <a:avLst/>
           </a:prstGeom>
           <a:solidFill>
-            <a:schemeClr val="accent3">
+            <a:schemeClr val="accent5">
               <a:lumMod val="20000"/>
               <a:lumOff val="80000"/>
             </a:schemeClr>
@@ -2940,7 +2928,7 @@
             <a:avLst/>
           </a:prstGeom>
           <a:solidFill>
-            <a:schemeClr val="accent3">
+            <a:schemeClr val="accent5">
               <a:lumMod val="20000"/>
               <a:lumOff val="80000"/>
             </a:schemeClr>
@@ -3004,7 +2992,7 @@
             <a:avLst/>
           </a:prstGeom>
           <a:solidFill>
-            <a:schemeClr val="accent3">
+            <a:schemeClr val="accent5">
               <a:lumMod val="20000"/>
               <a:lumOff val="80000"/>
             </a:schemeClr>
@@ -3068,7 +3056,7 @@
             <a:avLst/>
           </a:prstGeom>
           <a:solidFill>
-            <a:schemeClr val="accent3">
+            <a:schemeClr val="accent5">
               <a:lumMod val="20000"/>
               <a:lumOff val="80000"/>
             </a:schemeClr>
@@ -3133,10 +3121,7 @@
             <a:avLst/>
           </a:prstGeom>
           <a:solidFill>
-            <a:schemeClr val="accent2">
-              <a:lumMod val="20000"/>
-              <a:lumOff val="80000"/>
-            </a:schemeClr>
+            <a:schemeClr val="bg1"/>
           </a:solidFill>
           <a:ln>
             <a:solidFill>
@@ -3213,7 +3198,7 @@
             <a:avLst/>
           </a:prstGeom>
           <a:solidFill>
-            <a:schemeClr val="accent3">
+            <a:schemeClr val="accent5">
               <a:lumMod val="20000"/>
               <a:lumOff val="80000"/>
             </a:schemeClr>
@@ -3277,7 +3262,7 @@
             <a:avLst/>
           </a:prstGeom>
           <a:solidFill>
-            <a:schemeClr val="accent3">
+            <a:schemeClr val="accent5">
               <a:lumMod val="20000"/>
               <a:lumOff val="80000"/>
             </a:schemeClr>
@@ -3342,7 +3327,7 @@
             <a:avLst/>
           </a:prstGeom>
           <a:solidFill>
-            <a:schemeClr val="accent3">
+            <a:schemeClr val="accent5">
               <a:lumMod val="20000"/>
               <a:lumOff val="80000"/>
             </a:schemeClr>
@@ -3406,7 +3391,7 @@
             <a:avLst/>
           </a:prstGeom>
           <a:solidFill>
-            <a:schemeClr val="accent3">
+            <a:schemeClr val="accent5">
               <a:lumMod val="20000"/>
               <a:lumOff val="80000"/>
             </a:schemeClr>
@@ -3439,7 +3424,7 @@
           <a:p>
             <a:pPr algn="ctr"/>
             <a:r>
-              <a:rPr lang="en-US" sz="900" b="1">
+              <a:rPr lang="en-US" sz="900" b="1" dirty="0">
                 <a:solidFill>
                   <a:schemeClr val="tx1"/>
                 </a:solidFill>
@@ -3470,7 +3455,7 @@
             <a:avLst/>
           </a:prstGeom>
           <a:solidFill>
-            <a:schemeClr val="accent3">
+            <a:schemeClr val="accent5">
               <a:lumMod val="20000"/>
               <a:lumOff val="80000"/>
             </a:schemeClr>
@@ -3535,10 +3520,7 @@
             <a:avLst/>
           </a:prstGeom>
           <a:solidFill>
-            <a:schemeClr val="accent2">
-              <a:lumMod val="20000"/>
-              <a:lumOff val="80000"/>
-            </a:schemeClr>
+            <a:schemeClr val="bg1"/>
           </a:solidFill>
           <a:ln>
             <a:solidFill>
@@ -3691,7 +3673,7 @@
             <a:avLst/>
           </a:prstGeom>
           <a:solidFill>
-            <a:schemeClr val="accent3">
+            <a:schemeClr val="accent5">
               <a:lumMod val="20000"/>
               <a:lumOff val="80000"/>
             </a:schemeClr>
@@ -3755,7 +3737,7 @@
             <a:avLst/>
           </a:prstGeom>
           <a:solidFill>
-            <a:schemeClr val="accent3">
+            <a:schemeClr val="accent5">
               <a:lumMod val="20000"/>
               <a:lumOff val="80000"/>
             </a:schemeClr>
@@ -3820,10 +3802,7 @@
             <a:avLst/>
           </a:prstGeom>
           <a:solidFill>
-            <a:schemeClr val="accent2">
-              <a:lumMod val="20000"/>
-              <a:lumOff val="80000"/>
-            </a:schemeClr>
+            <a:schemeClr val="bg1"/>
           </a:solidFill>
           <a:ln>
             <a:solidFill>
@@ -4591,10 +4570,7 @@
             <a:avLst/>
           </a:prstGeom>
           <a:solidFill>
-            <a:schemeClr val="accent2">
-              <a:lumMod val="20000"/>
-              <a:lumOff val="80000"/>
-            </a:schemeClr>
+            <a:schemeClr val="bg1"/>
           </a:solidFill>
           <a:ln>
             <a:solidFill>
@@ -4655,7 +4631,7 @@
             <a:avLst/>
           </a:prstGeom>
           <a:solidFill>
-            <a:schemeClr val="accent3">
+            <a:schemeClr val="accent5">
               <a:lumMod val="20000"/>
               <a:lumOff val="80000"/>
             </a:schemeClr>
@@ -4719,7 +4695,7 @@
             <a:avLst/>
           </a:prstGeom>
           <a:solidFill>
-            <a:schemeClr val="accent3">
+            <a:schemeClr val="accent5">
               <a:lumMod val="20000"/>
               <a:lumOff val="80000"/>
             </a:schemeClr>
@@ -4783,7 +4759,7 @@
             <a:avLst/>
           </a:prstGeom>
           <a:solidFill>
-            <a:schemeClr val="accent3">
+            <a:schemeClr val="accent5">
               <a:lumMod val="20000"/>
               <a:lumOff val="80000"/>
             </a:schemeClr>
@@ -4848,10 +4824,7 @@
             <a:avLst/>
           </a:prstGeom>
           <a:solidFill>
-            <a:schemeClr val="accent2">
-              <a:lumMod val="20000"/>
-              <a:lumOff val="80000"/>
-            </a:schemeClr>
+            <a:schemeClr val="bg1"/>
           </a:solidFill>
           <a:ln>
             <a:solidFill>
@@ -5144,10 +5117,7 @@
             <a:avLst/>
           </a:prstGeom>
           <a:solidFill>
-            <a:schemeClr val="accent2">
-              <a:lumMod val="20000"/>
-              <a:lumOff val="80000"/>
-            </a:schemeClr>
+            <a:schemeClr val="bg1"/>
           </a:solidFill>
           <a:ln>
             <a:solidFill>
@@ -5293,7 +5263,7 @@
         </p:nvSpPr>
         <p:spPr>
           <a:xfrm>
-            <a:off x="5492037" y="13565828"/>
+            <a:off x="5492037" y="13566712"/>
             <a:ext cx="7658129" cy="154748"/>
           </a:xfrm>
           <a:prstGeom prst="rect">
@@ -5354,7 +5324,7 @@
         </p:nvSpPr>
         <p:spPr>
           <a:xfrm>
-            <a:off x="5492037" y="13755061"/>
+            <a:off x="5492037" y="13756387"/>
             <a:ext cx="7658129" cy="154748"/>
           </a:xfrm>
           <a:prstGeom prst="rect">
@@ -5420,7 +5390,7 @@
             <a:avLst/>
           </a:prstGeom>
           <a:solidFill>
-            <a:schemeClr val="accent3">
+            <a:schemeClr val="accent5">
               <a:lumMod val="20000"/>
               <a:lumOff val="80000"/>
             </a:schemeClr>
@@ -5485,10 +5455,7 @@
             <a:avLst/>
           </a:prstGeom>
           <a:solidFill>
-            <a:schemeClr val="accent2">
-              <a:lumMod val="20000"/>
-              <a:lumOff val="80000"/>
-            </a:schemeClr>
+            <a:schemeClr val="bg1"/>
           </a:solidFill>
           <a:ln>
             <a:solidFill>
@@ -5549,7 +5516,7 @@
             <a:avLst/>
           </a:prstGeom>
           <a:solidFill>
-            <a:schemeClr val="accent3">
+            <a:schemeClr val="accent5">
               <a:lumMod val="20000"/>
               <a:lumOff val="80000"/>
             </a:schemeClr>
@@ -5685,6 +5652,715 @@
           </a:fontRef>
         </p:style>
       </p:cxnSp>
+      <p:sp>
+        <p:nvSpPr>
+          <p:cNvPr id="51" name="Rectangle 50">
+            <a:extLst>
+              <a:ext uri="{FF2B5EF4-FFF2-40B4-BE49-F238E27FC236}">
+                <a16:creationId xmlns:a16="http://schemas.microsoft.com/office/drawing/2014/main" id="{CDE1E9B7-2094-9028-92D6-7EA499C19555}"/>
+              </a:ext>
+            </a:extLst>
+          </p:cNvPr>
+          <p:cNvSpPr/>
+          <p:nvPr/>
+        </p:nvSpPr>
+        <p:spPr>
+          <a:xfrm>
+            <a:off x="5492038" y="17059198"/>
+            <a:ext cx="7658126" cy="1061386"/>
+          </a:xfrm>
+          <a:prstGeom prst="rect">
+            <a:avLst/>
+          </a:prstGeom>
+          <a:solidFill>
+            <a:schemeClr val="accent3">
+              <a:lumMod val="20000"/>
+              <a:lumOff val="80000"/>
+            </a:schemeClr>
+          </a:solidFill>
+          <a:ln>
+            <a:noFill/>
+          </a:ln>
+        </p:spPr>
+        <p:style>
+          <a:lnRef idx="2">
+            <a:schemeClr val="accent1">
+              <a:shade val="50000"/>
+            </a:schemeClr>
+          </a:lnRef>
+          <a:fillRef idx="1">
+            <a:schemeClr val="accent1"/>
+          </a:fillRef>
+          <a:effectRef idx="0">
+            <a:schemeClr val="accent1"/>
+          </a:effectRef>
+          <a:fontRef idx="minor">
+            <a:schemeClr val="lt1"/>
+          </a:fontRef>
+        </p:style>
+        <p:txBody>
+          <a:bodyPr lIns="72000" tIns="72000" rIns="72000" bIns="72000" rtlCol="0" anchor="ctr" anchorCtr="0"/>
+          <a:lstStyle/>
+          <a:p>
+            <a:pPr algn="l"/>
+            <a:endParaRPr lang="en-US" sz="1600">
+              <a:solidFill>
+                <a:schemeClr val="tx1"/>
+              </a:solidFill>
+            </a:endParaRPr>
+          </a:p>
+        </p:txBody>
+      </p:sp>
+      <p:sp>
+        <p:nvSpPr>
+          <p:cNvPr id="58" name="Rectangle 57">
+            <a:extLst>
+              <a:ext uri="{FF2B5EF4-FFF2-40B4-BE49-F238E27FC236}">
+                <a16:creationId xmlns:a16="http://schemas.microsoft.com/office/drawing/2014/main" id="{3E5AEB2D-2583-9EF4-DD6C-04DBC3762C3A}"/>
+              </a:ext>
+            </a:extLst>
+          </p:cNvPr>
+          <p:cNvSpPr/>
+          <p:nvPr/>
+        </p:nvSpPr>
+        <p:spPr>
+          <a:xfrm>
+            <a:off x="7599734" y="17335539"/>
+            <a:ext cx="618087" cy="550255"/>
+          </a:xfrm>
+          <a:prstGeom prst="rect">
+            <a:avLst/>
+          </a:prstGeom>
+          <a:solidFill>
+            <a:schemeClr val="accent5">
+              <a:lumMod val="20000"/>
+              <a:lumOff val="80000"/>
+            </a:schemeClr>
+          </a:solidFill>
+          <a:ln>
+            <a:solidFill>
+              <a:schemeClr val="tx1"/>
+            </a:solidFill>
+          </a:ln>
+        </p:spPr>
+        <p:style>
+          <a:lnRef idx="2">
+            <a:schemeClr val="accent1">
+              <a:shade val="50000"/>
+            </a:schemeClr>
+          </a:lnRef>
+          <a:fillRef idx="1">
+            <a:schemeClr val="accent1"/>
+          </a:fillRef>
+          <a:effectRef idx="0">
+            <a:schemeClr val="accent1"/>
+          </a:effectRef>
+          <a:fontRef idx="minor">
+            <a:schemeClr val="lt1"/>
+          </a:fontRef>
+        </p:style>
+        <p:txBody>
+          <a:bodyPr lIns="0" tIns="72000" rIns="0" bIns="72000" rtlCol="0" anchor="ctr" anchorCtr="0"/>
+          <a:lstStyle/>
+          <a:p>
+            <a:pPr algn="ctr"/>
+            <a:r>
+              <a:rPr lang="en-US" sz="900" b="1" dirty="0">
+                <a:solidFill>
+                  <a:schemeClr val="tx1"/>
+                </a:solidFill>
+              </a:rPr>
+              <a:t>Asymptotic Stratified PPRM</a:t>
+            </a:r>
+          </a:p>
+        </p:txBody>
+      </p:sp>
+      <p:sp>
+        <p:nvSpPr>
+          <p:cNvPr id="61" name="Rectangle 60">
+            <a:extLst>
+              <a:ext uri="{FF2B5EF4-FFF2-40B4-BE49-F238E27FC236}">
+                <a16:creationId xmlns:a16="http://schemas.microsoft.com/office/drawing/2014/main" id="{EEBDFA7E-7F4D-0D67-D3B7-B233B807F929}"/>
+              </a:ext>
+            </a:extLst>
+          </p:cNvPr>
+          <p:cNvSpPr/>
+          <p:nvPr/>
+        </p:nvSpPr>
+        <p:spPr>
+          <a:xfrm>
+            <a:off x="5879867" y="17335539"/>
+            <a:ext cx="618087" cy="550255"/>
+          </a:xfrm>
+          <a:prstGeom prst="rect">
+            <a:avLst/>
+          </a:prstGeom>
+          <a:solidFill>
+            <a:schemeClr val="accent5">
+              <a:lumMod val="20000"/>
+              <a:lumOff val="80000"/>
+            </a:schemeClr>
+          </a:solidFill>
+          <a:ln>
+            <a:solidFill>
+              <a:schemeClr val="tx1"/>
+            </a:solidFill>
+          </a:ln>
+        </p:spPr>
+        <p:style>
+          <a:lnRef idx="2">
+            <a:schemeClr val="accent1">
+              <a:shade val="50000"/>
+            </a:schemeClr>
+          </a:lnRef>
+          <a:fillRef idx="1">
+            <a:schemeClr val="accent1"/>
+          </a:fillRef>
+          <a:effectRef idx="0">
+            <a:schemeClr val="accent1"/>
+          </a:effectRef>
+          <a:fontRef idx="minor">
+            <a:schemeClr val="lt1"/>
+          </a:fontRef>
+        </p:style>
+        <p:txBody>
+          <a:bodyPr lIns="0" tIns="72000" rIns="0" bIns="72000" rtlCol="0" anchor="ctr" anchorCtr="0"/>
+          <a:lstStyle/>
+          <a:p>
+            <a:pPr algn="ctr"/>
+            <a:r>
+              <a:rPr lang="en-US" sz="900" b="1" dirty="0">
+                <a:solidFill>
+                  <a:schemeClr val="tx1"/>
+                </a:solidFill>
+              </a:rPr>
+              <a:t>Asymptotic Active PPRM</a:t>
+            </a:r>
+          </a:p>
+        </p:txBody>
+      </p:sp>
+      <p:sp>
+        <p:nvSpPr>
+          <p:cNvPr id="63" name="Rectangle 62">
+            <a:extLst>
+              <a:ext uri="{FF2B5EF4-FFF2-40B4-BE49-F238E27FC236}">
+                <a16:creationId xmlns:a16="http://schemas.microsoft.com/office/drawing/2014/main" id="{CFC49BE5-945A-B18F-5C94-B2EB33937D6E}"/>
+              </a:ext>
+            </a:extLst>
+          </p:cNvPr>
+          <p:cNvSpPr/>
+          <p:nvPr/>
+        </p:nvSpPr>
+        <p:spPr>
+          <a:xfrm>
+            <a:off x="11699336" y="17335539"/>
+            <a:ext cx="618087" cy="550255"/>
+          </a:xfrm>
+          <a:prstGeom prst="rect">
+            <a:avLst/>
+          </a:prstGeom>
+          <a:solidFill>
+            <a:schemeClr val="accent5">
+              <a:lumMod val="20000"/>
+              <a:lumOff val="80000"/>
+            </a:schemeClr>
+          </a:solidFill>
+          <a:ln>
+            <a:solidFill>
+              <a:schemeClr val="tx1"/>
+            </a:solidFill>
+          </a:ln>
+        </p:spPr>
+        <p:style>
+          <a:lnRef idx="2">
+            <a:schemeClr val="accent1">
+              <a:shade val="50000"/>
+            </a:schemeClr>
+          </a:lnRef>
+          <a:fillRef idx="1">
+            <a:schemeClr val="accent1"/>
+          </a:fillRef>
+          <a:effectRef idx="0">
+            <a:schemeClr val="accent1"/>
+          </a:effectRef>
+          <a:fontRef idx="minor">
+            <a:schemeClr val="lt1"/>
+          </a:fontRef>
+        </p:style>
+        <p:txBody>
+          <a:bodyPr lIns="0" tIns="72000" rIns="0" bIns="72000" rtlCol="0" anchor="ctr" anchorCtr="0"/>
+          <a:lstStyle/>
+          <a:p>
+            <a:pPr algn="ctr"/>
+            <a:r>
+              <a:rPr lang="en-US" sz="900" b="1" dirty="0">
+                <a:solidFill>
+                  <a:schemeClr val="tx1"/>
+                </a:solidFill>
+              </a:rPr>
+              <a:t>Asymptotic PPRM</a:t>
+            </a:r>
+          </a:p>
+        </p:txBody>
+      </p:sp>
+      <p:sp>
+        <p:nvSpPr>
+          <p:cNvPr id="130" name="Rectangle 129">
+            <a:extLst>
+              <a:ext uri="{FF2B5EF4-FFF2-40B4-BE49-F238E27FC236}">
+                <a16:creationId xmlns:a16="http://schemas.microsoft.com/office/drawing/2014/main" id="{68ABB4DD-8D1F-E320-631E-A9AB8E960132}"/>
+              </a:ext>
+            </a:extLst>
+          </p:cNvPr>
+          <p:cNvSpPr/>
+          <p:nvPr/>
+        </p:nvSpPr>
+        <p:spPr>
+          <a:xfrm>
+            <a:off x="8968359" y="17335539"/>
+            <a:ext cx="618087" cy="550255"/>
+          </a:xfrm>
+          <a:prstGeom prst="rect">
+            <a:avLst/>
+          </a:prstGeom>
+          <a:solidFill>
+            <a:schemeClr val="accent5">
+              <a:lumMod val="20000"/>
+              <a:lumOff val="80000"/>
+            </a:schemeClr>
+          </a:solidFill>
+          <a:ln>
+            <a:solidFill>
+              <a:schemeClr val="tx1"/>
+            </a:solidFill>
+          </a:ln>
+        </p:spPr>
+        <p:style>
+          <a:lnRef idx="2">
+            <a:schemeClr val="accent1">
+              <a:shade val="50000"/>
+            </a:schemeClr>
+          </a:lnRef>
+          <a:fillRef idx="1">
+            <a:schemeClr val="accent1"/>
+          </a:fillRef>
+          <a:effectRef idx="0">
+            <a:schemeClr val="accent1"/>
+          </a:effectRef>
+          <a:fontRef idx="minor">
+            <a:schemeClr val="lt1"/>
+          </a:fontRef>
+        </p:style>
+        <p:txBody>
+          <a:bodyPr lIns="0" tIns="72000" rIns="0" bIns="72000" rtlCol="0" anchor="ctr" anchorCtr="0"/>
+          <a:lstStyle/>
+          <a:p>
+            <a:pPr algn="ctr"/>
+            <a:r>
+              <a:rPr lang="en-US" sz="900" b="1" dirty="0">
+                <a:solidFill>
+                  <a:schemeClr val="tx1"/>
+                </a:solidFill>
+              </a:rPr>
+              <a:t>Asymptotic Clustered PPRM</a:t>
+            </a:r>
+          </a:p>
+        </p:txBody>
+      </p:sp>
+      <p:sp>
+        <p:nvSpPr>
+          <p:cNvPr id="131" name="Rectangle 130">
+            <a:extLst>
+              <a:ext uri="{FF2B5EF4-FFF2-40B4-BE49-F238E27FC236}">
+                <a16:creationId xmlns:a16="http://schemas.microsoft.com/office/drawing/2014/main" id="{8B9B2A1A-E06D-6FD6-FCA4-DD838EABE39F}"/>
+              </a:ext>
+            </a:extLst>
+          </p:cNvPr>
+          <p:cNvSpPr/>
+          <p:nvPr/>
+        </p:nvSpPr>
+        <p:spPr>
+          <a:xfrm>
+            <a:off x="10331063" y="17335539"/>
+            <a:ext cx="618087" cy="550255"/>
+          </a:xfrm>
+          <a:prstGeom prst="rect">
+            <a:avLst/>
+          </a:prstGeom>
+          <a:solidFill>
+            <a:schemeClr val="accent5">
+              <a:lumMod val="20000"/>
+              <a:lumOff val="80000"/>
+            </a:schemeClr>
+          </a:solidFill>
+          <a:ln>
+            <a:solidFill>
+              <a:schemeClr val="tx1"/>
+            </a:solidFill>
+            <a:prstDash val="solid"/>
+          </a:ln>
+        </p:spPr>
+        <p:style>
+          <a:lnRef idx="2">
+            <a:schemeClr val="accent1">
+              <a:shade val="50000"/>
+            </a:schemeClr>
+          </a:lnRef>
+          <a:fillRef idx="1">
+            <a:schemeClr val="accent1"/>
+          </a:fillRef>
+          <a:effectRef idx="0">
+            <a:schemeClr val="accent1"/>
+          </a:effectRef>
+          <a:fontRef idx="minor">
+            <a:schemeClr val="lt1"/>
+          </a:fontRef>
+        </p:style>
+        <p:txBody>
+          <a:bodyPr lIns="0" tIns="72000" rIns="0" bIns="72000" rtlCol="0" anchor="ctr" anchorCtr="0"/>
+          <a:lstStyle/>
+          <a:p>
+            <a:pPr algn="ctr"/>
+            <a:r>
+              <a:rPr lang="en-US" sz="900" b="1" dirty="0">
+                <a:solidFill>
+                  <a:schemeClr val="tx1"/>
+                </a:solidFill>
+              </a:rPr>
+              <a:t>Asymptotic Multi-PPRM</a:t>
+            </a:r>
+          </a:p>
+        </p:txBody>
+      </p:sp>
+      <p:cxnSp>
+        <p:nvCxnSpPr>
+          <p:cNvPr id="136" name="Straight Arrow Connector 135">
+            <a:extLst>
+              <a:ext uri="{FF2B5EF4-FFF2-40B4-BE49-F238E27FC236}">
+                <a16:creationId xmlns:a16="http://schemas.microsoft.com/office/drawing/2014/main" id="{97948AC6-5DB3-2F50-7816-8350484616D8}"/>
+              </a:ext>
+            </a:extLst>
+          </p:cNvPr>
+          <p:cNvCxnSpPr>
+            <a:cxnSpLocks/>
+            <a:stCxn id="18" idx="2"/>
+            <a:endCxn id="63" idx="0"/>
+          </p:cNvCxnSpPr>
+          <p:nvPr/>
+        </p:nvCxnSpPr>
+        <p:spPr>
+          <a:xfrm>
+            <a:off x="12008380" y="16642252"/>
+            <a:ext cx="0" cy="693287"/>
+          </a:xfrm>
+          <a:prstGeom prst="straightConnector1">
+            <a:avLst/>
+          </a:prstGeom>
+          <a:ln w="9525">
+            <a:solidFill>
+              <a:schemeClr val="accent6">
+                <a:lumMod val="50000"/>
+              </a:schemeClr>
+            </a:solidFill>
+            <a:tailEnd type="triangle"/>
+          </a:ln>
+        </p:spPr>
+        <p:style>
+          <a:lnRef idx="1">
+            <a:schemeClr val="accent1"/>
+          </a:lnRef>
+          <a:fillRef idx="0">
+            <a:schemeClr val="accent1"/>
+          </a:fillRef>
+          <a:effectRef idx="0">
+            <a:schemeClr val="accent1"/>
+          </a:effectRef>
+          <a:fontRef idx="minor">
+            <a:schemeClr val="tx1"/>
+          </a:fontRef>
+        </p:style>
+      </p:cxnSp>
+      <p:cxnSp>
+        <p:nvCxnSpPr>
+          <p:cNvPr id="146" name="Straight Arrow Connector 145">
+            <a:extLst>
+              <a:ext uri="{FF2B5EF4-FFF2-40B4-BE49-F238E27FC236}">
+                <a16:creationId xmlns:a16="http://schemas.microsoft.com/office/drawing/2014/main" id="{6A7FED52-3B10-CBB4-9AC1-4B410794DC44}"/>
+              </a:ext>
+            </a:extLst>
+          </p:cNvPr>
+          <p:cNvCxnSpPr>
+            <a:cxnSpLocks/>
+            <a:stCxn id="50" idx="2"/>
+            <a:endCxn id="131" idx="0"/>
+          </p:cNvCxnSpPr>
+          <p:nvPr/>
+        </p:nvCxnSpPr>
+        <p:spPr>
+          <a:xfrm>
+            <a:off x="10640107" y="16642252"/>
+            <a:ext cx="0" cy="693287"/>
+          </a:xfrm>
+          <a:prstGeom prst="straightConnector1">
+            <a:avLst/>
+          </a:prstGeom>
+          <a:ln w="9525">
+            <a:solidFill>
+              <a:schemeClr val="accent6">
+                <a:lumMod val="50000"/>
+              </a:schemeClr>
+            </a:solidFill>
+            <a:tailEnd type="triangle"/>
+          </a:ln>
+        </p:spPr>
+        <p:style>
+          <a:lnRef idx="1">
+            <a:schemeClr val="accent1"/>
+          </a:lnRef>
+          <a:fillRef idx="0">
+            <a:schemeClr val="accent1"/>
+          </a:fillRef>
+          <a:effectRef idx="0">
+            <a:schemeClr val="accent1"/>
+          </a:effectRef>
+          <a:fontRef idx="minor">
+            <a:schemeClr val="tx1"/>
+          </a:fontRef>
+        </p:style>
+      </p:cxnSp>
+      <p:cxnSp>
+        <p:nvCxnSpPr>
+          <p:cNvPr id="150" name="Straight Arrow Connector 149">
+            <a:extLst>
+              <a:ext uri="{FF2B5EF4-FFF2-40B4-BE49-F238E27FC236}">
+                <a16:creationId xmlns:a16="http://schemas.microsoft.com/office/drawing/2014/main" id="{5FDBF186-46B7-9868-C25D-8430E73A6D53}"/>
+              </a:ext>
+            </a:extLst>
+          </p:cNvPr>
+          <p:cNvCxnSpPr>
+            <a:cxnSpLocks/>
+            <a:stCxn id="140" idx="2"/>
+            <a:endCxn id="130" idx="0"/>
+          </p:cNvCxnSpPr>
+          <p:nvPr/>
+        </p:nvCxnSpPr>
+        <p:spPr>
+          <a:xfrm>
+            <a:off x="9277403" y="16642252"/>
+            <a:ext cx="0" cy="693287"/>
+          </a:xfrm>
+          <a:prstGeom prst="straightConnector1">
+            <a:avLst/>
+          </a:prstGeom>
+          <a:ln w="9525">
+            <a:solidFill>
+              <a:schemeClr val="accent6">
+                <a:lumMod val="50000"/>
+              </a:schemeClr>
+            </a:solidFill>
+            <a:tailEnd type="triangle"/>
+          </a:ln>
+        </p:spPr>
+        <p:style>
+          <a:lnRef idx="1">
+            <a:schemeClr val="accent1"/>
+          </a:lnRef>
+          <a:fillRef idx="0">
+            <a:schemeClr val="accent1"/>
+          </a:fillRef>
+          <a:effectRef idx="0">
+            <a:schemeClr val="accent1"/>
+          </a:effectRef>
+          <a:fontRef idx="minor">
+            <a:schemeClr val="tx1"/>
+          </a:fontRef>
+        </p:style>
+      </p:cxnSp>
+      <p:cxnSp>
+        <p:nvCxnSpPr>
+          <p:cNvPr id="154" name="Straight Arrow Connector 153">
+            <a:extLst>
+              <a:ext uri="{FF2B5EF4-FFF2-40B4-BE49-F238E27FC236}">
+                <a16:creationId xmlns:a16="http://schemas.microsoft.com/office/drawing/2014/main" id="{9EE24596-8FB1-2F5E-A6B7-8F4554B78FC4}"/>
+              </a:ext>
+            </a:extLst>
+          </p:cNvPr>
+          <p:cNvCxnSpPr>
+            <a:cxnSpLocks/>
+            <a:stCxn id="22" idx="2"/>
+            <a:endCxn id="58" idx="0"/>
+          </p:cNvCxnSpPr>
+          <p:nvPr/>
+        </p:nvCxnSpPr>
+        <p:spPr>
+          <a:xfrm>
+            <a:off x="7908778" y="16642252"/>
+            <a:ext cx="0" cy="693287"/>
+          </a:xfrm>
+          <a:prstGeom prst="straightConnector1">
+            <a:avLst/>
+          </a:prstGeom>
+          <a:ln w="9525">
+            <a:solidFill>
+              <a:schemeClr val="accent6">
+                <a:lumMod val="50000"/>
+              </a:schemeClr>
+            </a:solidFill>
+            <a:tailEnd type="triangle"/>
+          </a:ln>
+        </p:spPr>
+        <p:style>
+          <a:lnRef idx="1">
+            <a:schemeClr val="accent1"/>
+          </a:lnRef>
+          <a:fillRef idx="0">
+            <a:schemeClr val="accent1"/>
+          </a:fillRef>
+          <a:effectRef idx="0">
+            <a:schemeClr val="accent1"/>
+          </a:effectRef>
+          <a:fontRef idx="minor">
+            <a:schemeClr val="tx1"/>
+          </a:fontRef>
+        </p:style>
+      </p:cxnSp>
+      <p:cxnSp>
+        <p:nvCxnSpPr>
+          <p:cNvPr id="157" name="Straight Arrow Connector 156">
+            <a:extLst>
+              <a:ext uri="{FF2B5EF4-FFF2-40B4-BE49-F238E27FC236}">
+                <a16:creationId xmlns:a16="http://schemas.microsoft.com/office/drawing/2014/main" id="{582BFE6B-3E7B-123F-5F42-B0AEE625B3C2}"/>
+              </a:ext>
+            </a:extLst>
+          </p:cNvPr>
+          <p:cNvCxnSpPr>
+            <a:cxnSpLocks/>
+            <a:stCxn id="28" idx="2"/>
+            <a:endCxn id="61" idx="0"/>
+          </p:cNvCxnSpPr>
+          <p:nvPr/>
+        </p:nvCxnSpPr>
+        <p:spPr>
+          <a:xfrm>
+            <a:off x="6188911" y="16642252"/>
+            <a:ext cx="0" cy="693287"/>
+          </a:xfrm>
+          <a:prstGeom prst="straightConnector1">
+            <a:avLst/>
+          </a:prstGeom>
+          <a:ln w="9525">
+            <a:solidFill>
+              <a:schemeClr val="accent6">
+                <a:lumMod val="50000"/>
+              </a:schemeClr>
+            </a:solidFill>
+            <a:tailEnd type="triangle"/>
+          </a:ln>
+        </p:spPr>
+        <p:style>
+          <a:lnRef idx="1">
+            <a:schemeClr val="accent1"/>
+          </a:lnRef>
+          <a:fillRef idx="0">
+            <a:schemeClr val="accent1"/>
+          </a:fillRef>
+          <a:effectRef idx="0">
+            <a:schemeClr val="accent1"/>
+          </a:effectRef>
+          <a:fontRef idx="minor">
+            <a:schemeClr val="tx1"/>
+          </a:fontRef>
+        </p:style>
+      </p:cxnSp>
+      <p:sp>
+        <p:nvSpPr>
+          <p:cNvPr id="2" name="Rectangle 1">
+            <a:extLst>
+              <a:ext uri="{FF2B5EF4-FFF2-40B4-BE49-F238E27FC236}">
+                <a16:creationId xmlns:a16="http://schemas.microsoft.com/office/drawing/2014/main" id="{C16385FA-E00C-F693-94C4-3E97EBDA7BEB}"/>
+              </a:ext>
+            </a:extLst>
+          </p:cNvPr>
+          <p:cNvSpPr/>
+          <p:nvPr/>
+        </p:nvSpPr>
+        <p:spPr>
+          <a:xfrm>
+            <a:off x="5500432" y="16869522"/>
+            <a:ext cx="7658129" cy="154748"/>
+          </a:xfrm>
+          <a:prstGeom prst="rect">
+            <a:avLst/>
+          </a:prstGeom>
+          <a:solidFill>
+            <a:schemeClr val="accent3"/>
+          </a:solidFill>
+          <a:ln>
+            <a:noFill/>
+          </a:ln>
+        </p:spPr>
+        <p:style>
+          <a:lnRef idx="2">
+            <a:schemeClr val="accent1">
+              <a:shade val="50000"/>
+            </a:schemeClr>
+          </a:lnRef>
+          <a:fillRef idx="1">
+            <a:schemeClr val="accent1"/>
+          </a:fillRef>
+          <a:effectRef idx="0">
+            <a:schemeClr val="accent1"/>
+          </a:effectRef>
+          <a:fontRef idx="minor">
+            <a:schemeClr val="lt1"/>
+          </a:fontRef>
+        </p:style>
+        <p:txBody>
+          <a:bodyPr lIns="0" tIns="72000" rIns="0" bIns="72000" rtlCol="0" anchor="ctr" anchorCtr="0"/>
+          <a:lstStyle/>
+          <a:p>
+            <a:pPr algn="ctr"/>
+            <a:r>
+              <a:rPr lang="en-US" sz="1400" b="1" dirty="0">
+                <a:solidFill>
+                  <a:schemeClr val="bg1"/>
+                </a:solidFill>
+              </a:rPr>
+              <a:t>Monitoring</a:t>
+            </a:r>
+          </a:p>
+        </p:txBody>
+      </p:sp>
+      <p:pic>
+        <p:nvPicPr>
+          <p:cNvPr id="160" name="Picture 159">
+            <a:extLst>
+              <a:ext uri="{FF2B5EF4-FFF2-40B4-BE49-F238E27FC236}">
+                <a16:creationId xmlns:a16="http://schemas.microsoft.com/office/drawing/2014/main" id="{4024645E-D924-52D3-0BBD-06FA43E384F1}"/>
+              </a:ext>
+            </a:extLst>
+          </p:cNvPr>
+          <p:cNvPicPr>
+            <a:picLocks noChangeAspect="1"/>
+          </p:cNvPicPr>
+          <p:nvPr/>
+        </p:nvPicPr>
+        <p:blipFill>
+          <a:blip r:embed="rId2"/>
+          <a:stretch>
+            <a:fillRect/>
+          </a:stretch>
+        </p:blipFill>
+        <p:spPr>
+          <a:xfrm>
+            <a:off x="9688796" y="16886958"/>
+            <a:ext cx="580842" cy="580842"/>
+          </a:xfrm>
+          <a:prstGeom prst="rect">
+            <a:avLst/>
+          </a:prstGeom>
+        </p:spPr>
+      </p:pic>
     </p:spTree>
     <p:extLst>
       <p:ext uri="{BB962C8B-B14F-4D97-AF65-F5344CB8AC3E}">

</xml_diff>

<commit_message>
doc: rename monitor tutorials and add Phase 4 monitoring guide (#391)
Drop the _monitor suffix from tutorial notebook filenames and enrich
the tutorials overview with a Phase 4: Monitoring section mirroring
the sampler/estimator decision guide, linking the Asymptotic PPRM
tutorial and marking the other monitor variants as coming soon.

Co-authored-by: Claude Sonnet 5 <noreply@anthropic.com>
</commit_message>
<xml_diff>
--- a/docs/assets/glide-decision-tree.pptx
+++ b/docs/assets/glide-decision-tree.pptx
@@ -1062,7 +1062,7 @@
           <a:p>
             <a:fld id="{554093C4-DEE1-4C4E-AC4A-8D017280FD94}" type="datetimeFigureOut">
               <a:rPr lang="nl-NL" smtClean="0"/>
-              <a:t>27-07-2026</a:t>
+              <a:t>31-07-2026</a:t>
             </a:fld>
             <a:endParaRPr lang="nl-NL"/>
           </a:p>
@@ -1255,7 +1255,7 @@
           <a:p>
             <a:fld id="{68674519-6056-489F-B3DD-67FB69B5B4F9}" type="datetimeFigureOut">
               <a:rPr lang="en-GB" smtClean="0"/>
-              <a:t>27/07/2026</a:t>
+              <a:t>31/07/2026</a:t>
             </a:fld>
             <a:endParaRPr lang="en-GB"/>
           </a:p>
@@ -2127,7 +2127,7 @@
         </p:nvSpPr>
         <p:spPr>
           <a:xfrm>
-            <a:off x="5492038" y="13944293"/>
+            <a:off x="5492038" y="13946062"/>
             <a:ext cx="7658126" cy="2888533"/>
           </a:xfrm>
           <a:prstGeom prst="rect">
@@ -2186,7 +2186,7 @@
         </p:nvSpPr>
         <p:spPr>
           <a:xfrm>
-            <a:off x="5492038" y="9586292"/>
+            <a:off x="5492038" y="9586734"/>
             <a:ext cx="7658126" cy="3945051"/>
           </a:xfrm>
           <a:prstGeom prst="rect">
@@ -2252,10 +2252,7 @@
             <a:avLst/>
           </a:prstGeom>
           <a:solidFill>
-            <a:schemeClr val="accent2">
-              <a:lumMod val="20000"/>
-              <a:lumOff val="80000"/>
-            </a:schemeClr>
+            <a:schemeClr val="bg1"/>
           </a:solidFill>
           <a:ln>
             <a:solidFill>
@@ -2316,10 +2313,7 @@
             <a:avLst/>
           </a:prstGeom>
           <a:solidFill>
-            <a:schemeClr val="accent2">
-              <a:lumMod val="20000"/>
-              <a:lumOff val="80000"/>
-            </a:schemeClr>
+            <a:schemeClr val="bg1"/>
           </a:solidFill>
           <a:ln>
             <a:solidFill>
@@ -2349,7 +2343,7 @@
           <a:p>
             <a:pPr algn="ctr"/>
             <a:r>
-              <a:rPr lang="en-US" sz="900" b="1">
+              <a:rPr lang="en-US" sz="900" b="1" dirty="0">
                 <a:solidFill>
                   <a:schemeClr val="tx1"/>
                 </a:solidFill>
@@ -2380,10 +2374,7 @@
             <a:avLst/>
           </a:prstGeom>
           <a:solidFill>
-            <a:schemeClr val="accent2">
-              <a:lumMod val="20000"/>
-              <a:lumOff val="80000"/>
-            </a:schemeClr>
+            <a:schemeClr val="bg1"/>
           </a:solidFill>
           <a:ln>
             <a:solidFill>
@@ -2812,10 +2803,7 @@
             <a:avLst/>
           </a:prstGeom>
           <a:solidFill>
-            <a:schemeClr val="accent2">
-              <a:lumMod val="20000"/>
-              <a:lumOff val="80000"/>
-            </a:schemeClr>
+            <a:schemeClr val="bg1"/>
           </a:solidFill>
           <a:ln>
             <a:solidFill>
@@ -2876,7 +2864,7 @@
             <a:avLst/>
           </a:prstGeom>
           <a:solidFill>
-            <a:schemeClr val="accent3">
+            <a:schemeClr val="accent5">
               <a:lumMod val="20000"/>
               <a:lumOff val="80000"/>
             </a:schemeClr>
@@ -2940,7 +2928,7 @@
             <a:avLst/>
           </a:prstGeom>
           <a:solidFill>
-            <a:schemeClr val="accent3">
+            <a:schemeClr val="accent5">
               <a:lumMod val="20000"/>
               <a:lumOff val="80000"/>
             </a:schemeClr>
@@ -3004,7 +2992,7 @@
             <a:avLst/>
           </a:prstGeom>
           <a:solidFill>
-            <a:schemeClr val="accent3">
+            <a:schemeClr val="accent5">
               <a:lumMod val="20000"/>
               <a:lumOff val="80000"/>
             </a:schemeClr>
@@ -3068,7 +3056,7 @@
             <a:avLst/>
           </a:prstGeom>
           <a:solidFill>
-            <a:schemeClr val="accent3">
+            <a:schemeClr val="accent5">
               <a:lumMod val="20000"/>
               <a:lumOff val="80000"/>
             </a:schemeClr>
@@ -3133,10 +3121,7 @@
             <a:avLst/>
           </a:prstGeom>
           <a:solidFill>
-            <a:schemeClr val="accent2">
-              <a:lumMod val="20000"/>
-              <a:lumOff val="80000"/>
-            </a:schemeClr>
+            <a:schemeClr val="bg1"/>
           </a:solidFill>
           <a:ln>
             <a:solidFill>
@@ -3213,7 +3198,7 @@
             <a:avLst/>
           </a:prstGeom>
           <a:solidFill>
-            <a:schemeClr val="accent3">
+            <a:schemeClr val="accent5">
               <a:lumMod val="20000"/>
               <a:lumOff val="80000"/>
             </a:schemeClr>
@@ -3277,7 +3262,7 @@
             <a:avLst/>
           </a:prstGeom>
           <a:solidFill>
-            <a:schemeClr val="accent3">
+            <a:schemeClr val="accent5">
               <a:lumMod val="20000"/>
               <a:lumOff val="80000"/>
             </a:schemeClr>
@@ -3342,7 +3327,7 @@
             <a:avLst/>
           </a:prstGeom>
           <a:solidFill>
-            <a:schemeClr val="accent3">
+            <a:schemeClr val="accent5">
               <a:lumMod val="20000"/>
               <a:lumOff val="80000"/>
             </a:schemeClr>
@@ -3406,7 +3391,7 @@
             <a:avLst/>
           </a:prstGeom>
           <a:solidFill>
-            <a:schemeClr val="accent3">
+            <a:schemeClr val="accent5">
               <a:lumMod val="20000"/>
               <a:lumOff val="80000"/>
             </a:schemeClr>
@@ -3439,7 +3424,7 @@
           <a:p>
             <a:pPr algn="ctr"/>
             <a:r>
-              <a:rPr lang="en-US" sz="900" b="1">
+              <a:rPr lang="en-US" sz="900" b="1" dirty="0">
                 <a:solidFill>
                   <a:schemeClr val="tx1"/>
                 </a:solidFill>
@@ -3470,7 +3455,7 @@
             <a:avLst/>
           </a:prstGeom>
           <a:solidFill>
-            <a:schemeClr val="accent3">
+            <a:schemeClr val="accent5">
               <a:lumMod val="20000"/>
               <a:lumOff val="80000"/>
             </a:schemeClr>
@@ -3535,10 +3520,7 @@
             <a:avLst/>
           </a:prstGeom>
           <a:solidFill>
-            <a:schemeClr val="accent2">
-              <a:lumMod val="20000"/>
-              <a:lumOff val="80000"/>
-            </a:schemeClr>
+            <a:schemeClr val="bg1"/>
           </a:solidFill>
           <a:ln>
             <a:solidFill>
@@ -3691,7 +3673,7 @@
             <a:avLst/>
           </a:prstGeom>
           <a:solidFill>
-            <a:schemeClr val="accent3">
+            <a:schemeClr val="accent5">
               <a:lumMod val="20000"/>
               <a:lumOff val="80000"/>
             </a:schemeClr>
@@ -3755,7 +3737,7 @@
             <a:avLst/>
           </a:prstGeom>
           <a:solidFill>
-            <a:schemeClr val="accent3">
+            <a:schemeClr val="accent5">
               <a:lumMod val="20000"/>
               <a:lumOff val="80000"/>
             </a:schemeClr>
@@ -3820,10 +3802,7 @@
             <a:avLst/>
           </a:prstGeom>
           <a:solidFill>
-            <a:schemeClr val="accent2">
-              <a:lumMod val="20000"/>
-              <a:lumOff val="80000"/>
-            </a:schemeClr>
+            <a:schemeClr val="bg1"/>
           </a:solidFill>
           <a:ln>
             <a:solidFill>
@@ -4591,10 +4570,7 @@
             <a:avLst/>
           </a:prstGeom>
           <a:solidFill>
-            <a:schemeClr val="accent2">
-              <a:lumMod val="20000"/>
-              <a:lumOff val="80000"/>
-            </a:schemeClr>
+            <a:schemeClr val="bg1"/>
           </a:solidFill>
           <a:ln>
             <a:solidFill>
@@ -4655,7 +4631,7 @@
             <a:avLst/>
           </a:prstGeom>
           <a:solidFill>
-            <a:schemeClr val="accent3">
+            <a:schemeClr val="accent5">
               <a:lumMod val="20000"/>
               <a:lumOff val="80000"/>
             </a:schemeClr>
@@ -4719,7 +4695,7 @@
             <a:avLst/>
           </a:prstGeom>
           <a:solidFill>
-            <a:schemeClr val="accent3">
+            <a:schemeClr val="accent5">
               <a:lumMod val="20000"/>
               <a:lumOff val="80000"/>
             </a:schemeClr>
@@ -4783,7 +4759,7 @@
             <a:avLst/>
           </a:prstGeom>
           <a:solidFill>
-            <a:schemeClr val="accent3">
+            <a:schemeClr val="accent5">
               <a:lumMod val="20000"/>
               <a:lumOff val="80000"/>
             </a:schemeClr>
@@ -4848,10 +4824,7 @@
             <a:avLst/>
           </a:prstGeom>
           <a:solidFill>
-            <a:schemeClr val="accent2">
-              <a:lumMod val="20000"/>
-              <a:lumOff val="80000"/>
-            </a:schemeClr>
+            <a:schemeClr val="bg1"/>
           </a:solidFill>
           <a:ln>
             <a:solidFill>
@@ -5144,10 +5117,7 @@
             <a:avLst/>
           </a:prstGeom>
           <a:solidFill>
-            <a:schemeClr val="accent2">
-              <a:lumMod val="20000"/>
-              <a:lumOff val="80000"/>
-            </a:schemeClr>
+            <a:schemeClr val="bg1"/>
           </a:solidFill>
           <a:ln>
             <a:solidFill>
@@ -5293,7 +5263,7 @@
         </p:nvSpPr>
         <p:spPr>
           <a:xfrm>
-            <a:off x="5492037" y="13565828"/>
+            <a:off x="5492037" y="13566712"/>
             <a:ext cx="7658129" cy="154748"/>
           </a:xfrm>
           <a:prstGeom prst="rect">
@@ -5354,7 +5324,7 @@
         </p:nvSpPr>
         <p:spPr>
           <a:xfrm>
-            <a:off x="5492037" y="13755061"/>
+            <a:off x="5492037" y="13756387"/>
             <a:ext cx="7658129" cy="154748"/>
           </a:xfrm>
           <a:prstGeom prst="rect">
@@ -5420,7 +5390,7 @@
             <a:avLst/>
           </a:prstGeom>
           <a:solidFill>
-            <a:schemeClr val="accent3">
+            <a:schemeClr val="accent5">
               <a:lumMod val="20000"/>
               <a:lumOff val="80000"/>
             </a:schemeClr>
@@ -5485,10 +5455,7 @@
             <a:avLst/>
           </a:prstGeom>
           <a:solidFill>
-            <a:schemeClr val="accent2">
-              <a:lumMod val="20000"/>
-              <a:lumOff val="80000"/>
-            </a:schemeClr>
+            <a:schemeClr val="bg1"/>
           </a:solidFill>
           <a:ln>
             <a:solidFill>
@@ -5549,7 +5516,7 @@
             <a:avLst/>
           </a:prstGeom>
           <a:solidFill>
-            <a:schemeClr val="accent3">
+            <a:schemeClr val="accent5">
               <a:lumMod val="20000"/>
               <a:lumOff val="80000"/>
             </a:schemeClr>
@@ -5685,6 +5652,715 @@
           </a:fontRef>
         </p:style>
       </p:cxnSp>
+      <p:sp>
+        <p:nvSpPr>
+          <p:cNvPr id="51" name="Rectangle 50">
+            <a:extLst>
+              <a:ext uri="{FF2B5EF4-FFF2-40B4-BE49-F238E27FC236}">
+                <a16:creationId xmlns:a16="http://schemas.microsoft.com/office/drawing/2014/main" id="{CDE1E9B7-2094-9028-92D6-7EA499C19555}"/>
+              </a:ext>
+            </a:extLst>
+          </p:cNvPr>
+          <p:cNvSpPr/>
+          <p:nvPr/>
+        </p:nvSpPr>
+        <p:spPr>
+          <a:xfrm>
+            <a:off x="5492038" y="17059198"/>
+            <a:ext cx="7658126" cy="1061386"/>
+          </a:xfrm>
+          <a:prstGeom prst="rect">
+            <a:avLst/>
+          </a:prstGeom>
+          <a:solidFill>
+            <a:schemeClr val="accent3">
+              <a:lumMod val="20000"/>
+              <a:lumOff val="80000"/>
+            </a:schemeClr>
+          </a:solidFill>
+          <a:ln>
+            <a:noFill/>
+          </a:ln>
+        </p:spPr>
+        <p:style>
+          <a:lnRef idx="2">
+            <a:schemeClr val="accent1">
+              <a:shade val="50000"/>
+            </a:schemeClr>
+          </a:lnRef>
+          <a:fillRef idx="1">
+            <a:schemeClr val="accent1"/>
+          </a:fillRef>
+          <a:effectRef idx="0">
+            <a:schemeClr val="accent1"/>
+          </a:effectRef>
+          <a:fontRef idx="minor">
+            <a:schemeClr val="lt1"/>
+          </a:fontRef>
+        </p:style>
+        <p:txBody>
+          <a:bodyPr lIns="72000" tIns="72000" rIns="72000" bIns="72000" rtlCol="0" anchor="ctr" anchorCtr="0"/>
+          <a:lstStyle/>
+          <a:p>
+            <a:pPr algn="l"/>
+            <a:endParaRPr lang="en-US" sz="1600">
+              <a:solidFill>
+                <a:schemeClr val="tx1"/>
+              </a:solidFill>
+            </a:endParaRPr>
+          </a:p>
+        </p:txBody>
+      </p:sp>
+      <p:sp>
+        <p:nvSpPr>
+          <p:cNvPr id="58" name="Rectangle 57">
+            <a:extLst>
+              <a:ext uri="{FF2B5EF4-FFF2-40B4-BE49-F238E27FC236}">
+                <a16:creationId xmlns:a16="http://schemas.microsoft.com/office/drawing/2014/main" id="{3E5AEB2D-2583-9EF4-DD6C-04DBC3762C3A}"/>
+              </a:ext>
+            </a:extLst>
+          </p:cNvPr>
+          <p:cNvSpPr/>
+          <p:nvPr/>
+        </p:nvSpPr>
+        <p:spPr>
+          <a:xfrm>
+            <a:off x="7599734" y="17335539"/>
+            <a:ext cx="618087" cy="550255"/>
+          </a:xfrm>
+          <a:prstGeom prst="rect">
+            <a:avLst/>
+          </a:prstGeom>
+          <a:solidFill>
+            <a:schemeClr val="accent5">
+              <a:lumMod val="20000"/>
+              <a:lumOff val="80000"/>
+            </a:schemeClr>
+          </a:solidFill>
+          <a:ln>
+            <a:solidFill>
+              <a:schemeClr val="tx1"/>
+            </a:solidFill>
+          </a:ln>
+        </p:spPr>
+        <p:style>
+          <a:lnRef idx="2">
+            <a:schemeClr val="accent1">
+              <a:shade val="50000"/>
+            </a:schemeClr>
+          </a:lnRef>
+          <a:fillRef idx="1">
+            <a:schemeClr val="accent1"/>
+          </a:fillRef>
+          <a:effectRef idx="0">
+            <a:schemeClr val="accent1"/>
+          </a:effectRef>
+          <a:fontRef idx="minor">
+            <a:schemeClr val="lt1"/>
+          </a:fontRef>
+        </p:style>
+        <p:txBody>
+          <a:bodyPr lIns="0" tIns="72000" rIns="0" bIns="72000" rtlCol="0" anchor="ctr" anchorCtr="0"/>
+          <a:lstStyle/>
+          <a:p>
+            <a:pPr algn="ctr"/>
+            <a:r>
+              <a:rPr lang="en-US" sz="900" b="1" dirty="0">
+                <a:solidFill>
+                  <a:schemeClr val="tx1"/>
+                </a:solidFill>
+              </a:rPr>
+              <a:t>Asymptotic Stratified PPRM</a:t>
+            </a:r>
+          </a:p>
+        </p:txBody>
+      </p:sp>
+      <p:sp>
+        <p:nvSpPr>
+          <p:cNvPr id="61" name="Rectangle 60">
+            <a:extLst>
+              <a:ext uri="{FF2B5EF4-FFF2-40B4-BE49-F238E27FC236}">
+                <a16:creationId xmlns:a16="http://schemas.microsoft.com/office/drawing/2014/main" id="{EEBDFA7E-7F4D-0D67-D3B7-B233B807F929}"/>
+              </a:ext>
+            </a:extLst>
+          </p:cNvPr>
+          <p:cNvSpPr/>
+          <p:nvPr/>
+        </p:nvSpPr>
+        <p:spPr>
+          <a:xfrm>
+            <a:off x="5879867" y="17335539"/>
+            <a:ext cx="618087" cy="550255"/>
+          </a:xfrm>
+          <a:prstGeom prst="rect">
+            <a:avLst/>
+          </a:prstGeom>
+          <a:solidFill>
+            <a:schemeClr val="accent5">
+              <a:lumMod val="20000"/>
+              <a:lumOff val="80000"/>
+            </a:schemeClr>
+          </a:solidFill>
+          <a:ln>
+            <a:solidFill>
+              <a:schemeClr val="tx1"/>
+            </a:solidFill>
+          </a:ln>
+        </p:spPr>
+        <p:style>
+          <a:lnRef idx="2">
+            <a:schemeClr val="accent1">
+              <a:shade val="50000"/>
+            </a:schemeClr>
+          </a:lnRef>
+          <a:fillRef idx="1">
+            <a:schemeClr val="accent1"/>
+          </a:fillRef>
+          <a:effectRef idx="0">
+            <a:schemeClr val="accent1"/>
+          </a:effectRef>
+          <a:fontRef idx="minor">
+            <a:schemeClr val="lt1"/>
+          </a:fontRef>
+        </p:style>
+        <p:txBody>
+          <a:bodyPr lIns="0" tIns="72000" rIns="0" bIns="72000" rtlCol="0" anchor="ctr" anchorCtr="0"/>
+          <a:lstStyle/>
+          <a:p>
+            <a:pPr algn="ctr"/>
+            <a:r>
+              <a:rPr lang="en-US" sz="900" b="1" dirty="0">
+                <a:solidFill>
+                  <a:schemeClr val="tx1"/>
+                </a:solidFill>
+              </a:rPr>
+              <a:t>Asymptotic Active PPRM</a:t>
+            </a:r>
+          </a:p>
+        </p:txBody>
+      </p:sp>
+      <p:sp>
+        <p:nvSpPr>
+          <p:cNvPr id="63" name="Rectangle 62">
+            <a:extLst>
+              <a:ext uri="{FF2B5EF4-FFF2-40B4-BE49-F238E27FC236}">
+                <a16:creationId xmlns:a16="http://schemas.microsoft.com/office/drawing/2014/main" id="{CFC49BE5-945A-B18F-5C94-B2EB33937D6E}"/>
+              </a:ext>
+            </a:extLst>
+          </p:cNvPr>
+          <p:cNvSpPr/>
+          <p:nvPr/>
+        </p:nvSpPr>
+        <p:spPr>
+          <a:xfrm>
+            <a:off x="11699336" y="17335539"/>
+            <a:ext cx="618087" cy="550255"/>
+          </a:xfrm>
+          <a:prstGeom prst="rect">
+            <a:avLst/>
+          </a:prstGeom>
+          <a:solidFill>
+            <a:schemeClr val="accent5">
+              <a:lumMod val="20000"/>
+              <a:lumOff val="80000"/>
+            </a:schemeClr>
+          </a:solidFill>
+          <a:ln>
+            <a:solidFill>
+              <a:schemeClr val="tx1"/>
+            </a:solidFill>
+          </a:ln>
+        </p:spPr>
+        <p:style>
+          <a:lnRef idx="2">
+            <a:schemeClr val="accent1">
+              <a:shade val="50000"/>
+            </a:schemeClr>
+          </a:lnRef>
+          <a:fillRef idx="1">
+            <a:schemeClr val="accent1"/>
+          </a:fillRef>
+          <a:effectRef idx="0">
+            <a:schemeClr val="accent1"/>
+          </a:effectRef>
+          <a:fontRef idx="minor">
+            <a:schemeClr val="lt1"/>
+          </a:fontRef>
+        </p:style>
+        <p:txBody>
+          <a:bodyPr lIns="0" tIns="72000" rIns="0" bIns="72000" rtlCol="0" anchor="ctr" anchorCtr="0"/>
+          <a:lstStyle/>
+          <a:p>
+            <a:pPr algn="ctr"/>
+            <a:r>
+              <a:rPr lang="en-US" sz="900" b="1" dirty="0">
+                <a:solidFill>
+                  <a:schemeClr val="tx1"/>
+                </a:solidFill>
+              </a:rPr>
+              <a:t>Asymptotic PPRM</a:t>
+            </a:r>
+          </a:p>
+        </p:txBody>
+      </p:sp>
+      <p:sp>
+        <p:nvSpPr>
+          <p:cNvPr id="130" name="Rectangle 129">
+            <a:extLst>
+              <a:ext uri="{FF2B5EF4-FFF2-40B4-BE49-F238E27FC236}">
+                <a16:creationId xmlns:a16="http://schemas.microsoft.com/office/drawing/2014/main" id="{68ABB4DD-8D1F-E320-631E-A9AB8E960132}"/>
+              </a:ext>
+            </a:extLst>
+          </p:cNvPr>
+          <p:cNvSpPr/>
+          <p:nvPr/>
+        </p:nvSpPr>
+        <p:spPr>
+          <a:xfrm>
+            <a:off x="8968359" y="17335539"/>
+            <a:ext cx="618087" cy="550255"/>
+          </a:xfrm>
+          <a:prstGeom prst="rect">
+            <a:avLst/>
+          </a:prstGeom>
+          <a:solidFill>
+            <a:schemeClr val="accent5">
+              <a:lumMod val="20000"/>
+              <a:lumOff val="80000"/>
+            </a:schemeClr>
+          </a:solidFill>
+          <a:ln>
+            <a:solidFill>
+              <a:schemeClr val="tx1"/>
+            </a:solidFill>
+          </a:ln>
+        </p:spPr>
+        <p:style>
+          <a:lnRef idx="2">
+            <a:schemeClr val="accent1">
+              <a:shade val="50000"/>
+            </a:schemeClr>
+          </a:lnRef>
+          <a:fillRef idx="1">
+            <a:schemeClr val="accent1"/>
+          </a:fillRef>
+          <a:effectRef idx="0">
+            <a:schemeClr val="accent1"/>
+          </a:effectRef>
+          <a:fontRef idx="minor">
+            <a:schemeClr val="lt1"/>
+          </a:fontRef>
+        </p:style>
+        <p:txBody>
+          <a:bodyPr lIns="0" tIns="72000" rIns="0" bIns="72000" rtlCol="0" anchor="ctr" anchorCtr="0"/>
+          <a:lstStyle/>
+          <a:p>
+            <a:pPr algn="ctr"/>
+            <a:r>
+              <a:rPr lang="en-US" sz="900" b="1" dirty="0">
+                <a:solidFill>
+                  <a:schemeClr val="tx1"/>
+                </a:solidFill>
+              </a:rPr>
+              <a:t>Asymptotic Clustered PPRM</a:t>
+            </a:r>
+          </a:p>
+        </p:txBody>
+      </p:sp>
+      <p:sp>
+        <p:nvSpPr>
+          <p:cNvPr id="131" name="Rectangle 130">
+            <a:extLst>
+              <a:ext uri="{FF2B5EF4-FFF2-40B4-BE49-F238E27FC236}">
+                <a16:creationId xmlns:a16="http://schemas.microsoft.com/office/drawing/2014/main" id="{8B9B2A1A-E06D-6FD6-FCA4-DD838EABE39F}"/>
+              </a:ext>
+            </a:extLst>
+          </p:cNvPr>
+          <p:cNvSpPr/>
+          <p:nvPr/>
+        </p:nvSpPr>
+        <p:spPr>
+          <a:xfrm>
+            <a:off x="10331063" y="17335539"/>
+            <a:ext cx="618087" cy="550255"/>
+          </a:xfrm>
+          <a:prstGeom prst="rect">
+            <a:avLst/>
+          </a:prstGeom>
+          <a:solidFill>
+            <a:schemeClr val="accent5">
+              <a:lumMod val="20000"/>
+              <a:lumOff val="80000"/>
+            </a:schemeClr>
+          </a:solidFill>
+          <a:ln>
+            <a:solidFill>
+              <a:schemeClr val="tx1"/>
+            </a:solidFill>
+            <a:prstDash val="solid"/>
+          </a:ln>
+        </p:spPr>
+        <p:style>
+          <a:lnRef idx="2">
+            <a:schemeClr val="accent1">
+              <a:shade val="50000"/>
+            </a:schemeClr>
+          </a:lnRef>
+          <a:fillRef idx="1">
+            <a:schemeClr val="accent1"/>
+          </a:fillRef>
+          <a:effectRef idx="0">
+            <a:schemeClr val="accent1"/>
+          </a:effectRef>
+          <a:fontRef idx="minor">
+            <a:schemeClr val="lt1"/>
+          </a:fontRef>
+        </p:style>
+        <p:txBody>
+          <a:bodyPr lIns="0" tIns="72000" rIns="0" bIns="72000" rtlCol="0" anchor="ctr" anchorCtr="0"/>
+          <a:lstStyle/>
+          <a:p>
+            <a:pPr algn="ctr"/>
+            <a:r>
+              <a:rPr lang="en-US" sz="900" b="1" dirty="0">
+                <a:solidFill>
+                  <a:schemeClr val="tx1"/>
+                </a:solidFill>
+              </a:rPr>
+              <a:t>Asymptotic Multi-PPRM</a:t>
+            </a:r>
+          </a:p>
+        </p:txBody>
+      </p:sp>
+      <p:cxnSp>
+        <p:nvCxnSpPr>
+          <p:cNvPr id="136" name="Straight Arrow Connector 135">
+            <a:extLst>
+              <a:ext uri="{FF2B5EF4-FFF2-40B4-BE49-F238E27FC236}">
+                <a16:creationId xmlns:a16="http://schemas.microsoft.com/office/drawing/2014/main" id="{97948AC6-5DB3-2F50-7816-8350484616D8}"/>
+              </a:ext>
+            </a:extLst>
+          </p:cNvPr>
+          <p:cNvCxnSpPr>
+            <a:cxnSpLocks/>
+            <a:stCxn id="18" idx="2"/>
+            <a:endCxn id="63" idx="0"/>
+          </p:cNvCxnSpPr>
+          <p:nvPr/>
+        </p:nvCxnSpPr>
+        <p:spPr>
+          <a:xfrm>
+            <a:off x="12008380" y="16642252"/>
+            <a:ext cx="0" cy="693287"/>
+          </a:xfrm>
+          <a:prstGeom prst="straightConnector1">
+            <a:avLst/>
+          </a:prstGeom>
+          <a:ln w="9525">
+            <a:solidFill>
+              <a:schemeClr val="accent6">
+                <a:lumMod val="50000"/>
+              </a:schemeClr>
+            </a:solidFill>
+            <a:tailEnd type="triangle"/>
+          </a:ln>
+        </p:spPr>
+        <p:style>
+          <a:lnRef idx="1">
+            <a:schemeClr val="accent1"/>
+          </a:lnRef>
+          <a:fillRef idx="0">
+            <a:schemeClr val="accent1"/>
+          </a:fillRef>
+          <a:effectRef idx="0">
+            <a:schemeClr val="accent1"/>
+          </a:effectRef>
+          <a:fontRef idx="minor">
+            <a:schemeClr val="tx1"/>
+          </a:fontRef>
+        </p:style>
+      </p:cxnSp>
+      <p:cxnSp>
+        <p:nvCxnSpPr>
+          <p:cNvPr id="146" name="Straight Arrow Connector 145">
+            <a:extLst>
+              <a:ext uri="{FF2B5EF4-FFF2-40B4-BE49-F238E27FC236}">
+                <a16:creationId xmlns:a16="http://schemas.microsoft.com/office/drawing/2014/main" id="{6A7FED52-3B10-CBB4-9AC1-4B410794DC44}"/>
+              </a:ext>
+            </a:extLst>
+          </p:cNvPr>
+          <p:cNvCxnSpPr>
+            <a:cxnSpLocks/>
+            <a:stCxn id="50" idx="2"/>
+            <a:endCxn id="131" idx="0"/>
+          </p:cNvCxnSpPr>
+          <p:nvPr/>
+        </p:nvCxnSpPr>
+        <p:spPr>
+          <a:xfrm>
+            <a:off x="10640107" y="16642252"/>
+            <a:ext cx="0" cy="693287"/>
+          </a:xfrm>
+          <a:prstGeom prst="straightConnector1">
+            <a:avLst/>
+          </a:prstGeom>
+          <a:ln w="9525">
+            <a:solidFill>
+              <a:schemeClr val="accent6">
+                <a:lumMod val="50000"/>
+              </a:schemeClr>
+            </a:solidFill>
+            <a:tailEnd type="triangle"/>
+          </a:ln>
+        </p:spPr>
+        <p:style>
+          <a:lnRef idx="1">
+            <a:schemeClr val="accent1"/>
+          </a:lnRef>
+          <a:fillRef idx="0">
+            <a:schemeClr val="accent1"/>
+          </a:fillRef>
+          <a:effectRef idx="0">
+            <a:schemeClr val="accent1"/>
+          </a:effectRef>
+          <a:fontRef idx="minor">
+            <a:schemeClr val="tx1"/>
+          </a:fontRef>
+        </p:style>
+      </p:cxnSp>
+      <p:cxnSp>
+        <p:nvCxnSpPr>
+          <p:cNvPr id="150" name="Straight Arrow Connector 149">
+            <a:extLst>
+              <a:ext uri="{FF2B5EF4-FFF2-40B4-BE49-F238E27FC236}">
+                <a16:creationId xmlns:a16="http://schemas.microsoft.com/office/drawing/2014/main" id="{5FDBF186-46B7-9868-C25D-8430E73A6D53}"/>
+              </a:ext>
+            </a:extLst>
+          </p:cNvPr>
+          <p:cNvCxnSpPr>
+            <a:cxnSpLocks/>
+            <a:stCxn id="140" idx="2"/>
+            <a:endCxn id="130" idx="0"/>
+          </p:cNvCxnSpPr>
+          <p:nvPr/>
+        </p:nvCxnSpPr>
+        <p:spPr>
+          <a:xfrm>
+            <a:off x="9277403" y="16642252"/>
+            <a:ext cx="0" cy="693287"/>
+          </a:xfrm>
+          <a:prstGeom prst="straightConnector1">
+            <a:avLst/>
+          </a:prstGeom>
+          <a:ln w="9525">
+            <a:solidFill>
+              <a:schemeClr val="accent6">
+                <a:lumMod val="50000"/>
+              </a:schemeClr>
+            </a:solidFill>
+            <a:tailEnd type="triangle"/>
+          </a:ln>
+        </p:spPr>
+        <p:style>
+          <a:lnRef idx="1">
+            <a:schemeClr val="accent1"/>
+          </a:lnRef>
+          <a:fillRef idx="0">
+            <a:schemeClr val="accent1"/>
+          </a:fillRef>
+          <a:effectRef idx="0">
+            <a:schemeClr val="accent1"/>
+          </a:effectRef>
+          <a:fontRef idx="minor">
+            <a:schemeClr val="tx1"/>
+          </a:fontRef>
+        </p:style>
+      </p:cxnSp>
+      <p:cxnSp>
+        <p:nvCxnSpPr>
+          <p:cNvPr id="154" name="Straight Arrow Connector 153">
+            <a:extLst>
+              <a:ext uri="{FF2B5EF4-FFF2-40B4-BE49-F238E27FC236}">
+                <a16:creationId xmlns:a16="http://schemas.microsoft.com/office/drawing/2014/main" id="{9EE24596-8FB1-2F5E-A6B7-8F4554B78FC4}"/>
+              </a:ext>
+            </a:extLst>
+          </p:cNvPr>
+          <p:cNvCxnSpPr>
+            <a:cxnSpLocks/>
+            <a:stCxn id="22" idx="2"/>
+            <a:endCxn id="58" idx="0"/>
+          </p:cNvCxnSpPr>
+          <p:nvPr/>
+        </p:nvCxnSpPr>
+        <p:spPr>
+          <a:xfrm>
+            <a:off x="7908778" y="16642252"/>
+            <a:ext cx="0" cy="693287"/>
+          </a:xfrm>
+          <a:prstGeom prst="straightConnector1">
+            <a:avLst/>
+          </a:prstGeom>
+          <a:ln w="9525">
+            <a:solidFill>
+              <a:schemeClr val="accent6">
+                <a:lumMod val="50000"/>
+              </a:schemeClr>
+            </a:solidFill>
+            <a:tailEnd type="triangle"/>
+          </a:ln>
+        </p:spPr>
+        <p:style>
+          <a:lnRef idx="1">
+            <a:schemeClr val="accent1"/>
+          </a:lnRef>
+          <a:fillRef idx="0">
+            <a:schemeClr val="accent1"/>
+          </a:fillRef>
+          <a:effectRef idx="0">
+            <a:schemeClr val="accent1"/>
+          </a:effectRef>
+          <a:fontRef idx="minor">
+            <a:schemeClr val="tx1"/>
+          </a:fontRef>
+        </p:style>
+      </p:cxnSp>
+      <p:cxnSp>
+        <p:nvCxnSpPr>
+          <p:cNvPr id="157" name="Straight Arrow Connector 156">
+            <a:extLst>
+              <a:ext uri="{FF2B5EF4-FFF2-40B4-BE49-F238E27FC236}">
+                <a16:creationId xmlns:a16="http://schemas.microsoft.com/office/drawing/2014/main" id="{582BFE6B-3E7B-123F-5F42-B0AEE625B3C2}"/>
+              </a:ext>
+            </a:extLst>
+          </p:cNvPr>
+          <p:cNvCxnSpPr>
+            <a:cxnSpLocks/>
+            <a:stCxn id="28" idx="2"/>
+            <a:endCxn id="61" idx="0"/>
+          </p:cNvCxnSpPr>
+          <p:nvPr/>
+        </p:nvCxnSpPr>
+        <p:spPr>
+          <a:xfrm>
+            <a:off x="6188911" y="16642252"/>
+            <a:ext cx="0" cy="693287"/>
+          </a:xfrm>
+          <a:prstGeom prst="straightConnector1">
+            <a:avLst/>
+          </a:prstGeom>
+          <a:ln w="9525">
+            <a:solidFill>
+              <a:schemeClr val="accent6">
+                <a:lumMod val="50000"/>
+              </a:schemeClr>
+            </a:solidFill>
+            <a:tailEnd type="triangle"/>
+          </a:ln>
+        </p:spPr>
+        <p:style>
+          <a:lnRef idx="1">
+            <a:schemeClr val="accent1"/>
+          </a:lnRef>
+          <a:fillRef idx="0">
+            <a:schemeClr val="accent1"/>
+          </a:fillRef>
+          <a:effectRef idx="0">
+            <a:schemeClr val="accent1"/>
+          </a:effectRef>
+          <a:fontRef idx="minor">
+            <a:schemeClr val="tx1"/>
+          </a:fontRef>
+        </p:style>
+      </p:cxnSp>
+      <p:sp>
+        <p:nvSpPr>
+          <p:cNvPr id="2" name="Rectangle 1">
+            <a:extLst>
+              <a:ext uri="{FF2B5EF4-FFF2-40B4-BE49-F238E27FC236}">
+                <a16:creationId xmlns:a16="http://schemas.microsoft.com/office/drawing/2014/main" id="{C16385FA-E00C-F693-94C4-3E97EBDA7BEB}"/>
+              </a:ext>
+            </a:extLst>
+          </p:cNvPr>
+          <p:cNvSpPr/>
+          <p:nvPr/>
+        </p:nvSpPr>
+        <p:spPr>
+          <a:xfrm>
+            <a:off x="5500432" y="16869522"/>
+            <a:ext cx="7658129" cy="154748"/>
+          </a:xfrm>
+          <a:prstGeom prst="rect">
+            <a:avLst/>
+          </a:prstGeom>
+          <a:solidFill>
+            <a:schemeClr val="accent3"/>
+          </a:solidFill>
+          <a:ln>
+            <a:noFill/>
+          </a:ln>
+        </p:spPr>
+        <p:style>
+          <a:lnRef idx="2">
+            <a:schemeClr val="accent1">
+              <a:shade val="50000"/>
+            </a:schemeClr>
+          </a:lnRef>
+          <a:fillRef idx="1">
+            <a:schemeClr val="accent1"/>
+          </a:fillRef>
+          <a:effectRef idx="0">
+            <a:schemeClr val="accent1"/>
+          </a:effectRef>
+          <a:fontRef idx="minor">
+            <a:schemeClr val="lt1"/>
+          </a:fontRef>
+        </p:style>
+        <p:txBody>
+          <a:bodyPr lIns="0" tIns="72000" rIns="0" bIns="72000" rtlCol="0" anchor="ctr" anchorCtr="0"/>
+          <a:lstStyle/>
+          <a:p>
+            <a:pPr algn="ctr"/>
+            <a:r>
+              <a:rPr lang="en-US" sz="1400" b="1" dirty="0">
+                <a:solidFill>
+                  <a:schemeClr val="bg1"/>
+                </a:solidFill>
+              </a:rPr>
+              <a:t>Monitoring</a:t>
+            </a:r>
+          </a:p>
+        </p:txBody>
+      </p:sp>
+      <p:pic>
+        <p:nvPicPr>
+          <p:cNvPr id="160" name="Picture 159">
+            <a:extLst>
+              <a:ext uri="{FF2B5EF4-FFF2-40B4-BE49-F238E27FC236}">
+                <a16:creationId xmlns:a16="http://schemas.microsoft.com/office/drawing/2014/main" id="{4024645E-D924-52D3-0BBD-06FA43E384F1}"/>
+              </a:ext>
+            </a:extLst>
+          </p:cNvPr>
+          <p:cNvPicPr>
+            <a:picLocks noChangeAspect="1"/>
+          </p:cNvPicPr>
+          <p:nvPr/>
+        </p:nvPicPr>
+        <p:blipFill>
+          <a:blip r:embed="rId2"/>
+          <a:stretch>
+            <a:fillRect/>
+          </a:stretch>
+        </p:blipFill>
+        <p:spPr>
+          <a:xfrm>
+            <a:off x="9688796" y="16886958"/>
+            <a:ext cx="580842" cy="580842"/>
+          </a:xfrm>
+          <a:prstGeom prst="rect">
+            <a:avLst/>
+          </a:prstGeom>
+        </p:spPr>
+      </p:pic>
     </p:spTree>
     <p:extLst>
       <p:ext uri="{BB962C8B-B14F-4D97-AF65-F5344CB8AC3E}">

</xml_diff>